<commit_message>
Domus Energia (negócio): plano de negócio e apresentação atualizados para o módulo 7855
Organização com um gerente e quatro eletricistas parceiros por especialidade,
arranque em setembro de 2027, obras-tipo feitas com o catálogo do site.

Co-Authored-By: Claude Opus 5.5 <noreply@anthropic.com>
</commit_message>
<xml_diff>
--- a/domus-energia/negocio/Domus_Energia_Ideia_de_Negocio.pptx
+++ b/domus-energia/negocio/Domus_Energia_Ideia_de_Negocio.pptx
@@ -17,9 +17,10 @@
     <p:sldId id="265" r:id="rId11"/>
     <p:sldId id="266" r:id="rId12"/>
     <p:sldId id="267" r:id="rId13"/>
+    <p:sldId id="268" r:id="rId14"/>
   </p:sldIdLst>
   <p:notesMasterIdLst>
-    <p:notesMasterId r:id="rId14"/>
+    <p:notesMasterId r:id="rId15"/>
   </p:notesMasterIdLst>
   <p:sldSz cx="9144000" cy="5143500"/>
   <p:notesSz cx="5143500" cy="9144000"/>
@@ -152,7 +153,7 @@
           </c:spPr>
           <c:invertIfNegative val="0"/>
           <c:dLbls>
-            <c:numFmt formatCode="#,##0" sourceLinked="0"/>
+            <c:numFmt formatCode="0" sourceLinked="0"/>
             <c:txPr>
               <a:bodyPr/>
               <a:lstStyle/>
@@ -177,30 +178,36 @@
           </c:dLbls>
           <c:cat>
             <c:multiLvlStrRef>
-              <c:f>Sheet1!$A$2:$A$8</c:f>
+              <c:f>Sheet1!$A$2:$A$10</c:f>
               <c:multiLvlStrCache>
-                <c:ptCount val="7"/>
+                <c:ptCount val="9"/>
                 <c:lvl>
                   <c:pt idx="0">
-                    <c:v>Stock inicial</c:v>
+                    <c:v>Fundo de reserva (3 meses)</c:v>
                   </c:pt>
                   <c:pt idx="1">
-                    <c:v>Ferramentas e EPI</c:v>
+                    <c:v>Stock de aparelhos</c:v>
                   </c:pt>
                   <c:pt idx="2">
-                    <c:v>Fundo de reserva</c:v>
+                    <c:v>Marketing de lançamento</c:v>
                   </c:pt>
                   <c:pt idx="3">
-                    <c:v>Marketing</c:v>
+                    <c:v>Documentos legais</c:v>
                   </c:pt>
                   <c:pt idx="4">
-                    <c:v>Seguro RC</c:v>
+                    <c:v>Seguro (1.º ano)</c:v>
                   </c:pt>
                   <c:pt idx="5">
-                    <c:v>Criar a empresa</c:v>
+                    <c:v>Servidor e faturação</c:v>
                   </c:pt>
                   <c:pt idx="6">
-                    <c:v>Servidor e domínio</c:v>
+                    <c:v>Bancada</c:v>
+                  </c:pt>
+                  <c:pt idx="7">
+                    <c:v>Quadro de demonstração</c:v>
+                  </c:pt>
+                  <c:pt idx="8">
+                    <c:v>Identificação</c:v>
                   </c:pt>
                 </c:lvl>
               </c:multiLvlStrCache>
@@ -208,37 +215,43 @@
           </c:cat>
           <c:val>
             <c:numRef>
-              <c:f>Sheet1!$B$2:$B$8</c:f>
+              <c:f>Sheet1!$B$2:$B$10</c:f>
               <c:numCache>
                 <c:formatCode>General</c:formatCode>
-                <c:ptCount val="7"/>
+                <c:ptCount val="9"/>
                 <c:pt idx="0">
-                  <c:v>1300</c:v>
+                  <c:v>1290</c:v>
                 </c:pt>
                 <c:pt idx="1">
-                  <c:v>1200</c:v>
+                  <c:v>900</c:v>
                 </c:pt>
                 <c:pt idx="2">
-                  <c:v>940</c:v>
+                  <c:v>800</c:v>
                 </c:pt>
                 <c:pt idx="3">
                   <c:v>600</c:v>
                 </c:pt>
                 <c:pt idx="4">
+                  <c:v>480</c:v>
+                </c:pt>
+                <c:pt idx="5">
                   <c:v>420</c:v>
                 </c:pt>
-                <c:pt idx="5">
-                  <c:v>360</c:v>
+                <c:pt idx="6">
+                  <c:v>350</c:v>
                 </c:pt>
-                <c:pt idx="6">
-                  <c:v>180</c:v>
+                <c:pt idx="7">
+                  <c:v>300</c:v>
+                </c:pt>
+                <c:pt idx="8">
+                  <c:v>150</c:v>
                 </c:pt>
               </c:numCache>
             </c:numRef>
           </c:val>
         </c:ser>
         <c:dLbls>
-          <c:numFmt formatCode="#,##0" sourceLinked="0"/>
+          <c:numFmt formatCode="0" sourceLinked="0"/>
           <c:txPr>
             <a:bodyPr/>
             <a:lstStyle/>
@@ -397,7 +410,7 @@
                 </a:solidFill>
                 <a:latin typeface="Arial"/>
               </a:rPr>
-              <a:t>Resultado mensal previsto (€, ano 1)</a:t>
+              <a:t>Resultado mensal previsto (€, set. 2027 a ago. 2028)</a:t>
             </a:r>
           </a:p>
         </c:rich>
@@ -464,40 +477,40 @@
                 <c:ptCount val="12"/>
                 <c:lvl>
                   <c:pt idx="0">
-                    <c:v>M1</c:v>
+                    <c:v>set</c:v>
                   </c:pt>
                   <c:pt idx="1">
-                    <c:v>M2</c:v>
+                    <c:v>out</c:v>
                   </c:pt>
                   <c:pt idx="2">
-                    <c:v>M3</c:v>
+                    <c:v>nov</c:v>
                   </c:pt>
                   <c:pt idx="3">
-                    <c:v>M4</c:v>
+                    <c:v>dez</c:v>
                   </c:pt>
                   <c:pt idx="4">
-                    <c:v>M5</c:v>
+                    <c:v>jan</c:v>
                   </c:pt>
                   <c:pt idx="5">
-                    <c:v>M6</c:v>
+                    <c:v>fev</c:v>
                   </c:pt>
                   <c:pt idx="6">
-                    <c:v>M7</c:v>
+                    <c:v>mar</c:v>
                   </c:pt>
                   <c:pt idx="7">
-                    <c:v>M8</c:v>
+                    <c:v>abr</c:v>
                   </c:pt>
                   <c:pt idx="8">
-                    <c:v>M9</c:v>
+                    <c:v>mai</c:v>
                   </c:pt>
                   <c:pt idx="9">
-                    <c:v>M10</c:v>
+                    <c:v>jun</c:v>
                   </c:pt>
                   <c:pt idx="10">
-                    <c:v>M11</c:v>
+                    <c:v>jul</c:v>
                   </c:pt>
                   <c:pt idx="11">
-                    <c:v>M12</c:v>
+                    <c:v>ago</c:v>
                   </c:pt>
                 </c:lvl>
               </c:multiLvlStrCache>
@@ -510,40 +523,40 @@
                 <c:formatCode>General</c:formatCode>
                 <c:ptCount val="12"/>
                 <c:pt idx="0">
-                  <c:v>-1</c:v>
+                  <c:v>168</c:v>
                 </c:pt>
                 <c:pt idx="1">
-                  <c:v>14</c:v>
+                  <c:v>175</c:v>
                 </c:pt>
                 <c:pt idx="2">
-                  <c:v>22</c:v>
+                  <c:v>338</c:v>
                 </c:pt>
                 <c:pt idx="3">
-                  <c:v>546</c:v>
+                  <c:v>500</c:v>
                 </c:pt>
                 <c:pt idx="4">
-                  <c:v>569</c:v>
+                  <c:v>655</c:v>
                 </c:pt>
                 <c:pt idx="5">
-                  <c:v>591</c:v>
+                  <c:v>825</c:v>
                 </c:pt>
                 <c:pt idx="6">
-                  <c:v>1123</c:v>
+                  <c:v>988</c:v>
                 </c:pt>
                 <c:pt idx="7">
-                  <c:v>1154</c:v>
+                  <c:v>1158</c:v>
                 </c:pt>
                 <c:pt idx="8">
-                  <c:v>1184</c:v>
+                  <c:v>1328</c:v>
                 </c:pt>
                 <c:pt idx="9">
-                  <c:v>1214</c:v>
+                  <c:v>1498</c:v>
                 </c:pt>
                 <c:pt idx="10">
-                  <c:v>1251</c:v>
+                  <c:v>1528</c:v>
                 </c:pt>
                 <c:pt idx="11">
-                  <c:v>1281</c:v>
+                  <c:v>1551</c:v>
                 </c:pt>
               </c:numCache>
             </c:numRef>
@@ -1089,7 +1102,7 @@
           <a:p>
             <a:r>
               <a:rPr lang="en-US" dirty="0"/>
-              <a:t>Apresentar a empresa numa frase: eletricidade e automação residencial na Grande Lisboa, com plataforma própria e mensalidade baixa.</a:t>
+              <a:t>Apresentar a empresa numa frase: eletricidade e casa inteligente com orçamento na hora no site, feitas por eletricistas parceiros. As obras começam em setembro de 2027, depois do curso.</a:t>
             </a:r>
             <a:endParaRPr lang="en-US" dirty="0"/>
           </a:p>
@@ -1377,6 +1390,94 @@
             <a:fld id="{F7021451-1387-4CA6-816F-3879F97B5CBC}" type="slidenum">
               <a:rPr lang="en-US"/>
               <a:t>12</a:t>
+            </a:fld>
+            <a:endParaRPr lang="en-US"/>
+          </a:p>
+        </p:txBody>
+      </p:sp>
+    </p:spTree>
+    <p:extLst>
+      <p:ext uri="{BB962C8B-B14F-4D97-AF65-F5344CB8AC3E}">
+        <p14:creationId xmlns:p14="http://schemas.microsoft.com/office/powerpoint/2010/main" val="1024086991"/>
+      </p:ext>
+    </p:extLst>
+  </p:cSld>
+  <p:clrMapOvr>
+    <a:masterClrMapping/>
+  </p:clrMapOvr>
+</p:notes>
+</file>
+
+<file path=ppt/notesSlides/notesSlide13.xml><?xml version="1.0" encoding="utf-8"?>
+<p:notes xmlns:a="http://schemas.openxmlformats.org/drawingml/2006/main" xmlns:r="http://schemas.openxmlformats.org/officeDocument/2006/relationships" xmlns:p="http://schemas.openxmlformats.org/presentationml/2006/main">
+  <p:cSld>
+    <p:spTree>
+      <p:nvGrpSpPr>
+        <p:cNvPr id="1" name=""/>
+        <p:cNvGrpSpPr/>
+        <p:nvPr/>
+      </p:nvGrpSpPr>
+      <p:grpSpPr>
+        <a:xfrm>
+          <a:off x="0" y="0"/>
+          <a:ext cx="0" cy="0"/>
+          <a:chOff x="0" y="0"/>
+          <a:chExt cx="0" cy="0"/>
+        </a:xfrm>
+      </p:grpSpPr>
+      <p:sp>
+        <p:nvSpPr>
+          <p:cNvPr id="2" name="Slide Image Placeholder 1"/>
+          <p:cNvSpPr>
+            <a:spLocks noGrp="1" noRot="1" noChangeAspect="1"/>
+          </p:cNvSpPr>
+          <p:nvPr>
+            <p:ph type="sldImg"/>
+          </p:nvPr>
+        </p:nvSpPr>
+        <p:spPr/>
+      </p:sp>
+      <p:sp>
+        <p:nvSpPr>
+          <p:cNvPr id="3" name="Notes Placeholder 2"/>
+          <p:cNvSpPr>
+            <a:spLocks noGrp="1"/>
+          </p:cNvSpPr>
+          <p:nvPr>
+            <p:ph type="body" idx="1"/>
+          </p:nvPr>
+        </p:nvSpPr>
+        <p:spPr/>
+        <p:txBody>
+          <a:bodyPr/>
+          <a:lstStyle/>
+          <a:p>
+            <a:r>
+              <a:rPr lang="en-US" dirty="0"/>
+              <a:t/>
+            </a:r>
+            <a:endParaRPr lang="en-US" dirty="0"/>
+          </a:p>
+        </p:txBody>
+      </p:sp>
+      <p:sp>
+        <p:nvSpPr>
+          <p:cNvPr id="4" name="Slide Number Placeholder 3"/>
+          <p:cNvSpPr>
+            <a:spLocks noGrp="1"/>
+          </p:cNvSpPr>
+          <p:nvPr>
+            <p:ph type="sldNum" sz="quarter" idx="10"/>
+          </p:nvPr>
+        </p:nvSpPr>
+        <p:spPr/>
+        <p:txBody>
+          <a:bodyPr/>
+          <a:lstStyle/>
+          <a:p>
+            <a:fld id="{F7021451-1387-4CA6-816F-3879F97B5CBC}" type="slidenum">
+              <a:rPr lang="en-US"/>
+              <a:t>13</a:t>
             </a:fld>
             <a:endParaRPr lang="en-US"/>
           </a:p>
@@ -2605,7 +2706,7 @@
                 <a:ea typeface="Calibri" pitchFamily="34" charset="-122"/>
                 <a:cs typeface="Calibri" pitchFamily="34" charset="-120"/>
               </a:rPr>
-              <a:t>Atividade de grupo: ideia de negócio · Módulo 7855 – Plano de negócio · Formador: Luís Santos</a:t>
+              <a:t>Atividade de grupo: ideia de negócio · Módulo 7855, Plano de negócio · Formador: Luís Santos · Rui Bragança</a:t>
             </a:r>
             <a:endParaRPr lang="en-US" sz="1200" dirty="0"/>
           </a:p>
@@ -2715,7 +2816,7 @@
                 <a:ea typeface="Cambria" pitchFamily="34" charset="-122"/>
                 <a:cs typeface="Cambria" pitchFamily="34" charset="-120"/>
               </a:rPr>
-              <a:t>Quais os principais riscos?</a:t>
+              <a:t>Como serão obtidas receitas?</a:t>
             </a:r>
             <a:endParaRPr lang="en-US" sz="3000" dirty="0"/>
           </a:p>
@@ -2779,7 +2880,7 @@
                 <a:ea typeface="Cambria" pitchFamily="34" charset="-122"/>
                 <a:cs typeface="Cambria" pitchFamily="34" charset="-120"/>
               </a:rPr>
-              <a:t>9</a:t>
+              <a:t>8</a:t>
             </a:r>
             <a:endParaRPr lang="en-US" sz="792" dirty="0"/>
           </a:p>
@@ -2818,7 +2919,7 @@
                 <a:ea typeface="Calibri" pitchFamily="34" charset="-122"/>
                 <a:cs typeface="Calibri" pitchFamily="34" charset="-120"/>
               </a:rPr>
-              <a:t>E a medida preventiva de cada um</a:t>
+              <a:t>As obras pagam a empresa; as mensalidades repetem-se todos os meses</a:t>
             </a:r>
             <a:endParaRPr lang="en-US" sz="1400" dirty="0"/>
           </a:p>
@@ -2826,37 +2927,42 @@
       </p:sp>
       <p:sp>
         <p:nvSpPr>
-          <p:cNvPr id="7" name="Shape 5"/>
-          <p:cNvSpPr/>
-          <p:nvPr/>
-        </p:nvSpPr>
-        <p:spPr>
-          <a:xfrm>
-            <a:off x="457200" y="1737360"/>
-            <a:ext cx="2624328" cy="1298448"/>
-          </a:xfrm>
-          <a:prstGeom prst="roundRect">
-            <a:avLst>
-              <a:gd name="adj" fmla="val 8451"/>
-            </a:avLst>
-          </a:prstGeom>
-          <a:solidFill>
-            <a:srgbClr val="FFFFFF"/>
-          </a:solidFill>
-          <a:ln w="9525">
-            <a:solidFill>
-              <a:srgbClr val="E6E0BF"/>
-            </a:solidFill>
-            <a:prstDash val="solid"/>
-          </a:ln>
-          <a:effectLst>
-            <a:outerShdw sx="100000" sy="100000" kx="0" ky="0" algn="bl" rotWithShape="0" blurRad="76200" dist="25400" dir="5400000">
-              <a:srgbClr val="283618">
-                <a:alpha val="8000"/>
-              </a:srgbClr>
-            </a:outerShdw>
-          </a:effectLst>
-        </p:spPr>
+          <p:cNvPr id="7" name="Text 5"/>
+          <p:cNvSpPr txBox="1"/>
+          <p:nvPr/>
+        </p:nvSpPr>
+        <p:spPr>
+          <a:xfrm>
+            <a:off x="457200" y="1783080"/>
+            <a:ext cx="3108960" cy="548640"/>
+          </a:xfrm>
+          <a:prstGeom prst="rect">
+            <a:avLst/>
+          </a:prstGeom>
+          <a:noFill/>
+          <a:ln/>
+        </p:spPr>
+        <p:txBody>
+          <a:bodyPr wrap="square" lIns="0" tIns="0" rIns="0" bIns="0" rtlCol="0" anchor="ctr"/>
+          <a:lstStyle/>
+          <a:p>
+            <a:pPr indent="0" marL="0">
+              <a:buNone/>
+            </a:pPr>
+            <a:r>
+              <a:rPr lang="en-US" sz="3200" b="1" dirty="0">
+                <a:solidFill>
+                  <a:srgbClr val="606C38"/>
+                </a:solidFill>
+                <a:latin typeface="Cambria" pitchFamily="34" charset="0"/>
+                <a:ea typeface="Cambria" pitchFamily="34" charset="-122"/>
+                <a:cs typeface="Cambria" pitchFamily="34" charset="-120"/>
+              </a:rPr>
+              <a:t>412 €</a:t>
+            </a:r>
+            <a:endParaRPr lang="en-US" sz="3200" dirty="0"/>
+          </a:p>
+        </p:txBody>
       </p:sp>
       <p:sp>
         <p:nvSpPr>
@@ -2866,8 +2972,8 @@
         </p:nvSpPr>
         <p:spPr>
           <a:xfrm>
-            <a:off x="640080" y="1874520"/>
-            <a:ext cx="2286000" cy="365760"/>
+            <a:off x="457200" y="2313432"/>
+            <a:ext cx="3108960" cy="320040"/>
           </a:xfrm>
           <a:prstGeom prst="rect">
             <a:avLst/>
@@ -2883,17 +2989,17 @@
               <a:buNone/>
             </a:pPr>
             <a:r>
-              <a:rPr lang="en-US" sz="1400" b="1" dirty="0">
-                <a:solidFill>
-                  <a:srgbClr val="BC6C25"/>
+              <a:rPr lang="en-US" sz="1200" dirty="0">
+                <a:solidFill>
+                  <a:srgbClr val="5C6446"/>
                 </a:solidFill>
                 <a:latin typeface="Calibri" pitchFamily="34" charset="0"/>
                 <a:ea typeface="Calibri" pitchFamily="34" charset="-122"/>
                 <a:cs typeface="Calibri" pitchFamily="34" charset="-120"/>
               </a:rPr>
-              <a:t>Falta de clientes</a:t>
-            </a:r>
-            <a:endParaRPr lang="en-US" sz="1400" dirty="0"/>
+              <a:t>valor médio de uma obra (sem IVA)</a:t>
+            </a:r>
+            <a:endParaRPr lang="en-US" sz="1200" dirty="0"/>
           </a:p>
         </p:txBody>
       </p:sp>
@@ -2905,17 +3011,56 @@
         </p:nvSpPr>
         <p:spPr>
           <a:xfrm>
-            <a:off x="640080" y="2240280"/>
-            <a:ext cx="2286000" cy="731520"/>
-          </a:xfrm>
-          <a:prstGeom prst="rect">
-            <a:avLst/>
-          </a:prstGeom>
-          <a:noFill/>
-          <a:ln/>
-        </p:spPr>
-        <p:txBody>
-          <a:bodyPr wrap="square" lIns="0" tIns="0" rIns="0" bIns="0" rtlCol="0" anchor="t"/>
+            <a:off x="457200" y="2770632"/>
+            <a:ext cx="3108960" cy="548640"/>
+          </a:xfrm>
+          <a:prstGeom prst="rect">
+            <a:avLst/>
+          </a:prstGeom>
+          <a:noFill/>
+          <a:ln/>
+        </p:spPr>
+        <p:txBody>
+          <a:bodyPr wrap="square" lIns="0" tIns="0" rIns="0" bIns="0" rtlCol="0" anchor="ctr"/>
+          <a:lstStyle/>
+          <a:p>
+            <a:pPr indent="0" marL="0">
+              <a:buNone/>
+            </a:pPr>
+            <a:r>
+              <a:rPr lang="en-US" sz="3200" b="1" dirty="0">
+                <a:solidFill>
+                  <a:srgbClr val="606C38"/>
+                </a:solidFill>
+                <a:latin typeface="Cambria" pitchFamily="34" charset="0"/>
+                <a:ea typeface="Cambria" pitchFamily="34" charset="-122"/>
+                <a:cs typeface="Cambria" pitchFamily="34" charset="-120"/>
+              </a:rPr>
+              <a:t>3 por mês</a:t>
+            </a:r>
+            <a:endParaRPr lang="en-US" sz="3200" dirty="0"/>
+          </a:p>
+        </p:txBody>
+      </p:sp>
+      <p:sp>
+        <p:nvSpPr>
+          <p:cNvPr id="10" name="Text 8"/>
+          <p:cNvSpPr txBox="1"/>
+          <p:nvPr/>
+        </p:nvSpPr>
+        <p:spPr>
+          <a:xfrm>
+            <a:off x="457200" y="3300984"/>
+            <a:ext cx="3108960" cy="320040"/>
+          </a:xfrm>
+          <a:prstGeom prst="rect">
+            <a:avLst/>
+          </a:prstGeom>
+          <a:noFill/>
+          <a:ln/>
+        </p:spPr>
+        <p:txBody>
+          <a:bodyPr wrap="square" lIns="0" tIns="0" rIns="0" bIns="0" rtlCol="0" anchor="ctr"/>
           <a:lstStyle/>
           <a:p>
             <a:pPr indent="0" marL="0">
@@ -2924,13 +3069,13 @@
             <a:r>
               <a:rPr lang="en-US" sz="1200" dirty="0">
                 <a:solidFill>
-                  <a:srgbClr val="283618"/>
+                  <a:srgbClr val="5C6446"/>
                 </a:solidFill>
                 <a:latin typeface="Calibri" pitchFamily="34" charset="0"/>
                 <a:ea typeface="Calibri" pitchFamily="34" charset="-122"/>
                 <a:cs typeface="Calibri" pitchFamily="34" charset="-120"/>
               </a:rPr>
-              <a:t>Pilotos com testemunhos; parcerias com AL, mediadoras e lares</a:t>
+              <a:t>obras para o ponto de equilíbrio</a:t>
             </a:r>
             <a:endParaRPr lang="en-US" sz="1200" dirty="0"/>
           </a:p>
@@ -2938,48 +3083,14 @@
       </p:sp>
       <p:sp>
         <p:nvSpPr>
-          <p:cNvPr id="10" name="Shape 8"/>
-          <p:cNvSpPr/>
-          <p:nvPr/>
-        </p:nvSpPr>
-        <p:spPr>
-          <a:xfrm>
-            <a:off x="3264408" y="1737360"/>
-            <a:ext cx="2624328" cy="1298448"/>
-          </a:xfrm>
-          <a:prstGeom prst="roundRect">
-            <a:avLst>
-              <a:gd name="adj" fmla="val 8451"/>
-            </a:avLst>
-          </a:prstGeom>
-          <a:solidFill>
-            <a:srgbClr val="FFFFFF"/>
-          </a:solidFill>
-          <a:ln w="9525">
-            <a:solidFill>
-              <a:srgbClr val="E6E0BF"/>
-            </a:solidFill>
-            <a:prstDash val="solid"/>
-          </a:ln>
-          <a:effectLst>
-            <a:outerShdw sx="100000" sy="100000" kx="0" ky="0" algn="bl" rotWithShape="0" blurRad="76200" dist="25400" dir="5400000">
-              <a:srgbClr val="283618">
-                <a:alpha val="8000"/>
-              </a:srgbClr>
-            </a:outerShdw>
-          </a:effectLst>
-        </p:spPr>
-      </p:sp>
-      <p:sp>
-        <p:nvSpPr>
           <p:cNvPr id="11" name="Text 9"/>
           <p:cNvSpPr txBox="1"/>
           <p:nvPr/>
         </p:nvSpPr>
         <p:spPr>
           <a:xfrm>
-            <a:off x="3447288" y="1874520"/>
-            <a:ext cx="2286000" cy="365760"/>
+            <a:off x="457200" y="3758184"/>
+            <a:ext cx="3108960" cy="548640"/>
           </a:xfrm>
           <a:prstGeom prst="rect">
             <a:avLst/>
@@ -2995,507 +3106,75 @@
               <a:buNone/>
             </a:pPr>
             <a:r>
-              <a:rPr lang="en-US" sz="1400" b="1" dirty="0">
-                <a:solidFill>
-                  <a:srgbClr val="BC6C25"/>
+              <a:rPr lang="en-US" sz="3200" b="1" dirty="0">
+                <a:solidFill>
+                  <a:srgbClr val="606C38"/>
+                </a:solidFill>
+                <a:latin typeface="Cambria" pitchFamily="34" charset="0"/>
+                <a:ea typeface="Cambria" pitchFamily="34" charset="-122"/>
+                <a:cs typeface="Cambria" pitchFamily="34" charset="-120"/>
+              </a:rPr>
+              <a:t>28</a:t>
+            </a:r>
+            <a:endParaRPr lang="en-US" sz="3200" dirty="0"/>
+          </a:p>
+        </p:txBody>
+      </p:sp>
+      <p:sp>
+        <p:nvSpPr>
+          <p:cNvPr id="12" name="Text 10"/>
+          <p:cNvSpPr txBox="1"/>
+          <p:nvPr/>
+        </p:nvSpPr>
+        <p:spPr>
+          <a:xfrm>
+            <a:off x="457200" y="4288536"/>
+            <a:ext cx="3108960" cy="320040"/>
+          </a:xfrm>
+          <a:prstGeom prst="rect">
+            <a:avLst/>
+          </a:prstGeom>
+          <a:noFill/>
+          <a:ln/>
+        </p:spPr>
+        <p:txBody>
+          <a:bodyPr wrap="square" lIns="0" tIns="0" rIns="0" bIns="0" rtlCol="0" anchor="ctr"/>
+          <a:lstStyle/>
+          <a:p>
+            <a:pPr indent="0" marL="0">
+              <a:buNone/>
+            </a:pPr>
+            <a:r>
+              <a:rPr lang="en-US" sz="1200" dirty="0">
+                <a:solidFill>
+                  <a:srgbClr val="5C6446"/>
                 </a:solidFill>
                 <a:latin typeface="Calibri" pitchFamily="34" charset="0"/>
                 <a:ea typeface="Calibri" pitchFamily="34" charset="-122"/>
                 <a:cs typeface="Calibri" pitchFamily="34" charset="-120"/>
               </a:rPr>
-              <a:t>Aumento dos custos</a:t>
-            </a:r>
-            <a:endParaRPr lang="en-US" sz="1400" dirty="0"/>
-          </a:p>
-        </p:txBody>
-      </p:sp>
-      <p:sp>
-        <p:nvSpPr>
-          <p:cNvPr id="12" name="Text 10"/>
-          <p:cNvSpPr txBox="1"/>
-          <p:nvPr/>
-        </p:nvSpPr>
-        <p:spPr>
-          <a:xfrm>
-            <a:off x="3447288" y="2240280"/>
-            <a:ext cx="2286000" cy="731520"/>
-          </a:xfrm>
-          <a:prstGeom prst="rect">
-            <a:avLst/>
-          </a:prstGeom>
-          <a:noFill/>
-          <a:ln/>
-        </p:spPr>
-        <p:txBody>
-          <a:bodyPr wrap="square" lIns="0" tIns="0" rIns="0" bIns="0" rtlCol="0" anchor="t"/>
-          <a:lstStyle/>
-          <a:p>
-            <a:pPr indent="0" marL="0">
-              <a:buNone/>
-            </a:pPr>
-            <a:r>
-              <a:rPr lang="en-US" sz="1200" dirty="0">
-                <a:solidFill>
-                  <a:srgbClr val="283618"/>
-                </a:solidFill>
-                <a:latin typeface="Calibri" pitchFamily="34" charset="0"/>
-                <a:ea typeface="Calibri" pitchFamily="34" charset="-122"/>
-                <a:cs typeface="Calibri" pitchFamily="34" charset="-120"/>
-              </a:rPr>
-              <a:t>Orçamentos válidos 30 dias; obras agrupadas por zona</a:t>
+              <a:t>casas com mensalidade em agosto de 2028</a:t>
             </a:r>
             <a:endParaRPr lang="en-US" sz="1200" dirty="0"/>
           </a:p>
         </p:txBody>
       </p:sp>
-      <p:sp>
-        <p:nvSpPr>
-          <p:cNvPr id="13" name="Shape 11"/>
-          <p:cNvSpPr/>
-          <p:nvPr/>
-        </p:nvSpPr>
-        <p:spPr>
-          <a:xfrm>
-            <a:off x="6071616" y="1737360"/>
-            <a:ext cx="2624328" cy="1298448"/>
-          </a:xfrm>
-          <a:prstGeom prst="roundRect">
-            <a:avLst>
-              <a:gd name="adj" fmla="val 8451"/>
-            </a:avLst>
-          </a:prstGeom>
-          <a:solidFill>
-            <a:srgbClr val="FFFFFF"/>
-          </a:solidFill>
-          <a:ln w="9525">
-            <a:solidFill>
-              <a:srgbClr val="E6E0BF"/>
-            </a:solidFill>
-            <a:prstDash val="solid"/>
-          </a:ln>
-          <a:effectLst>
-            <a:outerShdw sx="100000" sy="100000" kx="0" ky="0" algn="bl" rotWithShape="0" blurRad="76200" dist="25400" dir="5400000">
-              <a:srgbClr val="283618">
-                <a:alpha val="8000"/>
-              </a:srgbClr>
-            </a:outerShdw>
-          </a:effectLst>
-        </p:spPr>
-      </p:sp>
-      <p:sp>
-        <p:nvSpPr>
-          <p:cNvPr id="14" name="Text 12"/>
-          <p:cNvSpPr txBox="1"/>
-          <p:nvPr/>
-        </p:nvSpPr>
-        <p:spPr>
-          <a:xfrm>
-            <a:off x="6254496" y="1874520"/>
-            <a:ext cx="2286000" cy="365760"/>
-          </a:xfrm>
-          <a:prstGeom prst="rect">
-            <a:avLst/>
-          </a:prstGeom>
-          <a:noFill/>
-          <a:ln/>
-        </p:spPr>
-        <p:txBody>
-          <a:bodyPr wrap="square" lIns="0" tIns="0" rIns="0" bIns="0" rtlCol="0" anchor="ctr"/>
-          <a:lstStyle/>
-          <a:p>
-            <a:pPr indent="0" marL="0">
-              <a:buNone/>
-            </a:pPr>
-            <a:r>
-              <a:rPr lang="en-US" sz="1400" b="1" dirty="0">
-                <a:solidFill>
-                  <a:srgbClr val="BC6C25"/>
-                </a:solidFill>
-                <a:latin typeface="Calibri" pitchFamily="34" charset="0"/>
-                <a:ea typeface="Calibri" pitchFamily="34" charset="-122"/>
-                <a:cs typeface="Calibri" pitchFamily="34" charset="-120"/>
-              </a:rPr>
-              <a:t>Novos concorrentes</a:t>
-            </a:r>
-            <a:endParaRPr lang="en-US" sz="1400" dirty="0"/>
-          </a:p>
-        </p:txBody>
-      </p:sp>
-      <p:sp>
-        <p:nvSpPr>
-          <p:cNvPr id="15" name="Text 13"/>
-          <p:cNvSpPr txBox="1"/>
-          <p:nvPr/>
-        </p:nvSpPr>
-        <p:spPr>
-          <a:xfrm>
-            <a:off x="6254496" y="2240280"/>
-            <a:ext cx="2286000" cy="731520"/>
-          </a:xfrm>
-          <a:prstGeom prst="rect">
-            <a:avLst/>
-          </a:prstGeom>
-          <a:noFill/>
-          <a:ln/>
-        </p:spPr>
-        <p:txBody>
-          <a:bodyPr wrap="square" lIns="0" tIns="0" rIns="0" bIns="0" rtlCol="0" anchor="t"/>
-          <a:lstStyle/>
-          <a:p>
-            <a:pPr indent="0" marL="0">
-              <a:buNone/>
-            </a:pPr>
-            <a:r>
-              <a:rPr lang="en-US" sz="1200" dirty="0">
-                <a:solidFill>
-                  <a:srgbClr val="283618"/>
-                </a:solidFill>
-                <a:latin typeface="Calibri" pitchFamily="34" charset="0"/>
-                <a:ea typeface="Calibri" pitchFamily="34" charset="-122"/>
-                <a:cs typeface="Calibri" pitchFamily="34" charset="-120"/>
-              </a:rPr>
-              <a:t>Plataforma própria, suporte e preço sem fidelização</a:t>
-            </a:r>
-            <a:endParaRPr lang="en-US" sz="1200" dirty="0"/>
-          </a:p>
-        </p:txBody>
-      </p:sp>
-      <p:sp>
-        <p:nvSpPr>
-          <p:cNvPr id="16" name="Shape 14"/>
-          <p:cNvSpPr/>
-          <p:nvPr/>
-        </p:nvSpPr>
-        <p:spPr>
-          <a:xfrm>
-            <a:off x="457200" y="3200400"/>
-            <a:ext cx="2624328" cy="1298448"/>
-          </a:xfrm>
-          <a:prstGeom prst="roundRect">
-            <a:avLst>
-              <a:gd name="adj" fmla="val 8451"/>
-            </a:avLst>
-          </a:prstGeom>
-          <a:solidFill>
-            <a:srgbClr val="FFFFFF"/>
-          </a:solidFill>
-          <a:ln w="9525">
-            <a:solidFill>
-              <a:srgbClr val="E6E0BF"/>
-            </a:solidFill>
-            <a:prstDash val="solid"/>
-          </a:ln>
-          <a:effectLst>
-            <a:outerShdw sx="100000" sy="100000" kx="0" ky="0" algn="bl" rotWithShape="0" blurRad="76200" dist="25400" dir="5400000">
-              <a:srgbClr val="283618">
-                <a:alpha val="8000"/>
-              </a:srgbClr>
-            </a:outerShdw>
-          </a:effectLst>
-        </p:spPr>
-      </p:sp>
-      <p:sp>
-        <p:nvSpPr>
-          <p:cNvPr id="17" name="Text 15"/>
-          <p:cNvSpPr txBox="1"/>
-          <p:nvPr/>
-        </p:nvSpPr>
-        <p:spPr>
-          <a:xfrm>
-            <a:off x="640080" y="3337560"/>
-            <a:ext cx="2286000" cy="365760"/>
-          </a:xfrm>
-          <a:prstGeom prst="rect">
-            <a:avLst/>
-          </a:prstGeom>
-          <a:noFill/>
-          <a:ln/>
-        </p:spPr>
-        <p:txBody>
-          <a:bodyPr wrap="square" lIns="0" tIns="0" rIns="0" bIns="0" rtlCol="0" anchor="ctr"/>
-          <a:lstStyle/>
-          <a:p>
-            <a:pPr indent="0" marL="0">
-              <a:buNone/>
-            </a:pPr>
-            <a:r>
-              <a:rPr lang="en-US" sz="1400" b="1" dirty="0">
-                <a:solidFill>
-                  <a:srgbClr val="BC6C25"/>
-                </a:solidFill>
-                <a:latin typeface="Calibri" pitchFamily="34" charset="0"/>
-                <a:ea typeface="Calibri" pitchFamily="34" charset="-122"/>
-                <a:cs typeface="Calibri" pitchFamily="34" charset="-120"/>
-              </a:rPr>
-              <a:t>Um só fornecedor</a:t>
-            </a:r>
-            <a:endParaRPr lang="en-US" sz="1400" dirty="0"/>
-          </a:p>
-        </p:txBody>
-      </p:sp>
-      <p:sp>
-        <p:nvSpPr>
-          <p:cNvPr id="18" name="Text 16"/>
-          <p:cNvSpPr txBox="1"/>
-          <p:nvPr/>
-        </p:nvSpPr>
-        <p:spPr>
-          <a:xfrm>
-            <a:off x="640080" y="3703320"/>
-            <a:ext cx="2286000" cy="731520"/>
-          </a:xfrm>
-          <a:prstGeom prst="rect">
-            <a:avLst/>
-          </a:prstGeom>
-          <a:noFill/>
-          <a:ln/>
-        </p:spPr>
-        <p:txBody>
-          <a:bodyPr wrap="square" lIns="0" tIns="0" rIns="0" bIns="0" rtlCol="0" anchor="t"/>
-          <a:lstStyle/>
-          <a:p>
-            <a:pPr indent="0" marL="0">
-              <a:buNone/>
-            </a:pPr>
-            <a:r>
-              <a:rPr lang="en-US" sz="1200" dirty="0">
-                <a:solidFill>
-                  <a:srgbClr val="283618"/>
-                </a:solidFill>
-                <a:latin typeface="Calibri" pitchFamily="34" charset="0"/>
-                <a:ea typeface="Calibri" pitchFamily="34" charset="-122"/>
-                <a:cs typeface="Calibri" pitchFamily="34" charset="-120"/>
-              </a:rPr>
-              <a:t>2 distribuidores; protocolo aberto (MQTT)</a:t>
-            </a:r>
-            <a:endParaRPr lang="en-US" sz="1200" dirty="0"/>
-          </a:p>
-        </p:txBody>
-      </p:sp>
-      <p:sp>
-        <p:nvSpPr>
-          <p:cNvPr id="19" name="Shape 17"/>
-          <p:cNvSpPr/>
-          <p:nvPr/>
-        </p:nvSpPr>
-        <p:spPr>
-          <a:xfrm>
-            <a:off x="3264408" y="3200400"/>
-            <a:ext cx="2624328" cy="1298448"/>
-          </a:xfrm>
-          <a:prstGeom prst="roundRect">
-            <a:avLst>
-              <a:gd name="adj" fmla="val 8451"/>
-            </a:avLst>
-          </a:prstGeom>
-          <a:solidFill>
-            <a:srgbClr val="FFFFFF"/>
-          </a:solidFill>
-          <a:ln w="9525">
-            <a:solidFill>
-              <a:srgbClr val="E6E0BF"/>
-            </a:solidFill>
-            <a:prstDash val="solid"/>
-          </a:ln>
-          <a:effectLst>
-            <a:outerShdw sx="100000" sy="100000" kx="0" ky="0" algn="bl" rotWithShape="0" blurRad="76200" dist="25400" dir="5400000">
-              <a:srgbClr val="283618">
-                <a:alpha val="8000"/>
-              </a:srgbClr>
-            </a:outerShdw>
-          </a:effectLst>
-        </p:spPr>
-      </p:sp>
-      <p:sp>
-        <p:nvSpPr>
-          <p:cNvPr id="20" name="Text 18"/>
-          <p:cNvSpPr txBox="1"/>
-          <p:nvPr/>
-        </p:nvSpPr>
-        <p:spPr>
-          <a:xfrm>
-            <a:off x="3447288" y="3337560"/>
-            <a:ext cx="2286000" cy="365760"/>
-          </a:xfrm>
-          <a:prstGeom prst="rect">
-            <a:avLst/>
-          </a:prstGeom>
-          <a:noFill/>
-          <a:ln/>
-        </p:spPr>
-        <p:txBody>
-          <a:bodyPr wrap="square" lIns="0" tIns="0" rIns="0" bIns="0" rtlCol="0" anchor="ctr"/>
-          <a:lstStyle/>
-          <a:p>
-            <a:pPr indent="0" marL="0">
-              <a:buNone/>
-            </a:pPr>
-            <a:r>
-              <a:rPr lang="en-US" sz="1400" b="1" dirty="0">
-                <a:solidFill>
-                  <a:srgbClr val="BC6C25"/>
-                </a:solidFill>
-                <a:latin typeface="Calibri" pitchFamily="34" charset="0"/>
-                <a:ea typeface="Calibri" pitchFamily="34" charset="-122"/>
-                <a:cs typeface="Calibri" pitchFamily="34" charset="-120"/>
-              </a:rPr>
-              <a:t>Certificação DGEG</a:t>
-            </a:r>
-            <a:endParaRPr lang="en-US" sz="1400" dirty="0"/>
-          </a:p>
-        </p:txBody>
-      </p:sp>
-      <p:sp>
-        <p:nvSpPr>
-          <p:cNvPr id="21" name="Text 19"/>
-          <p:cNvSpPr txBox="1"/>
-          <p:nvPr/>
-        </p:nvSpPr>
-        <p:spPr>
-          <a:xfrm>
-            <a:off x="3447288" y="3703320"/>
-            <a:ext cx="2286000" cy="731520"/>
-          </a:xfrm>
-          <a:prstGeom prst="rect">
-            <a:avLst/>
-          </a:prstGeom>
-          <a:noFill/>
-          <a:ln/>
-        </p:spPr>
-        <p:txBody>
-          <a:bodyPr wrap="square" lIns="0" tIns="0" rIns="0" bIns="0" rtlCol="0" anchor="t"/>
-          <a:lstStyle/>
-          <a:p>
-            <a:pPr indent="0" marL="0">
-              <a:buNone/>
-            </a:pPr>
-            <a:r>
-              <a:rPr lang="en-US" sz="1200" dirty="0">
-                <a:solidFill>
-                  <a:srgbClr val="283618"/>
-                </a:solidFill>
-                <a:latin typeface="Calibri" pitchFamily="34" charset="0"/>
-                <a:ea typeface="Calibri" pitchFamily="34" charset="-122"/>
-                <a:cs typeface="Calibri" pitchFamily="34" charset="-120"/>
-              </a:rPr>
-              <a:t>Até ao fim do curso: subcontratar eletricista certificado</a:t>
-            </a:r>
-            <a:endParaRPr lang="en-US" sz="1200" dirty="0"/>
-          </a:p>
-        </p:txBody>
-      </p:sp>
-      <p:sp>
-        <p:nvSpPr>
-          <p:cNvPr id="22" name="Shape 20"/>
-          <p:cNvSpPr/>
-          <p:nvPr/>
-        </p:nvSpPr>
-        <p:spPr>
-          <a:xfrm>
-            <a:off x="6071616" y="3200400"/>
-            <a:ext cx="2624328" cy="1298448"/>
-          </a:xfrm>
-          <a:prstGeom prst="roundRect">
-            <a:avLst>
-              <a:gd name="adj" fmla="val 8451"/>
-            </a:avLst>
-          </a:prstGeom>
-          <a:solidFill>
-            <a:srgbClr val="FFFFFF"/>
-          </a:solidFill>
-          <a:ln w="9525">
-            <a:solidFill>
-              <a:srgbClr val="E6E0BF"/>
-            </a:solidFill>
-            <a:prstDash val="solid"/>
-          </a:ln>
-          <a:effectLst>
-            <a:outerShdw sx="100000" sy="100000" kx="0" ky="0" algn="bl" rotWithShape="0" blurRad="76200" dist="25400" dir="5400000">
-              <a:srgbClr val="283618">
-                <a:alpha val="8000"/>
-              </a:srgbClr>
-            </a:outerShdw>
-          </a:effectLst>
-        </p:spPr>
-      </p:sp>
-      <p:sp>
-        <p:nvSpPr>
-          <p:cNvPr id="23" name="Text 21"/>
-          <p:cNvSpPr txBox="1"/>
-          <p:nvPr/>
-        </p:nvSpPr>
-        <p:spPr>
-          <a:xfrm>
-            <a:off x="6254496" y="3337560"/>
-            <a:ext cx="2286000" cy="365760"/>
-          </a:xfrm>
-          <a:prstGeom prst="rect">
-            <a:avLst/>
-          </a:prstGeom>
-          <a:noFill/>
-          <a:ln/>
-        </p:spPr>
-        <p:txBody>
-          <a:bodyPr wrap="square" lIns="0" tIns="0" rIns="0" bIns="0" rtlCol="0" anchor="ctr"/>
-          <a:lstStyle/>
-          <a:p>
-            <a:pPr indent="0" marL="0">
-              <a:buNone/>
-            </a:pPr>
-            <a:r>
-              <a:rPr lang="en-US" sz="1400" b="1" dirty="0">
-                <a:solidFill>
-                  <a:srgbClr val="BC6C25"/>
-                </a:solidFill>
-                <a:latin typeface="Calibri" pitchFamily="34" charset="0"/>
-                <a:ea typeface="Calibri" pitchFamily="34" charset="-122"/>
-                <a:cs typeface="Calibri" pitchFamily="34" charset="-120"/>
-              </a:rPr>
-              <a:t>Falha de internet</a:t>
-            </a:r>
-            <a:endParaRPr lang="en-US" sz="1400" dirty="0"/>
-          </a:p>
-        </p:txBody>
-      </p:sp>
-      <p:sp>
-        <p:nvSpPr>
-          <p:cNvPr id="24" name="Text 22"/>
-          <p:cNvSpPr txBox="1"/>
-          <p:nvPr/>
-        </p:nvSpPr>
-        <p:spPr>
-          <a:xfrm>
-            <a:off x="6254496" y="3703320"/>
-            <a:ext cx="2286000" cy="731520"/>
-          </a:xfrm>
-          <a:prstGeom prst="rect">
-            <a:avLst/>
-          </a:prstGeom>
-          <a:noFill/>
-          <a:ln/>
-        </p:spPr>
-        <p:txBody>
-          <a:bodyPr wrap="square" lIns="0" tIns="0" rIns="0" bIns="0" rtlCol="0" anchor="t"/>
-          <a:lstStyle/>
-          <a:p>
-            <a:pPr indent="0" marL="0">
-              <a:buNone/>
-            </a:pPr>
-            <a:r>
-              <a:rPr lang="en-US" sz="1200" dirty="0">
-                <a:solidFill>
-                  <a:srgbClr val="283618"/>
-                </a:solidFill>
-                <a:latin typeface="Calibri" pitchFamily="34" charset="0"/>
-                <a:ea typeface="Calibri" pitchFamily="34" charset="-122"/>
-                <a:cs typeface="Calibri" pitchFamily="34" charset="-120"/>
-              </a:rPr>
-              <a:t>Regras nos aparelhos; Raspberry Pi no plano Premium</a:t>
-            </a:r>
-            <a:endParaRPr lang="en-US" sz="1200" dirty="0"/>
-          </a:p>
-        </p:txBody>
-      </p:sp>
+      <p:graphicFrame>
+        <p:nvGraphicFramePr>
+          <p:cNvPr id="13" name="Chart 0" descr=""/>
+          <p:cNvGraphicFramePr/>
+          <p:nvPr/>
+        </p:nvGraphicFramePr>
+        <p:xfrm>
+          <a:off x="3840480" y="1645920"/>
+          <a:ext cx="4937760" cy="3108960"/>
+        </p:xfrm>
+        <a:graphic xmlns:a="http://schemas.openxmlformats.org/drawingml/2006/main">
+          <a:graphicData uri="http://schemas.openxmlformats.org/drawingml/2006/chart">
+            <c:chart xmlns:c="http://schemas.openxmlformats.org/drawingml/2006/chart" r:id="rId1"/>
+          </a:graphicData>
+        </a:graphic>
+      </p:graphicFrame>
     </p:spTree>
   </p:cSld>
   <p:clrMapOvr>
@@ -3561,7 +3240,7 @@
                 <a:ea typeface="Calibri" pitchFamily="34" charset="-122"/>
                 <a:cs typeface="Calibri" pitchFamily="34" charset="-120"/>
               </a:rPr>
-              <a:t>FASE 3 · NEGÓCIO</a:t>
+              <a:t>FASE 2 · PROJETO</a:t>
             </a:r>
             <a:endParaRPr lang="en-US" sz="1100" dirty="0"/>
           </a:p>
@@ -3600,7 +3279,7 @@
                 <a:ea typeface="Cambria" pitchFamily="34" charset="-122"/>
                 <a:cs typeface="Cambria" pitchFamily="34" charset="-120"/>
               </a:rPr>
-              <a:t>Qual a primeira ação a realizar?</a:t>
+              <a:t>Quais os principais riscos?</a:t>
             </a:r>
             <a:endParaRPr lang="en-US" sz="3000" dirty="0"/>
           </a:p>
@@ -3664,7 +3343,7 @@
                 <a:ea typeface="Cambria" pitchFamily="34" charset="-122"/>
                 <a:cs typeface="Cambria" pitchFamily="34" charset="-120"/>
               </a:rPr>
-              <a:t>10</a:t>
+              <a:t>9</a:t>
             </a:r>
             <a:endParaRPr lang="en-US" sz="792" dirty="0"/>
           </a:p>
@@ -3703,7 +3382,7 @@
                 <a:ea typeface="Calibri" pitchFamily="34" charset="-122"/>
                 <a:cs typeface="Calibri" pitchFamily="34" charset="-120"/>
               </a:rPr>
-              <a:t>Plano de ação dos primeiros 3 meses</a:t>
+              <a:t>E a medida preventiva de cada um</a:t>
             </a:r>
             <a:endParaRPr lang="en-US" sz="1400" dirty="0"/>
           </a:p>
@@ -3717,56 +3396,154 @@
         </p:nvSpPr>
         <p:spPr>
           <a:xfrm>
-            <a:off x="822960" y="2331720"/>
-            <a:ext cx="7498080" cy="0"/>
-          </a:xfrm>
-          <a:prstGeom prst="line">
-            <a:avLst/>
-          </a:prstGeom>
-          <a:noFill/>
-          <a:ln w="25400">
+            <a:off x="457200" y="1737360"/>
+            <a:ext cx="2624328" cy="1298448"/>
+          </a:xfrm>
+          <a:prstGeom prst="roundRect">
+            <a:avLst>
+              <a:gd name="adj" fmla="val 8451"/>
+            </a:avLst>
+          </a:prstGeom>
+          <a:solidFill>
+            <a:srgbClr val="FFFFFF"/>
+          </a:solidFill>
+          <a:ln w="9525">
             <a:solidFill>
-              <a:srgbClr val="DDA15E"/>
+              <a:srgbClr val="E6E0BF"/>
             </a:solidFill>
             <a:prstDash val="solid"/>
           </a:ln>
-        </p:spPr>
-      </p:sp>
-      <p:sp>
-        <p:nvSpPr>
-          <p:cNvPr id="8" name="Shape 6"/>
+          <a:effectLst>
+            <a:outerShdw sx="100000" sy="100000" kx="0" ky="0" algn="bl" rotWithShape="0" blurRad="76200" dist="25400" dir="5400000">
+              <a:srgbClr val="283618">
+                <a:alpha val="8000"/>
+              </a:srgbClr>
+            </a:outerShdw>
+          </a:effectLst>
+        </p:spPr>
+      </p:sp>
+      <p:sp>
+        <p:nvSpPr>
+          <p:cNvPr id="8" name="Text 6"/>
+          <p:cNvSpPr txBox="1"/>
+          <p:nvPr/>
+        </p:nvSpPr>
+        <p:spPr>
+          <a:xfrm>
+            <a:off x="640080" y="1874520"/>
+            <a:ext cx="2286000" cy="365760"/>
+          </a:xfrm>
+          <a:prstGeom prst="rect">
+            <a:avLst/>
+          </a:prstGeom>
+          <a:noFill/>
+          <a:ln/>
+        </p:spPr>
+        <p:txBody>
+          <a:bodyPr wrap="square" lIns="0" tIns="0" rIns="0" bIns="0" rtlCol="0" anchor="ctr"/>
+          <a:lstStyle/>
+          <a:p>
+            <a:pPr indent="0" marL="0">
+              <a:buNone/>
+            </a:pPr>
+            <a:r>
+              <a:rPr lang="en-US" sz="1400" b="1" dirty="0">
+                <a:solidFill>
+                  <a:srgbClr val="BC6C25"/>
+                </a:solidFill>
+                <a:latin typeface="Calibri" pitchFamily="34" charset="0"/>
+                <a:ea typeface="Calibri" pitchFamily="34" charset="-122"/>
+                <a:cs typeface="Calibri" pitchFamily="34" charset="-120"/>
+              </a:rPr>
+              <a:t>Falta de clientes</a:t>
+            </a:r>
+            <a:endParaRPr lang="en-US" sz="1400" dirty="0"/>
+          </a:p>
+        </p:txBody>
+      </p:sp>
+      <p:sp>
+        <p:nvSpPr>
+          <p:cNvPr id="9" name="Text 7"/>
+          <p:cNvSpPr txBox="1"/>
+          <p:nvPr/>
+        </p:nvSpPr>
+        <p:spPr>
+          <a:xfrm>
+            <a:off x="640080" y="2240280"/>
+            <a:ext cx="2286000" cy="731520"/>
+          </a:xfrm>
+          <a:prstGeom prst="rect">
+            <a:avLst/>
+          </a:prstGeom>
+          <a:noFill/>
+          <a:ln/>
+        </p:spPr>
+        <p:txBody>
+          <a:bodyPr wrap="square" lIns="0" tIns="0" rIns="0" bIns="0" rtlCol="0" anchor="t"/>
+          <a:lstStyle/>
+          <a:p>
+            <a:pPr indent="0" marL="0">
+              <a:buNone/>
+            </a:pPr>
+            <a:r>
+              <a:rPr lang="en-US" sz="1200" dirty="0">
+                <a:solidFill>
+                  <a:srgbClr val="283618"/>
+                </a:solidFill>
+                <a:latin typeface="Calibri" pitchFamily="34" charset="0"/>
+                <a:ea typeface="Calibri" pitchFamily="34" charset="-122"/>
+                <a:cs typeface="Calibri" pitchFamily="34" charset="-120"/>
+              </a:rPr>
+              <a:t>Avaliações no Google, relatório grátis da casa, parcerias</a:t>
+            </a:r>
+            <a:endParaRPr lang="en-US" sz="1200" dirty="0"/>
+          </a:p>
+        </p:txBody>
+      </p:sp>
+      <p:sp>
+        <p:nvSpPr>
+          <p:cNvPr id="10" name="Shape 8"/>
           <p:cNvSpPr/>
           <p:nvPr/>
         </p:nvSpPr>
         <p:spPr>
           <a:xfrm>
-            <a:off x="640080" y="2148840"/>
-            <a:ext cx="365760" cy="365760"/>
-          </a:xfrm>
-          <a:prstGeom prst="ellipse">
-            <a:avLst/>
+            <a:off x="3264408" y="1737360"/>
+            <a:ext cx="2624328" cy="1298448"/>
+          </a:xfrm>
+          <a:prstGeom prst="roundRect">
+            <a:avLst>
+              <a:gd name="adj" fmla="val 8451"/>
+            </a:avLst>
           </a:prstGeom>
           <a:solidFill>
-            <a:srgbClr val="BC6C25"/>
+            <a:srgbClr val="FFFFFF"/>
           </a:solidFill>
-          <a:ln w="12700">
+          <a:ln w="9525">
             <a:solidFill>
-              <a:srgbClr val="BC6C25"/>
+              <a:srgbClr val="E6E0BF"/>
             </a:solidFill>
             <a:prstDash val="solid"/>
           </a:ln>
-        </p:spPr>
-      </p:sp>
-      <p:sp>
-        <p:nvSpPr>
-          <p:cNvPr id="9" name="Text 7"/>
-          <p:cNvSpPr txBox="1"/>
-          <p:nvPr/>
-        </p:nvSpPr>
-        <p:spPr>
-          <a:xfrm>
-            <a:off x="640080" y="2148840"/>
-            <a:ext cx="365760" cy="365760"/>
+          <a:effectLst>
+            <a:outerShdw sx="100000" sy="100000" kx="0" ky="0" algn="bl" rotWithShape="0" blurRad="76200" dist="25400" dir="5400000">
+              <a:srgbClr val="283618">
+                <a:alpha val="8000"/>
+              </a:srgbClr>
+            </a:outerShdw>
+          </a:effectLst>
+        </p:spPr>
+      </p:sp>
+      <p:sp>
+        <p:nvSpPr>
+          <p:cNvPr id="11" name="Text 9"/>
+          <p:cNvSpPr txBox="1"/>
+          <p:nvPr/>
+        </p:nvSpPr>
+        <p:spPr>
+          <a:xfrm>
+            <a:off x="3447288" y="1874520"/>
+            <a:ext cx="2286000" cy="365760"/>
           </a:xfrm>
           <a:prstGeom prst="rect">
             <a:avLst/>
@@ -3778,50 +3555,11 @@
           <a:bodyPr wrap="square" lIns="0" tIns="0" rIns="0" bIns="0" rtlCol="0" anchor="ctr"/>
           <a:lstStyle/>
           <a:p>
-            <a:pPr algn="ctr" indent="0" marL="0">
-              <a:buNone/>
-            </a:pPr>
-            <a:r>
-              <a:rPr lang="en-US" sz="880" b="1" dirty="0">
-                <a:solidFill>
-                  <a:srgbClr val="FEFAE0"/>
-                </a:solidFill>
-                <a:latin typeface="Cambria" pitchFamily="34" charset="0"/>
-                <a:ea typeface="Cambria" pitchFamily="34" charset="-122"/>
-                <a:cs typeface="Cambria" pitchFamily="34" charset="-120"/>
-              </a:rPr>
-              <a:t>1</a:t>
-            </a:r>
-            <a:endParaRPr lang="en-US" sz="880" dirty="0"/>
-          </a:p>
-        </p:txBody>
-      </p:sp>
-      <p:sp>
-        <p:nvSpPr>
-          <p:cNvPr id="10" name="Text 8"/>
-          <p:cNvSpPr txBox="1"/>
-          <p:nvPr/>
-        </p:nvSpPr>
-        <p:spPr>
-          <a:xfrm>
-            <a:off x="457200" y="2651760"/>
-            <a:ext cx="1920240" cy="320040"/>
-          </a:xfrm>
-          <a:prstGeom prst="rect">
-            <a:avLst/>
-          </a:prstGeom>
-          <a:noFill/>
-          <a:ln/>
-        </p:spPr>
-        <p:txBody>
-          <a:bodyPr wrap="square" lIns="0" tIns="0" rIns="0" bIns="0" rtlCol="0" anchor="ctr"/>
-          <a:lstStyle/>
-          <a:p>
-            <a:pPr indent="0" marL="0">
-              <a:buNone/>
-            </a:pPr>
-            <a:r>
-              <a:rPr lang="en-US" sz="1300" b="1" dirty="0">
+            <a:pPr indent="0" marL="0">
+              <a:buNone/>
+            </a:pPr>
+            <a:r>
+              <a:rPr lang="en-US" sz="1400" b="1" dirty="0">
                 <a:solidFill>
                   <a:srgbClr val="BC6C25"/>
                 </a:solidFill>
@@ -3829,22 +3567,22 @@
                 <a:ea typeface="Calibri" pitchFamily="34" charset="-122"/>
                 <a:cs typeface="Calibri" pitchFamily="34" charset="-120"/>
               </a:rPr>
-              <a:t>Mês 1</a:t>
-            </a:r>
-            <a:endParaRPr lang="en-US" sz="1300" dirty="0"/>
-          </a:p>
-        </p:txBody>
-      </p:sp>
-      <p:sp>
-        <p:nvSpPr>
-          <p:cNvPr id="11" name="Text 9"/>
-          <p:cNvSpPr txBox="1"/>
-          <p:nvPr/>
-        </p:nvSpPr>
-        <p:spPr>
-          <a:xfrm>
-            <a:off x="457200" y="2971800"/>
-            <a:ext cx="1920240" cy="1188720"/>
+              <a:t>Habilitação atrasada</a:t>
+            </a:r>
+            <a:endParaRPr lang="en-US" sz="1400" dirty="0"/>
+          </a:p>
+        </p:txBody>
+      </p:sp>
+      <p:sp>
+        <p:nvSpPr>
+          <p:cNvPr id="12" name="Text 10"/>
+          <p:cNvSpPr txBox="1"/>
+          <p:nvPr/>
+        </p:nvSpPr>
+        <p:spPr>
+          <a:xfrm>
+            <a:off x="3447288" y="2240280"/>
+            <a:ext cx="2286000" cy="731520"/>
           </a:xfrm>
           <a:prstGeom prst="rect">
             <a:avLst/>
@@ -3860,7 +3598,7 @@
               <a:buNone/>
             </a:pPr>
             <a:r>
-              <a:rPr lang="en-US" sz="1300" dirty="0">
+              <a:rPr lang="en-US" sz="1200" dirty="0">
                 <a:solidFill>
                   <a:srgbClr val="283618"/>
                 </a:solidFill>
@@ -3868,47 +3606,56 @@
                 <a:ea typeface="Calibri" pitchFamily="34" charset="-122"/>
                 <a:cs typeface="Calibri" pitchFamily="34" charset="-120"/>
               </a:rPr>
-              <a:t>Decidir sócios e criar a empresa; seguro e contabilista</a:t>
-            </a:r>
-            <a:endParaRPr lang="en-US" sz="1300" dirty="0"/>
-          </a:p>
-        </p:txBody>
-      </p:sp>
-      <p:sp>
-        <p:nvSpPr>
-          <p:cNvPr id="12" name="Shape 10"/>
+              <a:t>Não marcar obras antes do fim do curso</a:t>
+            </a:r>
+            <a:endParaRPr lang="en-US" sz="1200" dirty="0"/>
+          </a:p>
+        </p:txBody>
+      </p:sp>
+      <p:sp>
+        <p:nvSpPr>
+          <p:cNvPr id="13" name="Shape 11"/>
           <p:cNvSpPr/>
           <p:nvPr/>
         </p:nvSpPr>
         <p:spPr>
           <a:xfrm>
-            <a:off x="2743200" y="2148840"/>
-            <a:ext cx="365760" cy="365760"/>
-          </a:xfrm>
-          <a:prstGeom prst="ellipse">
-            <a:avLst/>
+            <a:off x="6071616" y="1737360"/>
+            <a:ext cx="2624328" cy="1298448"/>
+          </a:xfrm>
+          <a:prstGeom prst="roundRect">
+            <a:avLst>
+              <a:gd name="adj" fmla="val 8451"/>
+            </a:avLst>
           </a:prstGeom>
           <a:solidFill>
-            <a:srgbClr val="606C38"/>
+            <a:srgbClr val="FFFFFF"/>
           </a:solidFill>
-          <a:ln w="12700">
+          <a:ln w="9525">
             <a:solidFill>
-              <a:srgbClr val="606C38"/>
+              <a:srgbClr val="E6E0BF"/>
             </a:solidFill>
             <a:prstDash val="solid"/>
           </a:ln>
-        </p:spPr>
-      </p:sp>
-      <p:sp>
-        <p:nvSpPr>
-          <p:cNvPr id="13" name="Text 11"/>
-          <p:cNvSpPr txBox="1"/>
-          <p:nvPr/>
-        </p:nvSpPr>
-        <p:spPr>
-          <a:xfrm>
-            <a:off x="2743200" y="2148840"/>
-            <a:ext cx="365760" cy="365760"/>
+          <a:effectLst>
+            <a:outerShdw sx="100000" sy="100000" kx="0" ky="0" algn="bl" rotWithShape="0" blurRad="76200" dist="25400" dir="5400000">
+              <a:srgbClr val="283618">
+                <a:alpha val="8000"/>
+              </a:srgbClr>
+            </a:outerShdw>
+          </a:effectLst>
+        </p:spPr>
+      </p:sp>
+      <p:sp>
+        <p:nvSpPr>
+          <p:cNvPr id="14" name="Text 12"/>
+          <p:cNvSpPr txBox="1"/>
+          <p:nvPr/>
+        </p:nvSpPr>
+        <p:spPr>
+          <a:xfrm>
+            <a:off x="6254496" y="1874520"/>
+            <a:ext cx="2286000" cy="365760"/>
           </a:xfrm>
           <a:prstGeom prst="rect">
             <a:avLst/>
@@ -3920,50 +3667,11 @@
           <a:bodyPr wrap="square" lIns="0" tIns="0" rIns="0" bIns="0" rtlCol="0" anchor="ctr"/>
           <a:lstStyle/>
           <a:p>
-            <a:pPr algn="ctr" indent="0" marL="0">
-              <a:buNone/>
-            </a:pPr>
-            <a:r>
-              <a:rPr lang="en-US" sz="880" b="1" dirty="0">
-                <a:solidFill>
-                  <a:srgbClr val="FEFAE0"/>
-                </a:solidFill>
-                <a:latin typeface="Cambria" pitchFamily="34" charset="0"/>
-                <a:ea typeface="Cambria" pitchFamily="34" charset="-122"/>
-                <a:cs typeface="Cambria" pitchFamily="34" charset="-120"/>
-              </a:rPr>
-              <a:t>2</a:t>
-            </a:r>
-            <a:endParaRPr lang="en-US" sz="880" dirty="0"/>
-          </a:p>
-        </p:txBody>
-      </p:sp>
-      <p:sp>
-        <p:nvSpPr>
-          <p:cNvPr id="14" name="Text 12"/>
-          <p:cNvSpPr txBox="1"/>
-          <p:nvPr/>
-        </p:nvSpPr>
-        <p:spPr>
-          <a:xfrm>
-            <a:off x="2560320" y="2651760"/>
-            <a:ext cx="1920240" cy="320040"/>
-          </a:xfrm>
-          <a:prstGeom prst="rect">
-            <a:avLst/>
-          </a:prstGeom>
-          <a:noFill/>
-          <a:ln/>
-        </p:spPr>
-        <p:txBody>
-          <a:bodyPr wrap="square" lIns="0" tIns="0" rIns="0" bIns="0" rtlCol="0" anchor="ctr"/>
-          <a:lstStyle/>
-          <a:p>
-            <a:pPr indent="0" marL="0">
-              <a:buNone/>
-            </a:pPr>
-            <a:r>
-              <a:rPr lang="en-US" sz="1300" b="1" dirty="0">
+            <a:pPr indent="0" marL="0">
+              <a:buNone/>
+            </a:pPr>
+            <a:r>
+              <a:rPr lang="en-US" sz="1400" b="1" dirty="0">
                 <a:solidFill>
                   <a:srgbClr val="BC6C25"/>
                 </a:solidFill>
@@ -3971,9 +3679,9 @@
                 <a:ea typeface="Calibri" pitchFamily="34" charset="-122"/>
                 <a:cs typeface="Calibri" pitchFamily="34" charset="-120"/>
               </a:rPr>
-              <a:t>Mês 1–2</a:t>
-            </a:r>
-            <a:endParaRPr lang="en-US" sz="1300" dirty="0"/>
+              <a:t>Tudo depende do gerente</a:t>
+            </a:r>
+            <a:endParaRPr lang="en-US" sz="1400" dirty="0"/>
           </a:p>
         </p:txBody>
       </p:sp>
@@ -3985,8 +3693,8 @@
         </p:nvSpPr>
         <p:spPr>
           <a:xfrm>
-            <a:off x="2560320" y="2971800"/>
-            <a:ext cx="1920240" cy="1188720"/>
+            <a:off x="6254496" y="2240280"/>
+            <a:ext cx="2286000" cy="731520"/>
           </a:xfrm>
           <a:prstGeom prst="rect">
             <a:avLst/>
@@ -4002,7 +3710,7 @@
               <a:buNone/>
             </a:pPr>
             <a:r>
-              <a:rPr lang="en-US" sz="1300" dirty="0">
+              <a:rPr lang="en-US" sz="1200" dirty="0">
                 <a:solidFill>
                   <a:srgbClr val="283618"/>
                 </a:solidFill>
@@ -4010,9 +3718,9 @@
                 <a:ea typeface="Calibri" pitchFamily="34" charset="-122"/>
                 <a:cs typeface="Calibri" pitchFamily="34" charset="-120"/>
               </a:rPr>
-              <a:t>Servidor, app e kit de demonstração prontos</a:t>
-            </a:r>
-            <a:endParaRPr lang="en-US" sz="1300" dirty="0"/>
+              <a:t>Procedimentos escritos; atendimento a meio tempo acima de 12 obras por mês</a:t>
+            </a:r>
+            <a:endParaRPr lang="en-US" sz="1200" dirty="0"/>
           </a:p>
         </p:txBody>
       </p:sp>
@@ -4024,21 +3732,30 @@
         </p:nvSpPr>
         <p:spPr>
           <a:xfrm>
-            <a:off x="4846320" y="2148840"/>
-            <a:ext cx="365760" cy="365760"/>
-          </a:xfrm>
-          <a:prstGeom prst="ellipse">
-            <a:avLst/>
+            <a:off x="457200" y="3200400"/>
+            <a:ext cx="2624328" cy="1298448"/>
+          </a:xfrm>
+          <a:prstGeom prst="roundRect">
+            <a:avLst>
+              <a:gd name="adj" fmla="val 8451"/>
+            </a:avLst>
           </a:prstGeom>
           <a:solidFill>
-            <a:srgbClr val="606C38"/>
+            <a:srgbClr val="FFFFFF"/>
           </a:solidFill>
-          <a:ln w="12700">
+          <a:ln w="9525">
             <a:solidFill>
-              <a:srgbClr val="606C38"/>
+              <a:srgbClr val="E6E0BF"/>
             </a:solidFill>
             <a:prstDash val="solid"/>
           </a:ln>
+          <a:effectLst>
+            <a:outerShdw sx="100000" sy="100000" kx="0" ky="0" algn="bl" rotWithShape="0" blurRad="76200" dist="25400" dir="5400000">
+              <a:srgbClr val="283618">
+                <a:alpha val="8000"/>
+              </a:srgbClr>
+            </a:outerShdw>
+          </a:effectLst>
         </p:spPr>
       </p:sp>
       <p:sp>
@@ -4049,8 +3766,8 @@
         </p:nvSpPr>
         <p:spPr>
           <a:xfrm>
-            <a:off x="4846320" y="2148840"/>
-            <a:ext cx="365760" cy="365760"/>
+            <a:off x="640080" y="3337560"/>
+            <a:ext cx="2286000" cy="365760"/>
           </a:xfrm>
           <a:prstGeom prst="rect">
             <a:avLst/>
@@ -4062,50 +3779,11 @@
           <a:bodyPr wrap="square" lIns="0" tIns="0" rIns="0" bIns="0" rtlCol="0" anchor="ctr"/>
           <a:lstStyle/>
           <a:p>
-            <a:pPr algn="ctr" indent="0" marL="0">
-              <a:buNone/>
-            </a:pPr>
-            <a:r>
-              <a:rPr lang="en-US" sz="880" b="1" dirty="0">
-                <a:solidFill>
-                  <a:srgbClr val="FEFAE0"/>
-                </a:solidFill>
-                <a:latin typeface="Cambria" pitchFamily="34" charset="0"/>
-                <a:ea typeface="Cambria" pitchFamily="34" charset="-122"/>
-                <a:cs typeface="Cambria" pitchFamily="34" charset="-120"/>
-              </a:rPr>
-              <a:t>3</a:t>
-            </a:r>
-            <a:endParaRPr lang="en-US" sz="880" dirty="0"/>
-          </a:p>
-        </p:txBody>
-      </p:sp>
-      <p:sp>
-        <p:nvSpPr>
-          <p:cNvPr id="18" name="Text 16"/>
-          <p:cNvSpPr txBox="1"/>
-          <p:nvPr/>
-        </p:nvSpPr>
-        <p:spPr>
-          <a:xfrm>
-            <a:off x="4663440" y="2651760"/>
-            <a:ext cx="1920240" cy="320040"/>
-          </a:xfrm>
-          <a:prstGeom prst="rect">
-            <a:avLst/>
-          </a:prstGeom>
-          <a:noFill/>
-          <a:ln/>
-        </p:spPr>
-        <p:txBody>
-          <a:bodyPr wrap="square" lIns="0" tIns="0" rIns="0" bIns="0" rtlCol="0" anchor="ctr"/>
-          <a:lstStyle/>
-          <a:p>
-            <a:pPr indent="0" marL="0">
-              <a:buNone/>
-            </a:pPr>
-            <a:r>
-              <a:rPr lang="en-US" sz="1300" b="1" dirty="0">
+            <a:pPr indent="0" marL="0">
+              <a:buNone/>
+            </a:pPr>
+            <a:r>
+              <a:rPr lang="en-US" sz="1400" b="1" dirty="0">
                 <a:solidFill>
                   <a:srgbClr val="BC6C25"/>
                 </a:solidFill>
@@ -4113,22 +3791,22 @@
                 <a:ea typeface="Calibri" pitchFamily="34" charset="-122"/>
                 <a:cs typeface="Calibri" pitchFamily="34" charset="-120"/>
               </a:rPr>
-              <a:t>Mês 2</a:t>
-            </a:r>
-            <a:endParaRPr lang="en-US" sz="1300" dirty="0"/>
-          </a:p>
-        </p:txBody>
-      </p:sp>
-      <p:sp>
-        <p:nvSpPr>
-          <p:cNvPr id="19" name="Text 17"/>
-          <p:cNvSpPr txBox="1"/>
-          <p:nvPr/>
-        </p:nvSpPr>
-        <p:spPr>
-          <a:xfrm>
-            <a:off x="4663440" y="2971800"/>
-            <a:ext cx="1920240" cy="1188720"/>
+              <a:t>Parceiros sem disponibilidade</a:t>
+            </a:r>
+            <a:endParaRPr lang="en-US" sz="1400" dirty="0"/>
+          </a:p>
+        </p:txBody>
+      </p:sp>
+      <p:sp>
+        <p:nvSpPr>
+          <p:cNvPr id="18" name="Text 16"/>
+          <p:cNvSpPr txBox="1"/>
+          <p:nvPr/>
+        </p:nvSpPr>
+        <p:spPr>
+          <a:xfrm>
+            <a:off x="640080" y="3703320"/>
+            <a:ext cx="2286000" cy="731520"/>
           </a:xfrm>
           <a:prstGeom prst="rect">
             <a:avLst/>
@@ -4144,7 +3822,7 @@
               <a:buNone/>
             </a:pPr>
             <a:r>
-              <a:rPr lang="en-US" sz="1300" dirty="0">
+              <a:rPr lang="en-US" sz="1200" dirty="0">
                 <a:solidFill>
                   <a:srgbClr val="283618"/>
                 </a:solidFill>
@@ -4152,47 +3830,56 @@
                 <a:ea typeface="Calibri" pitchFamily="34" charset="-122"/>
                 <a:cs typeface="Calibri" pitchFamily="34" charset="-120"/>
               </a:rPr>
-              <a:t>Lançamento: Google, site, flyers; pagamentos Stripe</a:t>
-            </a:r>
-            <a:endParaRPr lang="en-US" sz="1300" dirty="0"/>
-          </a:p>
-        </p:txBody>
-      </p:sp>
-      <p:sp>
-        <p:nvSpPr>
-          <p:cNvPr id="20" name="Shape 18"/>
+              <a:t>Suplente em cada especialidade; bolsa de trabalhos</a:t>
+            </a:r>
+            <a:endParaRPr lang="en-US" sz="1200" dirty="0"/>
+          </a:p>
+        </p:txBody>
+      </p:sp>
+      <p:sp>
+        <p:nvSpPr>
+          <p:cNvPr id="19" name="Shape 17"/>
           <p:cNvSpPr/>
           <p:nvPr/>
         </p:nvSpPr>
         <p:spPr>
           <a:xfrm>
-            <a:off x="6949440" y="2148840"/>
-            <a:ext cx="365760" cy="365760"/>
-          </a:xfrm>
-          <a:prstGeom prst="ellipse">
-            <a:avLst/>
+            <a:off x="3264408" y="3200400"/>
+            <a:ext cx="2624328" cy="1298448"/>
+          </a:xfrm>
+          <a:prstGeom prst="roundRect">
+            <a:avLst>
+              <a:gd name="adj" fmla="val 8451"/>
+            </a:avLst>
           </a:prstGeom>
           <a:solidFill>
-            <a:srgbClr val="606C38"/>
+            <a:srgbClr val="FFFFFF"/>
           </a:solidFill>
-          <a:ln w="12700">
+          <a:ln w="9525">
             <a:solidFill>
-              <a:srgbClr val="606C38"/>
+              <a:srgbClr val="E6E0BF"/>
             </a:solidFill>
             <a:prstDash val="solid"/>
           </a:ln>
-        </p:spPr>
-      </p:sp>
-      <p:sp>
-        <p:nvSpPr>
-          <p:cNvPr id="21" name="Text 19"/>
-          <p:cNvSpPr txBox="1"/>
-          <p:nvPr/>
-        </p:nvSpPr>
-        <p:spPr>
-          <a:xfrm>
-            <a:off x="6949440" y="2148840"/>
-            <a:ext cx="365760" cy="365760"/>
+          <a:effectLst>
+            <a:outerShdw sx="100000" sy="100000" kx="0" ky="0" algn="bl" rotWithShape="0" blurRad="76200" dist="25400" dir="5400000">
+              <a:srgbClr val="283618">
+                <a:alpha val="8000"/>
+              </a:srgbClr>
+            </a:outerShdw>
+          </a:effectLst>
+        </p:spPr>
+      </p:sp>
+      <p:sp>
+        <p:nvSpPr>
+          <p:cNvPr id="20" name="Text 18"/>
+          <p:cNvSpPr txBox="1"/>
+          <p:nvPr/>
+        </p:nvSpPr>
+        <p:spPr>
+          <a:xfrm>
+            <a:off x="3447288" y="3337560"/>
+            <a:ext cx="2286000" cy="365760"/>
           </a:xfrm>
           <a:prstGeom prst="rect">
             <a:avLst/>
@@ -4204,50 +3891,11 @@
           <a:bodyPr wrap="square" lIns="0" tIns="0" rIns="0" bIns="0" rtlCol="0" anchor="ctr"/>
           <a:lstStyle/>
           <a:p>
-            <a:pPr algn="ctr" indent="0" marL="0">
-              <a:buNone/>
-            </a:pPr>
-            <a:r>
-              <a:rPr lang="en-US" sz="880" b="1" dirty="0">
-                <a:solidFill>
-                  <a:srgbClr val="FEFAE0"/>
-                </a:solidFill>
-                <a:latin typeface="Cambria" pitchFamily="34" charset="0"/>
-                <a:ea typeface="Cambria" pitchFamily="34" charset="-122"/>
-                <a:cs typeface="Cambria" pitchFamily="34" charset="-120"/>
-              </a:rPr>
-              <a:t>4</a:t>
-            </a:r>
-            <a:endParaRPr lang="en-US" sz="880" dirty="0"/>
-          </a:p>
-        </p:txBody>
-      </p:sp>
-      <p:sp>
-        <p:nvSpPr>
-          <p:cNvPr id="22" name="Text 20"/>
-          <p:cNvSpPr txBox="1"/>
-          <p:nvPr/>
-        </p:nvSpPr>
-        <p:spPr>
-          <a:xfrm>
-            <a:off x="6766560" y="2651760"/>
-            <a:ext cx="1920240" cy="320040"/>
-          </a:xfrm>
-          <a:prstGeom prst="rect">
-            <a:avLst/>
-          </a:prstGeom>
-          <a:noFill/>
-          <a:ln/>
-        </p:spPr>
-        <p:txBody>
-          <a:bodyPr wrap="square" lIns="0" tIns="0" rIns="0" bIns="0" rtlCol="0" anchor="ctr"/>
-          <a:lstStyle/>
-          <a:p>
-            <a:pPr indent="0" marL="0">
-              <a:buNone/>
-            </a:pPr>
-            <a:r>
-              <a:rPr lang="en-US" sz="1300" b="1" dirty="0">
+            <a:pPr indent="0" marL="0">
+              <a:buNone/>
+            </a:pPr>
+            <a:r>
+              <a:rPr lang="en-US" sz="1400" b="1" dirty="0">
                 <a:solidFill>
                   <a:srgbClr val="BC6C25"/>
                 </a:solidFill>
@@ -4255,22 +3903,22 @@
                 <a:ea typeface="Calibri" pitchFamily="34" charset="-122"/>
                 <a:cs typeface="Calibri" pitchFamily="34" charset="-120"/>
               </a:rPr>
-              <a:t>Mês 2–3</a:t>
-            </a:r>
-            <a:endParaRPr lang="en-US" sz="1300" dirty="0"/>
-          </a:p>
-        </p:txBody>
-      </p:sp>
-      <p:sp>
-        <p:nvSpPr>
-          <p:cNvPr id="23" name="Text 21"/>
-          <p:cNvSpPr txBox="1"/>
-          <p:nvPr/>
-        </p:nvSpPr>
-        <p:spPr>
-          <a:xfrm>
-            <a:off x="6766560" y="2971800"/>
-            <a:ext cx="1920240" cy="1188720"/>
+              <a:t>Aparelho avaria</a:t>
+            </a:r>
+            <a:endParaRPr lang="en-US" sz="1400" dirty="0"/>
+          </a:p>
+        </p:txBody>
+      </p:sp>
+      <p:sp>
+        <p:nvSpPr>
+          <p:cNvPr id="21" name="Text 19"/>
+          <p:cNvSpPr txBox="1"/>
+          <p:nvPr/>
+        </p:nvSpPr>
+        <p:spPr>
+          <a:xfrm>
+            <a:off x="3447288" y="3703320"/>
+            <a:ext cx="2286000" cy="731520"/>
           </a:xfrm>
           <a:prstGeom prst="rect">
             <a:avLst/>
@@ -4286,7 +3934,7 @@
               <a:buNone/>
             </a:pPr>
             <a:r>
-              <a:rPr lang="en-US" sz="1300" dirty="0">
+              <a:rPr lang="en-US" sz="1200" dirty="0">
                 <a:solidFill>
                   <a:srgbClr val="283618"/>
                 </a:solidFill>
@@ -4294,22 +3942,56 @@
                 <a:ea typeface="Calibri" pitchFamily="34" charset="-122"/>
                 <a:cs typeface="Calibri" pitchFamily="34" charset="-120"/>
               </a:rPr>
-              <a:t>3 instalações-piloto com testemunhos</a:t>
-            </a:r>
-            <a:endParaRPr lang="en-US" sz="1300" dirty="0"/>
-          </a:p>
-        </p:txBody>
-      </p:sp>
-      <p:sp>
-        <p:nvSpPr>
-          <p:cNvPr id="24" name="Text 22"/>
-          <p:cNvSpPr txBox="1"/>
-          <p:nvPr/>
-        </p:nvSpPr>
-        <p:spPr>
-          <a:xfrm>
-            <a:off x="457200" y="4297680"/>
-            <a:ext cx="8229600" cy="411480"/>
+              <a:t>Testado na bancada; stock de substituição; garantia da empresa</a:t>
+            </a:r>
+            <a:endParaRPr lang="en-US" sz="1200" dirty="0"/>
+          </a:p>
+        </p:txBody>
+      </p:sp>
+      <p:sp>
+        <p:nvSpPr>
+          <p:cNvPr id="22" name="Shape 20"/>
+          <p:cNvSpPr/>
+          <p:nvPr/>
+        </p:nvSpPr>
+        <p:spPr>
+          <a:xfrm>
+            <a:off x="6071616" y="3200400"/>
+            <a:ext cx="2624328" cy="1298448"/>
+          </a:xfrm>
+          <a:prstGeom prst="roundRect">
+            <a:avLst>
+              <a:gd name="adj" fmla="val 8451"/>
+            </a:avLst>
+          </a:prstGeom>
+          <a:solidFill>
+            <a:srgbClr val="FFFFFF"/>
+          </a:solidFill>
+          <a:ln w="9525">
+            <a:solidFill>
+              <a:srgbClr val="E6E0BF"/>
+            </a:solidFill>
+            <a:prstDash val="solid"/>
+          </a:ln>
+          <a:effectLst>
+            <a:outerShdw sx="100000" sy="100000" kx="0" ky="0" algn="bl" rotWithShape="0" blurRad="76200" dist="25400" dir="5400000">
+              <a:srgbClr val="283618">
+                <a:alpha val="8000"/>
+              </a:srgbClr>
+            </a:outerShdw>
+          </a:effectLst>
+        </p:spPr>
+      </p:sp>
+      <p:sp>
+        <p:nvSpPr>
+          <p:cNvPr id="23" name="Text 21"/>
+          <p:cNvSpPr txBox="1"/>
+          <p:nvPr/>
+        </p:nvSpPr>
+        <p:spPr>
+          <a:xfrm>
+            <a:off x="6254496" y="3337560"/>
+            <a:ext cx="2286000" cy="365760"/>
           </a:xfrm>
           <a:prstGeom prst="rect">
             <a:avLst/>
@@ -4325,17 +4007,56 @@
               <a:buNone/>
             </a:pPr>
             <a:r>
-              <a:rPr lang="en-US" sz="1500" b="1" dirty="0">
-                <a:solidFill>
-                  <a:srgbClr val="606C38"/>
+              <a:rPr lang="en-US" sz="1400" b="1" dirty="0">
+                <a:solidFill>
+                  <a:srgbClr val="BC6C25"/>
                 </a:solidFill>
                 <a:latin typeface="Calibri" pitchFamily="34" charset="0"/>
                 <a:ea typeface="Calibri" pitchFamily="34" charset="-122"/>
                 <a:cs typeface="Calibri" pitchFamily="34" charset="-120"/>
               </a:rPr>
-              <a:t>Primeira ação: decidir os sócios e criar a empresa (Empresa na Hora).</a:t>
-            </a:r>
-            <a:endParaRPr lang="en-US" sz="1500" dirty="0"/>
+              <a:t>Obra mal feita</a:t>
+            </a:r>
+            <a:endParaRPr lang="en-US" sz="1400" dirty="0"/>
+          </a:p>
+        </p:txBody>
+      </p:sp>
+      <p:sp>
+        <p:nvSpPr>
+          <p:cNvPr id="24" name="Text 22"/>
+          <p:cNvSpPr txBox="1"/>
+          <p:nvPr/>
+        </p:nvSpPr>
+        <p:spPr>
+          <a:xfrm>
+            <a:off x="6254496" y="3703320"/>
+            <a:ext cx="2286000" cy="731520"/>
+          </a:xfrm>
+          <a:prstGeom prst="rect">
+            <a:avLst/>
+          </a:prstGeom>
+          <a:noFill/>
+          <a:ln/>
+        </p:spPr>
+        <p:txBody>
+          <a:bodyPr wrap="square" lIns="0" tIns="0" rIns="0" bIns="0" rtlCol="0" anchor="t"/>
+          <a:lstStyle/>
+          <a:p>
+            <a:pPr indent="0" marL="0">
+              <a:buNone/>
+            </a:pPr>
+            <a:r>
+              <a:rPr lang="en-US" sz="1200" dirty="0">
+                <a:solidFill>
+                  <a:srgbClr val="283618"/>
+                </a:solidFill>
+                <a:latin typeface="Calibri" pitchFamily="34" charset="0"/>
+                <a:ea typeface="Calibri" pitchFamily="34" charset="-122"/>
+                <a:cs typeface="Calibri" pitchFamily="34" charset="-120"/>
+              </a:rPr>
+              <a:t>Ensaios, fotografias, revisão por outro eletricista, seguro</a:t>
+            </a:r>
+            <a:endParaRPr lang="en-US" sz="1200" dirty="0"/>
           </a:p>
         </p:txBody>
       </p:sp>
@@ -4350,6 +4071,849 @@
 <file path=ppt/slides/slide12.xml><?xml version="1.0" encoding="utf-8"?>
 <p:sld xmlns:a="http://schemas.openxmlformats.org/drawingml/2006/main" xmlns:r="http://schemas.openxmlformats.org/officeDocument/2006/relationships" xmlns:p="http://schemas.openxmlformats.org/presentationml/2006/main">
   <p:cSld name="Slide 12">
+    <p:bg>
+      <p:bgPr>
+        <a:solidFill>
+          <a:srgbClr val="FEFAE0"/>
+        </a:solidFill>
+      </p:bgPr>
+    </p:bg>
+    <p:spTree>
+      <p:nvGrpSpPr>
+        <p:cNvPr id="1" name=""/>
+        <p:cNvGrpSpPr/>
+        <p:nvPr/>
+      </p:nvGrpSpPr>
+      <p:grpSpPr>
+        <a:xfrm>
+          <a:off x="0" y="0"/>
+          <a:ext cx="0" cy="0"/>
+          <a:chOff x="0" y="0"/>
+          <a:chExt cx="0" cy="0"/>
+        </a:xfrm>
+      </p:grpSpPr>
+      <p:sp>
+        <p:nvSpPr>
+          <p:cNvPr id="2" name="Text 0"/>
+          <p:cNvSpPr txBox="1"/>
+          <p:nvPr/>
+        </p:nvSpPr>
+        <p:spPr>
+          <a:xfrm>
+            <a:off x="457200" y="274320"/>
+            <a:ext cx="5486400" cy="274320"/>
+          </a:xfrm>
+          <a:prstGeom prst="rect">
+            <a:avLst/>
+          </a:prstGeom>
+          <a:noFill/>
+          <a:ln/>
+        </p:spPr>
+        <p:txBody>
+          <a:bodyPr wrap="square" lIns="0" tIns="0" rIns="0" bIns="0" rtlCol="0" anchor="ctr"/>
+          <a:lstStyle/>
+          <a:p>
+            <a:pPr indent="0" marL="0">
+              <a:buNone/>
+            </a:pPr>
+            <a:r>
+              <a:rPr lang="en-US" sz="1100" b="1" spc="300" kern="0" dirty="0">
+                <a:solidFill>
+                  <a:srgbClr val="BC6C25"/>
+                </a:solidFill>
+                <a:latin typeface="Calibri" pitchFamily="34" charset="0"/>
+                <a:ea typeface="Calibri" pitchFamily="34" charset="-122"/>
+                <a:cs typeface="Calibri" pitchFamily="34" charset="-120"/>
+              </a:rPr>
+              <a:t>FASE 3 · NEGÓCIO</a:t>
+            </a:r>
+            <a:endParaRPr lang="en-US" sz="1100" dirty="0"/>
+          </a:p>
+        </p:txBody>
+      </p:sp>
+      <p:sp>
+        <p:nvSpPr>
+          <p:cNvPr id="3" name="Text 1"/>
+          <p:cNvSpPr txBox="1"/>
+          <p:nvPr/>
+        </p:nvSpPr>
+        <p:spPr>
+          <a:xfrm>
+            <a:off x="457200" y="502920"/>
+            <a:ext cx="8229600" cy="640080"/>
+          </a:xfrm>
+          <a:prstGeom prst="rect">
+            <a:avLst/>
+          </a:prstGeom>
+          <a:noFill/>
+          <a:ln/>
+        </p:spPr>
+        <p:txBody>
+          <a:bodyPr wrap="square" lIns="0" tIns="0" rIns="0" bIns="0" rtlCol="0" anchor="ctr"/>
+          <a:lstStyle/>
+          <a:p>
+            <a:pPr indent="0" marL="0">
+              <a:buNone/>
+            </a:pPr>
+            <a:r>
+              <a:rPr lang="en-US" sz="3000" b="1" dirty="0">
+                <a:solidFill>
+                  <a:srgbClr val="283618"/>
+                </a:solidFill>
+                <a:latin typeface="Cambria" pitchFamily="34" charset="0"/>
+                <a:ea typeface="Cambria" pitchFamily="34" charset="-122"/>
+                <a:cs typeface="Cambria" pitchFamily="34" charset="-120"/>
+              </a:rPr>
+              <a:t>Qual a primeira ação a realizar?</a:t>
+            </a:r>
+            <a:endParaRPr lang="en-US" sz="3000" dirty="0"/>
+          </a:p>
+        </p:txBody>
+      </p:sp>
+      <p:sp>
+        <p:nvSpPr>
+          <p:cNvPr id="4" name="Shape 2"/>
+          <p:cNvSpPr/>
+          <p:nvPr/>
+        </p:nvSpPr>
+        <p:spPr>
+          <a:xfrm>
+            <a:off x="457200" y="1188720"/>
+            <a:ext cx="329184" cy="329184"/>
+          </a:xfrm>
+          <a:prstGeom prst="ellipse">
+            <a:avLst/>
+          </a:prstGeom>
+          <a:solidFill>
+            <a:srgbClr val="BC6C25"/>
+          </a:solidFill>
+          <a:ln w="12700">
+            <a:solidFill>
+              <a:srgbClr val="BC6C25"/>
+            </a:solidFill>
+            <a:prstDash val="solid"/>
+          </a:ln>
+        </p:spPr>
+      </p:sp>
+      <p:sp>
+        <p:nvSpPr>
+          <p:cNvPr id="5" name="Text 3"/>
+          <p:cNvSpPr txBox="1"/>
+          <p:nvPr/>
+        </p:nvSpPr>
+        <p:spPr>
+          <a:xfrm>
+            <a:off x="457200" y="1188720"/>
+            <a:ext cx="329184" cy="329184"/>
+          </a:xfrm>
+          <a:prstGeom prst="rect">
+            <a:avLst/>
+          </a:prstGeom>
+          <a:noFill/>
+          <a:ln/>
+        </p:spPr>
+        <p:txBody>
+          <a:bodyPr wrap="square" lIns="0" tIns="0" rIns="0" bIns="0" rtlCol="0" anchor="ctr"/>
+          <a:lstStyle/>
+          <a:p>
+            <a:pPr algn="ctr" indent="0" marL="0">
+              <a:buNone/>
+            </a:pPr>
+            <a:r>
+              <a:rPr lang="en-US" sz="792" b="1" dirty="0">
+                <a:solidFill>
+                  <a:srgbClr val="FEFAE0"/>
+                </a:solidFill>
+                <a:latin typeface="Cambria" pitchFamily="34" charset="0"/>
+                <a:ea typeface="Cambria" pitchFamily="34" charset="-122"/>
+                <a:cs typeface="Cambria" pitchFamily="34" charset="-120"/>
+              </a:rPr>
+              <a:t>10</a:t>
+            </a:r>
+            <a:endParaRPr lang="en-US" sz="792" dirty="0"/>
+          </a:p>
+        </p:txBody>
+      </p:sp>
+      <p:sp>
+        <p:nvSpPr>
+          <p:cNvPr id="6" name="Text 4"/>
+          <p:cNvSpPr txBox="1"/>
+          <p:nvPr/>
+        </p:nvSpPr>
+        <p:spPr>
+          <a:xfrm>
+            <a:off x="896112" y="1188720"/>
+            <a:ext cx="7315200" cy="329184"/>
+          </a:xfrm>
+          <a:prstGeom prst="rect">
+            <a:avLst/>
+          </a:prstGeom>
+          <a:noFill/>
+          <a:ln/>
+        </p:spPr>
+        <p:txBody>
+          <a:bodyPr wrap="square" lIns="0" tIns="0" rIns="0" bIns="0" rtlCol="0" anchor="ctr"/>
+          <a:lstStyle/>
+          <a:p>
+            <a:pPr indent="0" marL="0">
+              <a:buNone/>
+            </a:pPr>
+            <a:r>
+              <a:rPr lang="en-US" sz="1400" i="1" dirty="0">
+                <a:solidFill>
+                  <a:srgbClr val="5C6446"/>
+                </a:solidFill>
+                <a:latin typeface="Calibri" pitchFamily="34" charset="0"/>
+                <a:ea typeface="Calibri" pitchFamily="34" charset="-122"/>
+                <a:cs typeface="Calibri" pitchFamily="34" charset="-120"/>
+              </a:rPr>
+              <a:t>Da preparação à primeira obra</a:t>
+            </a:r>
+            <a:endParaRPr lang="en-US" sz="1400" dirty="0"/>
+          </a:p>
+        </p:txBody>
+      </p:sp>
+      <p:sp>
+        <p:nvSpPr>
+          <p:cNvPr id="7" name="Shape 5"/>
+          <p:cNvSpPr/>
+          <p:nvPr/>
+        </p:nvSpPr>
+        <p:spPr>
+          <a:xfrm>
+            <a:off x="822960" y="2331720"/>
+            <a:ext cx="7498080" cy="0"/>
+          </a:xfrm>
+          <a:prstGeom prst="line">
+            <a:avLst/>
+          </a:prstGeom>
+          <a:noFill/>
+          <a:ln w="25400">
+            <a:solidFill>
+              <a:srgbClr val="DDA15E"/>
+            </a:solidFill>
+            <a:prstDash val="solid"/>
+          </a:ln>
+        </p:spPr>
+      </p:sp>
+      <p:sp>
+        <p:nvSpPr>
+          <p:cNvPr id="8" name="Shape 6"/>
+          <p:cNvSpPr/>
+          <p:nvPr/>
+        </p:nvSpPr>
+        <p:spPr>
+          <a:xfrm>
+            <a:off x="640080" y="2148840"/>
+            <a:ext cx="365760" cy="365760"/>
+          </a:xfrm>
+          <a:prstGeom prst="ellipse">
+            <a:avLst/>
+          </a:prstGeom>
+          <a:solidFill>
+            <a:srgbClr val="BC6C25"/>
+          </a:solidFill>
+          <a:ln w="12700">
+            <a:solidFill>
+              <a:srgbClr val="BC6C25"/>
+            </a:solidFill>
+            <a:prstDash val="solid"/>
+          </a:ln>
+        </p:spPr>
+      </p:sp>
+      <p:sp>
+        <p:nvSpPr>
+          <p:cNvPr id="9" name="Text 7"/>
+          <p:cNvSpPr txBox="1"/>
+          <p:nvPr/>
+        </p:nvSpPr>
+        <p:spPr>
+          <a:xfrm>
+            <a:off x="640080" y="2148840"/>
+            <a:ext cx="365760" cy="365760"/>
+          </a:xfrm>
+          <a:prstGeom prst="rect">
+            <a:avLst/>
+          </a:prstGeom>
+          <a:noFill/>
+          <a:ln/>
+        </p:spPr>
+        <p:txBody>
+          <a:bodyPr wrap="square" lIns="0" tIns="0" rIns="0" bIns="0" rtlCol="0" anchor="ctr"/>
+          <a:lstStyle/>
+          <a:p>
+            <a:pPr algn="ctr" indent="0" marL="0">
+              <a:buNone/>
+            </a:pPr>
+            <a:r>
+              <a:rPr lang="en-US" sz="880" b="1" dirty="0">
+                <a:solidFill>
+                  <a:srgbClr val="FEFAE0"/>
+                </a:solidFill>
+                <a:latin typeface="Cambria" pitchFamily="34" charset="0"/>
+                <a:ea typeface="Cambria" pitchFamily="34" charset="-122"/>
+                <a:cs typeface="Cambria" pitchFamily="34" charset="-120"/>
+              </a:rPr>
+              <a:t>1</a:t>
+            </a:r>
+            <a:endParaRPr lang="en-US" sz="880" dirty="0"/>
+          </a:p>
+        </p:txBody>
+      </p:sp>
+      <p:sp>
+        <p:nvSpPr>
+          <p:cNvPr id="10" name="Text 8"/>
+          <p:cNvSpPr txBox="1"/>
+          <p:nvPr/>
+        </p:nvSpPr>
+        <p:spPr>
+          <a:xfrm>
+            <a:off x="457200" y="2651760"/>
+            <a:ext cx="1920240" cy="320040"/>
+          </a:xfrm>
+          <a:prstGeom prst="rect">
+            <a:avLst/>
+          </a:prstGeom>
+          <a:noFill/>
+          <a:ln/>
+        </p:spPr>
+        <p:txBody>
+          <a:bodyPr wrap="square" lIns="0" tIns="0" rIns="0" bIns="0" rtlCol="0" anchor="ctr"/>
+          <a:lstStyle/>
+          <a:p>
+            <a:pPr indent="0" marL="0">
+              <a:buNone/>
+            </a:pPr>
+            <a:r>
+              <a:rPr lang="en-US" sz="1300" b="1" dirty="0">
+                <a:solidFill>
+                  <a:srgbClr val="BC6C25"/>
+                </a:solidFill>
+                <a:latin typeface="Calibri" pitchFamily="34" charset="0"/>
+                <a:ea typeface="Calibri" pitchFamily="34" charset="-122"/>
+                <a:cs typeface="Calibri" pitchFamily="34" charset="-120"/>
+              </a:rPr>
+              <a:t>Até dez. 2026</a:t>
+            </a:r>
+            <a:endParaRPr lang="en-US" sz="1300" dirty="0"/>
+          </a:p>
+        </p:txBody>
+      </p:sp>
+      <p:sp>
+        <p:nvSpPr>
+          <p:cNvPr id="11" name="Text 9"/>
+          <p:cNvSpPr txBox="1"/>
+          <p:nvPr/>
+        </p:nvSpPr>
+        <p:spPr>
+          <a:xfrm>
+            <a:off x="457200" y="2971800"/>
+            <a:ext cx="1920240" cy="1188720"/>
+          </a:xfrm>
+          <a:prstGeom prst="rect">
+            <a:avLst/>
+          </a:prstGeom>
+          <a:noFill/>
+          <a:ln/>
+        </p:spPr>
+        <p:txBody>
+          <a:bodyPr wrap="square" lIns="0" tIns="0" rIns="0" bIns="0" rtlCol="0" anchor="t"/>
+          <a:lstStyle/>
+          <a:p>
+            <a:pPr indent="0" marL="0">
+              <a:buNone/>
+            </a:pPr>
+            <a:r>
+              <a:rPr lang="en-US" sz="1300" dirty="0">
+                <a:solidFill>
+                  <a:srgbClr val="283618"/>
+                </a:solidFill>
+                <a:latin typeface="Calibri" pitchFamily="34" charset="0"/>
+                <a:ea typeface="Calibri" pitchFamily="34" charset="-122"/>
+                <a:cs typeface="Calibri" pitchFamily="34" charset="-120"/>
+              </a:rPr>
+              <a:t>Montar a bancada e testar os aparelhos</a:t>
+            </a:r>
+            <a:endParaRPr lang="en-US" sz="1300" dirty="0"/>
+          </a:p>
+        </p:txBody>
+      </p:sp>
+      <p:sp>
+        <p:nvSpPr>
+          <p:cNvPr id="12" name="Shape 10"/>
+          <p:cNvSpPr/>
+          <p:nvPr/>
+        </p:nvSpPr>
+        <p:spPr>
+          <a:xfrm>
+            <a:off x="2743200" y="2148840"/>
+            <a:ext cx="365760" cy="365760"/>
+          </a:xfrm>
+          <a:prstGeom prst="ellipse">
+            <a:avLst/>
+          </a:prstGeom>
+          <a:solidFill>
+            <a:srgbClr val="606C38"/>
+          </a:solidFill>
+          <a:ln w="12700">
+            <a:solidFill>
+              <a:srgbClr val="606C38"/>
+            </a:solidFill>
+            <a:prstDash val="solid"/>
+          </a:ln>
+        </p:spPr>
+      </p:sp>
+      <p:sp>
+        <p:nvSpPr>
+          <p:cNvPr id="13" name="Text 11"/>
+          <p:cNvSpPr txBox="1"/>
+          <p:nvPr/>
+        </p:nvSpPr>
+        <p:spPr>
+          <a:xfrm>
+            <a:off x="2743200" y="2148840"/>
+            <a:ext cx="365760" cy="365760"/>
+          </a:xfrm>
+          <a:prstGeom prst="rect">
+            <a:avLst/>
+          </a:prstGeom>
+          <a:noFill/>
+          <a:ln/>
+        </p:spPr>
+        <p:txBody>
+          <a:bodyPr wrap="square" lIns="0" tIns="0" rIns="0" bIns="0" rtlCol="0" anchor="ctr"/>
+          <a:lstStyle/>
+          <a:p>
+            <a:pPr algn="ctr" indent="0" marL="0">
+              <a:buNone/>
+            </a:pPr>
+            <a:r>
+              <a:rPr lang="en-US" sz="880" b="1" dirty="0">
+                <a:solidFill>
+                  <a:srgbClr val="FEFAE0"/>
+                </a:solidFill>
+                <a:latin typeface="Cambria" pitchFamily="34" charset="0"/>
+                <a:ea typeface="Cambria" pitchFamily="34" charset="-122"/>
+                <a:cs typeface="Cambria" pitchFamily="34" charset="-120"/>
+              </a:rPr>
+              <a:t>2</a:t>
+            </a:r>
+            <a:endParaRPr lang="en-US" sz="880" dirty="0"/>
+          </a:p>
+        </p:txBody>
+      </p:sp>
+      <p:sp>
+        <p:nvSpPr>
+          <p:cNvPr id="14" name="Text 12"/>
+          <p:cNvSpPr txBox="1"/>
+          <p:nvPr/>
+        </p:nvSpPr>
+        <p:spPr>
+          <a:xfrm>
+            <a:off x="2560320" y="2651760"/>
+            <a:ext cx="1920240" cy="320040"/>
+          </a:xfrm>
+          <a:prstGeom prst="rect">
+            <a:avLst/>
+          </a:prstGeom>
+          <a:noFill/>
+          <a:ln/>
+        </p:spPr>
+        <p:txBody>
+          <a:bodyPr wrap="square" lIns="0" tIns="0" rIns="0" bIns="0" rtlCol="0" anchor="ctr"/>
+          <a:lstStyle/>
+          <a:p>
+            <a:pPr indent="0" marL="0">
+              <a:buNone/>
+            </a:pPr>
+            <a:r>
+              <a:rPr lang="en-US" sz="1300" b="1" dirty="0">
+                <a:solidFill>
+                  <a:srgbClr val="BC6C25"/>
+                </a:solidFill>
+                <a:latin typeface="Calibri" pitchFamily="34" charset="0"/>
+                <a:ea typeface="Calibri" pitchFamily="34" charset="-122"/>
+                <a:cs typeface="Calibri" pitchFamily="34" charset="-120"/>
+              </a:rPr>
+              <a:t>Até mar. 2027</a:t>
+            </a:r>
+            <a:endParaRPr lang="en-US" sz="1300" dirty="0"/>
+          </a:p>
+        </p:txBody>
+      </p:sp>
+      <p:sp>
+        <p:nvSpPr>
+          <p:cNvPr id="15" name="Text 13"/>
+          <p:cNvSpPr txBox="1"/>
+          <p:nvPr/>
+        </p:nvSpPr>
+        <p:spPr>
+          <a:xfrm>
+            <a:off x="2560320" y="2971800"/>
+            <a:ext cx="1920240" cy="1188720"/>
+          </a:xfrm>
+          <a:prstGeom prst="rect">
+            <a:avLst/>
+          </a:prstGeom>
+          <a:noFill/>
+          <a:ln/>
+        </p:spPr>
+        <p:txBody>
+          <a:bodyPr wrap="square" lIns="0" tIns="0" rIns="0" bIns="0" rtlCol="0" anchor="t"/>
+          <a:lstStyle/>
+          <a:p>
+            <a:pPr indent="0" marL="0">
+              <a:buNone/>
+            </a:pPr>
+            <a:r>
+              <a:rPr lang="en-US" sz="1300" dirty="0">
+                <a:solidFill>
+                  <a:srgbClr val="283618"/>
+                </a:solidFill>
+                <a:latin typeface="Calibri" pitchFamily="34" charset="0"/>
+                <a:ea typeface="Calibri" pitchFamily="34" charset="-122"/>
+                <a:cs typeface="Calibri" pitchFamily="34" charset="-120"/>
+              </a:rPr>
+              <a:t>Documentos legais, contrato de parceiro, CAE 43210</a:t>
+            </a:r>
+            <a:endParaRPr lang="en-US" sz="1300" dirty="0"/>
+          </a:p>
+        </p:txBody>
+      </p:sp>
+      <p:sp>
+        <p:nvSpPr>
+          <p:cNvPr id="16" name="Shape 14"/>
+          <p:cNvSpPr/>
+          <p:nvPr/>
+        </p:nvSpPr>
+        <p:spPr>
+          <a:xfrm>
+            <a:off x="4846320" y="2148840"/>
+            <a:ext cx="365760" cy="365760"/>
+          </a:xfrm>
+          <a:prstGeom prst="ellipse">
+            <a:avLst/>
+          </a:prstGeom>
+          <a:solidFill>
+            <a:srgbClr val="606C38"/>
+          </a:solidFill>
+          <a:ln w="12700">
+            <a:solidFill>
+              <a:srgbClr val="606C38"/>
+            </a:solidFill>
+            <a:prstDash val="solid"/>
+          </a:ln>
+        </p:spPr>
+      </p:sp>
+      <p:sp>
+        <p:nvSpPr>
+          <p:cNvPr id="17" name="Text 15"/>
+          <p:cNvSpPr txBox="1"/>
+          <p:nvPr/>
+        </p:nvSpPr>
+        <p:spPr>
+          <a:xfrm>
+            <a:off x="4846320" y="2148840"/>
+            <a:ext cx="365760" cy="365760"/>
+          </a:xfrm>
+          <a:prstGeom prst="rect">
+            <a:avLst/>
+          </a:prstGeom>
+          <a:noFill/>
+          <a:ln/>
+        </p:spPr>
+        <p:txBody>
+          <a:bodyPr wrap="square" lIns="0" tIns="0" rIns="0" bIns="0" rtlCol="0" anchor="ctr"/>
+          <a:lstStyle/>
+          <a:p>
+            <a:pPr algn="ctr" indent="0" marL="0">
+              <a:buNone/>
+            </a:pPr>
+            <a:r>
+              <a:rPr lang="en-US" sz="880" b="1" dirty="0">
+                <a:solidFill>
+                  <a:srgbClr val="FEFAE0"/>
+                </a:solidFill>
+                <a:latin typeface="Cambria" pitchFamily="34" charset="0"/>
+                <a:ea typeface="Cambria" pitchFamily="34" charset="-122"/>
+                <a:cs typeface="Cambria" pitchFamily="34" charset="-120"/>
+              </a:rPr>
+              <a:t>3</a:t>
+            </a:r>
+            <a:endParaRPr lang="en-US" sz="880" dirty="0"/>
+          </a:p>
+        </p:txBody>
+      </p:sp>
+      <p:sp>
+        <p:nvSpPr>
+          <p:cNvPr id="18" name="Text 16"/>
+          <p:cNvSpPr txBox="1"/>
+          <p:nvPr/>
+        </p:nvSpPr>
+        <p:spPr>
+          <a:xfrm>
+            <a:off x="4663440" y="2651760"/>
+            <a:ext cx="1920240" cy="320040"/>
+          </a:xfrm>
+          <a:prstGeom prst="rect">
+            <a:avLst/>
+          </a:prstGeom>
+          <a:noFill/>
+          <a:ln/>
+        </p:spPr>
+        <p:txBody>
+          <a:bodyPr wrap="square" lIns="0" tIns="0" rIns="0" bIns="0" rtlCol="0" anchor="ctr"/>
+          <a:lstStyle/>
+          <a:p>
+            <a:pPr indent="0" marL="0">
+              <a:buNone/>
+            </a:pPr>
+            <a:r>
+              <a:rPr lang="en-US" sz="1300" b="1" dirty="0">
+                <a:solidFill>
+                  <a:srgbClr val="BC6C25"/>
+                </a:solidFill>
+                <a:latin typeface="Calibri" pitchFamily="34" charset="0"/>
+                <a:ea typeface="Calibri" pitchFamily="34" charset="-122"/>
+                <a:cs typeface="Calibri" pitchFamily="34" charset="-120"/>
+              </a:rPr>
+              <a:t>Mai. a ago. 2027</a:t>
+            </a:r>
+            <a:endParaRPr lang="en-US" sz="1300" dirty="0"/>
+          </a:p>
+        </p:txBody>
+      </p:sp>
+      <p:sp>
+        <p:nvSpPr>
+          <p:cNvPr id="19" name="Text 17"/>
+          <p:cNvSpPr txBox="1"/>
+          <p:nvPr/>
+        </p:nvSpPr>
+        <p:spPr>
+          <a:xfrm>
+            <a:off x="4663440" y="2971800"/>
+            <a:ext cx="1920240" cy="1188720"/>
+          </a:xfrm>
+          <a:prstGeom prst="rect">
+            <a:avLst/>
+          </a:prstGeom>
+          <a:noFill/>
+          <a:ln/>
+        </p:spPr>
+        <p:txBody>
+          <a:bodyPr wrap="square" lIns="0" tIns="0" rIns="0" bIns="0" rtlCol="0" anchor="t"/>
+          <a:lstStyle/>
+          <a:p>
+            <a:pPr indent="0" marL="0">
+              <a:buNone/>
+            </a:pPr>
+            <a:r>
+              <a:rPr lang="en-US" sz="1300" dirty="0">
+                <a:solidFill>
+                  <a:srgbClr val="283618"/>
+                </a:solidFill>
+                <a:latin typeface="Calibri" pitchFamily="34" charset="0"/>
+                <a:ea typeface="Calibri" pitchFamily="34" charset="-122"/>
+                <a:cs typeface="Calibri" pitchFamily="34" charset="-120"/>
+              </a:rPr>
+              <a:t>Treinar os 4 parceiros; seguro; fim do curso</a:t>
+            </a:r>
+            <a:endParaRPr lang="en-US" sz="1300" dirty="0"/>
+          </a:p>
+        </p:txBody>
+      </p:sp>
+      <p:sp>
+        <p:nvSpPr>
+          <p:cNvPr id="20" name="Shape 18"/>
+          <p:cNvSpPr/>
+          <p:nvPr/>
+        </p:nvSpPr>
+        <p:spPr>
+          <a:xfrm>
+            <a:off x="6949440" y="2148840"/>
+            <a:ext cx="365760" cy="365760"/>
+          </a:xfrm>
+          <a:prstGeom prst="ellipse">
+            <a:avLst/>
+          </a:prstGeom>
+          <a:solidFill>
+            <a:srgbClr val="606C38"/>
+          </a:solidFill>
+          <a:ln w="12700">
+            <a:solidFill>
+              <a:srgbClr val="606C38"/>
+            </a:solidFill>
+            <a:prstDash val="solid"/>
+          </a:ln>
+        </p:spPr>
+      </p:sp>
+      <p:sp>
+        <p:nvSpPr>
+          <p:cNvPr id="21" name="Text 19"/>
+          <p:cNvSpPr txBox="1"/>
+          <p:nvPr/>
+        </p:nvSpPr>
+        <p:spPr>
+          <a:xfrm>
+            <a:off x="6949440" y="2148840"/>
+            <a:ext cx="365760" cy="365760"/>
+          </a:xfrm>
+          <a:prstGeom prst="rect">
+            <a:avLst/>
+          </a:prstGeom>
+          <a:noFill/>
+          <a:ln/>
+        </p:spPr>
+        <p:txBody>
+          <a:bodyPr wrap="square" lIns="0" tIns="0" rIns="0" bIns="0" rtlCol="0" anchor="ctr"/>
+          <a:lstStyle/>
+          <a:p>
+            <a:pPr algn="ctr" indent="0" marL="0">
+              <a:buNone/>
+            </a:pPr>
+            <a:r>
+              <a:rPr lang="en-US" sz="880" b="1" dirty="0">
+                <a:solidFill>
+                  <a:srgbClr val="FEFAE0"/>
+                </a:solidFill>
+                <a:latin typeface="Cambria" pitchFamily="34" charset="0"/>
+                <a:ea typeface="Cambria" pitchFamily="34" charset="-122"/>
+                <a:cs typeface="Cambria" pitchFamily="34" charset="-120"/>
+              </a:rPr>
+              <a:t>4</a:t>
+            </a:r>
+            <a:endParaRPr lang="en-US" sz="880" dirty="0"/>
+          </a:p>
+        </p:txBody>
+      </p:sp>
+      <p:sp>
+        <p:nvSpPr>
+          <p:cNvPr id="22" name="Text 20"/>
+          <p:cNvSpPr txBox="1"/>
+          <p:nvPr/>
+        </p:nvSpPr>
+        <p:spPr>
+          <a:xfrm>
+            <a:off x="6766560" y="2651760"/>
+            <a:ext cx="1920240" cy="320040"/>
+          </a:xfrm>
+          <a:prstGeom prst="rect">
+            <a:avLst/>
+          </a:prstGeom>
+          <a:noFill/>
+          <a:ln/>
+        </p:spPr>
+        <p:txBody>
+          <a:bodyPr wrap="square" lIns="0" tIns="0" rIns="0" bIns="0" rtlCol="0" anchor="ctr"/>
+          <a:lstStyle/>
+          <a:p>
+            <a:pPr indent="0" marL="0">
+              <a:buNone/>
+            </a:pPr>
+            <a:r>
+              <a:rPr lang="en-US" sz="1300" b="1" dirty="0">
+                <a:solidFill>
+                  <a:srgbClr val="BC6C25"/>
+                </a:solidFill>
+                <a:latin typeface="Calibri" pitchFamily="34" charset="0"/>
+                <a:ea typeface="Calibri" pitchFamily="34" charset="-122"/>
+                <a:cs typeface="Calibri" pitchFamily="34" charset="-120"/>
+              </a:rPr>
+              <a:t>Set. 2027</a:t>
+            </a:r>
+            <a:endParaRPr lang="en-US" sz="1300" dirty="0"/>
+          </a:p>
+        </p:txBody>
+      </p:sp>
+      <p:sp>
+        <p:nvSpPr>
+          <p:cNvPr id="23" name="Text 21"/>
+          <p:cNvSpPr txBox="1"/>
+          <p:nvPr/>
+        </p:nvSpPr>
+        <p:spPr>
+          <a:xfrm>
+            <a:off x="6766560" y="2971800"/>
+            <a:ext cx="1920240" cy="1188720"/>
+          </a:xfrm>
+          <a:prstGeom prst="rect">
+            <a:avLst/>
+          </a:prstGeom>
+          <a:noFill/>
+          <a:ln/>
+        </p:spPr>
+        <p:txBody>
+          <a:bodyPr wrap="square" lIns="0" tIns="0" rIns="0" bIns="0" rtlCol="0" anchor="t"/>
+          <a:lstStyle/>
+          <a:p>
+            <a:pPr indent="0" marL="0">
+              <a:buNone/>
+            </a:pPr>
+            <a:r>
+              <a:rPr lang="en-US" sz="1300" dirty="0">
+                <a:solidFill>
+                  <a:srgbClr val="283618"/>
+                </a:solidFill>
+                <a:latin typeface="Calibri" pitchFamily="34" charset="0"/>
+                <a:ea typeface="Calibri" pitchFamily="34" charset="-122"/>
+                <a:cs typeface="Calibri" pitchFamily="34" charset="-120"/>
+              </a:rPr>
+              <a:t>Lançamento e primeiras 4 obras, uma por especialidade</a:t>
+            </a:r>
+            <a:endParaRPr lang="en-US" sz="1300" dirty="0"/>
+          </a:p>
+        </p:txBody>
+      </p:sp>
+      <p:sp>
+        <p:nvSpPr>
+          <p:cNvPr id="24" name="Text 22"/>
+          <p:cNvSpPr txBox="1"/>
+          <p:nvPr/>
+        </p:nvSpPr>
+        <p:spPr>
+          <a:xfrm>
+            <a:off x="457200" y="4297680"/>
+            <a:ext cx="8229600" cy="411480"/>
+          </a:xfrm>
+          <a:prstGeom prst="rect">
+            <a:avLst/>
+          </a:prstGeom>
+          <a:noFill/>
+          <a:ln/>
+        </p:spPr>
+        <p:txBody>
+          <a:bodyPr wrap="square" lIns="0" tIns="0" rIns="0" bIns="0" rtlCol="0" anchor="ctr"/>
+          <a:lstStyle/>
+          <a:p>
+            <a:pPr indent="0" marL="0">
+              <a:buNone/>
+            </a:pPr>
+            <a:r>
+              <a:rPr lang="en-US" sz="1500" b="1" dirty="0">
+                <a:solidFill>
+                  <a:srgbClr val="606C38"/>
+                </a:solidFill>
+                <a:latin typeface="Calibri" pitchFamily="34" charset="0"/>
+                <a:ea typeface="Calibri" pitchFamily="34" charset="-122"/>
+                <a:cs typeface="Calibri" pitchFamily="34" charset="-120"/>
+              </a:rPr>
+              <a:t>Primeira ação: montar a bancada e testar os aparelhos que vão para casa dos clientes.</a:t>
+            </a:r>
+            <a:endParaRPr lang="en-US" sz="1500" dirty="0"/>
+          </a:p>
+        </p:txBody>
+      </p:sp>
+    </p:spTree>
+  </p:cSld>
+  <p:clrMapOvr>
+    <a:masterClrMapping/>
+  </p:clrMapOvr>
+</p:sld>
+</file>
+
+<file path=ppt/slides/slide13.xml><?xml version="1.0" encoding="utf-8"?>
+<p:sld xmlns:a="http://schemas.openxmlformats.org/drawingml/2006/main" xmlns:r="http://schemas.openxmlformats.org/officeDocument/2006/relationships" xmlns:p="http://schemas.openxmlformats.org/presentationml/2006/main">
+  <p:cSld name="Slide 13">
     <p:bg>
       <p:bgPr>
         <a:solidFill>
@@ -4443,7 +5007,7 @@
                 <a:ea typeface="Calibri" pitchFamily="34" charset="-122"/>
                 <a:cs typeface="Calibri" pitchFamily="34" charset="-120"/>
               </a:rPr>
-              <a:t>Domus Energia · Grande Lisboa</a:t>
+              <a:t>Domus Energia · opancas.pt · 968 728 723</a:t>
             </a:r>
             <a:endParaRPr lang="en-US" sz="1800" dirty="0"/>
           </a:p>
@@ -4729,7 +5293,7 @@
                 <a:ea typeface="Calibri" pitchFamily="34" charset="-122"/>
                 <a:cs typeface="Calibri" pitchFamily="34" charset="-120"/>
               </a:rPr>
-              <a:t>Casas gastam demais e não têm segurança. Com aparelhos Wi-Fi e uma app própria, um eletricista pode resolver isso.</a:t>
+              <a:t>Pedir um eletricista é lento e o preço é uma surpresa. Com um site que dá o orçamento na hora e aparelhos Wi-Fi baratos, dá para fazer melhor.</a:t>
             </a:r>
             <a:endParaRPr lang="en-US" sz="1300" dirty="0"/>
           </a:p>
@@ -4944,7 +5508,7 @@
                 <a:ea typeface="Calibri" pitchFamily="34" charset="-122"/>
                 <a:cs typeface="Calibri" pitchFamily="34" charset="-120"/>
               </a:rPr>
-              <a:t>Mercado, clientes, concorrência, recursos, custos e riscos estudados. Plataforma (servidor, app e site) já construída e testada.</a:t>
+              <a:t>Mercado, clientes, concorrência, recursos, custos e riscos estudados. Empresa criada e plataforma publicada em opancas.pt.</a:t>
             </a:r>
             <a:endParaRPr lang="en-US" sz="1300" dirty="0"/>
           </a:p>
@@ -5159,7 +5723,7 @@
                 <a:ea typeface="Calibri" pitchFamily="34" charset="-122"/>
                 <a:cs typeface="Calibri" pitchFamily="34" charset="-120"/>
               </a:rPr>
-              <a:t>Criar a empresa, 3 instalações-piloto, primeiros clientes e mensalidades, resultados acompanhados todas as semanas.</a:t>
+              <a:t>Setembro de 2027: fim do curso, primeiras obras pagas, parceiros a trabalhar, primeiras mensalidades.</a:t>
             </a:r>
             <a:endParaRPr lang="en-US" sz="1300" dirty="0"/>
           </a:p>
@@ -5359,7 +5923,7 @@
                 <a:ea typeface="Calibri" pitchFamily="34" charset="-122"/>
                 <a:cs typeface="Calibri" pitchFamily="34" charset="-120"/>
               </a:rPr>
-              <a:t>Casas inteligentes instaladas por eletricistas, ligadas a uma plataforma própria (app Android e site), com mensalidade baixa.</a:t>
+              <a:t>Eletricidade e casa inteligente com orçamento na hora no site, feitas por eletricistas e ligadas a uma plataforma própria.</a:t>
             </a:r>
             <a:endParaRPr lang="en-US" sz="1300" dirty="0"/>
           </a:p>
@@ -5501,7 +6065,7 @@
                 <a:ea typeface="Calibri" pitchFamily="34" charset="-122"/>
                 <a:cs typeface="Calibri" pitchFamily="34" charset="-120"/>
               </a:rPr>
-              <a:t>Gastar menos eletricidade</a:t>
+              <a:t>Saber o preço antes da visita</a:t>
             </a:r>
             <a:endParaRPr lang="en-US" sz="1500" dirty="0"/>
           </a:p>
@@ -5518,7 +6082,7 @@
                 <a:ea typeface="Calibri" pitchFamily="34" charset="-122"/>
                 <a:cs typeface="Calibri" pitchFamily="34" charset="-120"/>
               </a:rPr>
-              <a:t>consumo por circuito e alertas</a:t>
+              <a:t>orçamento na hora, no site</a:t>
             </a:r>
             <a:endParaRPr lang="en-US" sz="1500" dirty="0"/>
           </a:p>
@@ -5621,7 +6185,7 @@
                 <a:ea typeface="Calibri" pitchFamily="34" charset="-122"/>
                 <a:cs typeface="Calibri" pitchFamily="34" charset="-120"/>
               </a:rPr>
-              <a:t>Ter segurança</a:t>
+              <a:t>Ter um quadro seguro</a:t>
             </a:r>
             <a:endParaRPr lang="en-US" sz="1500" dirty="0"/>
           </a:p>
@@ -5638,7 +6202,7 @@
                 <a:ea typeface="Calibri" pitchFamily="34" charset="-122"/>
                 <a:cs typeface="Calibri" pitchFamily="34" charset="-120"/>
               </a:rPr>
-              <a:t>alarme sem contratos de 24 meses</a:t>
+              <a:t>proteções certas e ensaios feitos</a:t>
             </a:r>
             <a:endParaRPr lang="en-US" sz="1500" dirty="0"/>
           </a:p>
@@ -5702,7 +6266,7 @@
                 <a:ea typeface="Cambria" pitchFamily="34" charset="-122"/>
                 <a:cs typeface="Cambria" pitchFamily="34" charset="-120"/>
               </a:rPr>
-              <a:t>📱</a:t>
+              <a:t>⚡</a:t>
             </a:r>
             <a:endParaRPr lang="en-US" sz="1210" dirty="0"/>
           </a:p>
@@ -5741,7 +6305,7 @@
                 <a:ea typeface="Calibri" pitchFamily="34" charset="-122"/>
                 <a:cs typeface="Calibri" pitchFamily="34" charset="-120"/>
               </a:rPr>
-              <a:t>Controlar à distância</a:t>
+              <a:t>Gastar menos eletricidade</a:t>
             </a:r>
             <a:endParaRPr lang="en-US" sz="1500" dirty="0"/>
           </a:p>
@@ -5758,7 +6322,7 @@
                 <a:ea typeface="Calibri" pitchFamily="34" charset="-122"/>
                 <a:cs typeface="Calibri" pitchFamily="34" charset="-120"/>
               </a:rPr>
-              <a:t>luzes, estores e aparelhos</a:t>
+              <a:t>consumo por circuito e alertas</a:t>
             </a:r>
             <a:endParaRPr lang="en-US" sz="1500" dirty="0"/>
           </a:p>
@@ -5822,7 +6386,7 @@
                 <a:ea typeface="Cambria" pitchFamily="34" charset="-122"/>
                 <a:cs typeface="Cambria" pitchFamily="34" charset="-120"/>
               </a:rPr>
-              <a:t>♥</a:t>
+              <a:t>📱</a:t>
             </a:r>
             <a:endParaRPr lang="en-US" sz="1210" dirty="0"/>
           </a:p>
@@ -5861,7 +6425,7 @@
                 <a:ea typeface="Calibri" pitchFamily="34" charset="-122"/>
                 <a:cs typeface="Calibri" pitchFamily="34" charset="-120"/>
               </a:rPr>
-              <a:t>Acompanhar os pais</a:t>
+              <a:t>Controlar a casa à distância</a:t>
             </a:r>
             <a:endParaRPr lang="en-US" sz="1500" dirty="0"/>
           </a:p>
@@ -5878,7 +6442,7 @@
                 <a:ea typeface="Calibri" pitchFamily="34" charset="-122"/>
                 <a:cs typeface="Calibri" pitchFamily="34" charset="-120"/>
               </a:rPr>
-              <a:t>aviso se algo não está normal</a:t>
+              <a:t>luzes, estores e aparelhos</a:t>
             </a:r>
             <a:endParaRPr lang="en-US" sz="1500" dirty="0"/>
           </a:p>
@@ -6091,7 +6655,7 @@
                 <a:ea typeface="Calibri" pitchFamily="34" charset="-122"/>
                 <a:cs typeface="Calibri" pitchFamily="34" charset="-120"/>
               </a:rPr>
-              <a:t>Grande Lisboa, no primeiro ano</a:t>
+              <a:t>Lisboa e até 100 km</a:t>
             </a:r>
             <a:endParaRPr lang="en-US" sz="1400" dirty="0"/>
           </a:p>
@@ -6164,7 +6728,7 @@
                 <a:ea typeface="Cambria" pitchFamily="34" charset="-122"/>
                 <a:cs typeface="Cambria" pitchFamily="34" charset="-120"/>
               </a:rPr>
-              <a:t>Famílias em moradias</a:t>
+              <a:t>Famílias em casa própria</a:t>
             </a:r>
             <a:endParaRPr lang="en-US" sz="1800" dirty="0"/>
           </a:p>
@@ -6203,7 +6767,7 @@
                 <a:ea typeface="Calibri" pitchFamily="34" charset="-122"/>
                 <a:cs typeface="Calibri" pitchFamily="34" charset="-120"/>
               </a:rPr>
-              <a:t>Segurança, conforto e poupança na fatura</a:t>
+              <a:t>Quadro seguro, conforto e poupança na fatura. Também senhorios e quem cuida dos pais</a:t>
             </a:r>
             <a:endParaRPr lang="en-US" sz="1300" dirty="0"/>
           </a:p>
@@ -6269,7 +6833,7 @@
                 <a:ea typeface="Calibri" pitchFamily="34" charset="-122"/>
                 <a:cs typeface="Calibri" pitchFamily="34" charset="-120"/>
               </a:rPr>
-              <a:t>Kit Conforto ou Premium</a:t>
+              <a:t>Casa inteligente · Quadro novo</a:t>
             </a:r>
             <a:endParaRPr lang="en-US" sz="1200" dirty="0"/>
           </a:p>
@@ -6342,7 +6906,7 @@
                 <a:ea typeface="Cambria" pitchFamily="34" charset="-122"/>
                 <a:cs typeface="Cambria" pitchFamily="34" charset="-120"/>
               </a:rPr>
-              <a:t>Apartamentos e alojamento local</a:t>
+              <a:t>Donos de carro elétrico</a:t>
             </a:r>
             <a:endParaRPr lang="en-US" sz="1800" dirty="0"/>
           </a:p>
@@ -6381,7 +6945,7 @@
                 <a:ea typeface="Calibri" pitchFamily="34" charset="-122"/>
                 <a:cs typeface="Calibri" pitchFamily="34" charset="-120"/>
               </a:rPr>
-              <a:t>Controlo à distância e consumo por estadia</a:t>
+              <a:t>Carregar em casa com segurança e saber quanto gasta</a:t>
             </a:r>
             <a:endParaRPr lang="en-US" sz="1300" dirty="0"/>
           </a:p>
@@ -6447,7 +7011,7 @@
                 <a:ea typeface="Calibri" pitchFamily="34" charset="-122"/>
                 <a:cs typeface="Calibri" pitchFamily="34" charset="-120"/>
               </a:rPr>
-              <a:t>Kit Essencial ou Conforto</a:t>
+              <a:t>Carregador de carro</a:t>
             </a:r>
             <a:endParaRPr lang="en-US" sz="1200" dirty="0"/>
           </a:p>
@@ -6520,7 +7084,7 @@
                 <a:ea typeface="Cambria" pitchFamily="34" charset="-122"/>
                 <a:cs typeface="Cambria" pitchFamily="34" charset="-120"/>
               </a:rPr>
-              <a:t>Idosos e familiares</a:t>
+              <a:t>Quem tem uma avaria</a:t>
             </a:r>
             <a:endParaRPr lang="en-US" sz="1800" dirty="0"/>
           </a:p>
@@ -6559,7 +7123,7 @@
                 <a:ea typeface="Calibri" pitchFamily="34" charset="-122"/>
                 <a:cs typeface="Calibri" pitchFamily="34" charset="-120"/>
               </a:rPr>
-              <a:t>Aviso se não houver movimento de manhã</a:t>
+              <a:t>Resposta rápida e preço conhecido antes da visita</a:t>
             </a:r>
             <a:endParaRPr lang="en-US" sz="1300" dirty="0"/>
           </a:p>
@@ -6625,7 +7189,7 @@
                 <a:ea typeface="Calibri" pitchFamily="34" charset="-122"/>
                 <a:cs typeface="Calibri" pitchFamily="34" charset="-120"/>
               </a:rPr>
-              <a:t>Kit Conforto</a:t>
+              <a:t>Avaria · Reparações</a:t>
             </a:r>
             <a:endParaRPr lang="en-US" sz="1200" dirty="0"/>
           </a:p>
@@ -6838,7 +7402,7 @@
                 <a:ea typeface="Calibri" pitchFamily="34" charset="-122"/>
                 <a:cs typeface="Calibri" pitchFamily="34" charset="-120"/>
               </a:rPr>
-              <a:t>Instalação uma vez + mensalidade</a:t>
+              <a:t>A obra paga-se uma vez; a mensalidade, todos os meses</a:t>
             </a:r>
             <a:endParaRPr lang="en-US" sz="1400" dirty="0"/>
           </a:p>
@@ -6870,7 +7434,7 @@
                 <a:gridCol w="2697480"/>
                 <a:gridCol w="1280160"/>
               </a:tblGrid>
-              <a:tr h="384048">
+              <a:tr h="329184">
                 <a:tc>
                   <a:txBody>
                     <a:bodyPr/>
@@ -6888,7 +7452,7 @@
                           <a:ea typeface="Calibri" pitchFamily="34" charset="-122"/>
                           <a:cs typeface="Calibri" pitchFamily="34" charset="-120"/>
                         </a:rPr>
-                        <a:t>Kit de instalação</a:t>
+                        <a:t>Obra-tipo (exemplo)</a:t>
                       </a:r>
                       <a:endParaRPr lang="en-US" sz="1200" dirty="0">
                         <a:latin typeface="Calibri" charset="0"/>
@@ -6956,7 +7520,7 @@
                           <a:ea typeface="Calibri" pitchFamily="34" charset="-122"/>
                           <a:cs typeface="Calibri" pitchFamily="34" charset="-120"/>
                         </a:rPr>
-                        <a:t>Preço s/ IVA</a:t>
+                        <a:t>c/ IVA</a:t>
                       </a:r>
                       <a:endParaRPr lang="en-US" sz="1200" dirty="0">
                         <a:latin typeface="Calibri" charset="0"/>
@@ -7008,7 +7572,7 @@
                   </a:tcPr>
                 </a:tc>
               </a:tr>
-              <a:tr h="384048">
+              <a:tr h="329184">
                 <a:tc>
                   <a:txBody>
                     <a:bodyPr/>
@@ -7026,7 +7590,7 @@
                           <a:ea typeface="Calibri" pitchFamily="34" charset="-122"/>
                           <a:cs typeface="Calibri" pitchFamily="34" charset="-120"/>
                         </a:rPr>
-                        <a:t>Essencial</a:t>
+                        <a:t>Casa inteligente (T3)</a:t>
                       </a:r>
                       <a:endParaRPr lang="en-US" sz="1200" dirty="0">
                         <a:latin typeface="Calibri" charset="0"/>
@@ -7094,7 +7658,7 @@
                           <a:ea typeface="Calibri" pitchFamily="34" charset="-122"/>
                           <a:cs typeface="Calibri" pitchFamily="34" charset="-120"/>
                         </a:rPr>
-                        <a:t>390 €</a:t>
+                        <a:t>843 €</a:t>
                       </a:r>
                       <a:endParaRPr lang="en-US" sz="1200" dirty="0">
                         <a:latin typeface="Calibri" charset="0"/>
@@ -7146,7 +7710,7 @@
                   </a:tcPr>
                 </a:tc>
               </a:tr>
-              <a:tr h="384048">
+              <a:tr h="329184">
                 <a:tc>
                   <a:txBody>
                     <a:bodyPr/>
@@ -7164,7 +7728,7 @@
                           <a:ea typeface="Calibri" pitchFamily="34" charset="-122"/>
                           <a:cs typeface="Calibri" pitchFamily="34" charset="-120"/>
                         </a:rPr>
-                        <a:t>Conforto</a:t>
+                        <a:t>Quadro elétrico novo</a:t>
                       </a:r>
                       <a:endParaRPr lang="en-US" sz="1200" dirty="0">
                         <a:latin typeface="Calibri" charset="0"/>
@@ -7232,7 +7796,7 @@
                           <a:ea typeface="Calibri" pitchFamily="34" charset="-122"/>
                           <a:cs typeface="Calibri" pitchFamily="34" charset="-120"/>
                         </a:rPr>
-                        <a:t>890 €</a:t>
+                        <a:t>1043 €</a:t>
                       </a:r>
                       <a:endParaRPr lang="en-US" sz="1200" dirty="0">
                         <a:latin typeface="Calibri" charset="0"/>
@@ -7284,7 +7848,7 @@
                   </a:tcPr>
                 </a:tc>
               </a:tr>
-              <a:tr h="384048">
+              <a:tr h="329184">
                 <a:tc>
                   <a:txBody>
                     <a:bodyPr/>
@@ -7302,7 +7866,7 @@
                           <a:ea typeface="Calibri" pitchFamily="34" charset="-122"/>
                           <a:cs typeface="Calibri" pitchFamily="34" charset="-120"/>
                         </a:rPr>
-                        <a:t>Segurança Premium</a:t>
+                        <a:t>Carregador de carro elétrico</a:t>
                       </a:r>
                       <a:endParaRPr lang="en-US" sz="1200" dirty="0">
                         <a:latin typeface="Calibri" charset="0"/>
@@ -7370,7 +7934,283 @@
                           <a:ea typeface="Calibri" pitchFamily="34" charset="-122"/>
                           <a:cs typeface="Calibri" pitchFamily="34" charset="-120"/>
                         </a:rPr>
-                        <a:t>1490 €</a:t>
+                        <a:t>449 €</a:t>
+                      </a:r>
+                      <a:endParaRPr lang="en-US" sz="1200" dirty="0">
+                        <a:latin typeface="Calibri" charset="0"/>
+                        <a:ea typeface="Calibri" charset="0"/>
+                        <a:cs typeface="Calibri" charset="0"/>
+                      </a:endParaRPr>
+                    </a:p>
+                  </a:txBody>
+                  <a:tcPr marL="54864" marR="54864" marT="54864" marB="54864">
+                    <a:lnL w="6350" cap="flat" cmpd="sng" algn="ctr">
+                      <a:solidFill>
+                        <a:srgbClr val="D9D3B0"/>
+                      </a:solidFill>
+                      <a:prstDash val="solid"/>
+                      <a:round/>
+                      <a:headEnd type="none" w="med" len="med"/>
+                      <a:tailEnd type="none" w="med" len="med"/>
+                    </a:lnL>
+                    <a:lnR w="6350" cap="flat" cmpd="sng" algn="ctr">
+                      <a:solidFill>
+                        <a:srgbClr val="D9D3B0"/>
+                      </a:solidFill>
+                      <a:prstDash val="solid"/>
+                      <a:round/>
+                      <a:headEnd type="none" w="med" len="med"/>
+                      <a:tailEnd type="none" w="med" len="med"/>
+                    </a:lnR>
+                    <a:lnT w="6350" cap="flat" cmpd="sng" algn="ctr">
+                      <a:solidFill>
+                        <a:srgbClr val="D9D3B0"/>
+                      </a:solidFill>
+                      <a:prstDash val="solid"/>
+                      <a:round/>
+                      <a:headEnd type="none" w="med" len="med"/>
+                      <a:tailEnd type="none" w="med" len="med"/>
+                    </a:lnT>
+                    <a:lnB w="6350" cap="flat" cmpd="sng" algn="ctr">
+                      <a:solidFill>
+                        <a:srgbClr val="D9D3B0"/>
+                      </a:solidFill>
+                      <a:prstDash val="solid"/>
+                      <a:round/>
+                      <a:headEnd type="none" w="med" len="med"/>
+                      <a:tailEnd type="none" w="med" len="med"/>
+                    </a:lnB>
+                    <a:solidFill>
+                      <a:srgbClr val="FFFFFF"/>
+                    </a:solidFill>
+                  </a:tcPr>
+                </a:tc>
+              </a:tr>
+              <a:tr h="329184">
+                <a:tc>
+                  <a:txBody>
+                    <a:bodyPr/>
+                    <a:lstStyle/>
+                    <a:p>
+                      <a:pPr indent="0" marL="0">
+                        <a:buNone/>
+                      </a:pPr>
+                      <a:r>
+                        <a:rPr lang="en-US" sz="1200" dirty="0">
+                          <a:solidFill>
+                            <a:srgbClr val="283618"/>
+                          </a:solidFill>
+                          <a:latin typeface="Calibri" pitchFamily="34" charset="0"/>
+                          <a:ea typeface="Calibri" pitchFamily="34" charset="-122"/>
+                          <a:cs typeface="Calibri" pitchFamily="34" charset="-120"/>
+                        </a:rPr>
+                        <a:t>Pequenas reparações</a:t>
+                      </a:r>
+                      <a:endParaRPr lang="en-US" sz="1200" dirty="0">
+                        <a:latin typeface="Calibri" charset="0"/>
+                        <a:ea typeface="Calibri" charset="0"/>
+                        <a:cs typeface="Calibri" charset="0"/>
+                      </a:endParaRPr>
+                    </a:p>
+                  </a:txBody>
+                  <a:tcPr marL="54864" marR="54864" marT="54864" marB="54864">
+                    <a:lnL w="6350" cap="flat" cmpd="sng" algn="ctr">
+                      <a:solidFill>
+                        <a:srgbClr val="D9D3B0"/>
+                      </a:solidFill>
+                      <a:prstDash val="solid"/>
+                      <a:round/>
+                      <a:headEnd type="none" w="med" len="med"/>
+                      <a:tailEnd type="none" w="med" len="med"/>
+                    </a:lnL>
+                    <a:lnR w="6350" cap="flat" cmpd="sng" algn="ctr">
+                      <a:solidFill>
+                        <a:srgbClr val="D9D3B0"/>
+                      </a:solidFill>
+                      <a:prstDash val="solid"/>
+                      <a:round/>
+                      <a:headEnd type="none" w="med" len="med"/>
+                      <a:tailEnd type="none" w="med" len="med"/>
+                    </a:lnR>
+                    <a:lnT w="6350" cap="flat" cmpd="sng" algn="ctr">
+                      <a:solidFill>
+                        <a:srgbClr val="D9D3B0"/>
+                      </a:solidFill>
+                      <a:prstDash val="solid"/>
+                      <a:round/>
+                      <a:headEnd type="none" w="med" len="med"/>
+                      <a:tailEnd type="none" w="med" len="med"/>
+                    </a:lnT>
+                    <a:lnB w="6350" cap="flat" cmpd="sng" algn="ctr">
+                      <a:solidFill>
+                        <a:srgbClr val="D9D3B0"/>
+                      </a:solidFill>
+                      <a:prstDash val="solid"/>
+                      <a:round/>
+                      <a:headEnd type="none" w="med" len="med"/>
+                      <a:tailEnd type="none" w="med" len="med"/>
+                    </a:lnB>
+                    <a:solidFill>
+                      <a:srgbClr val="FFFFFF"/>
+                    </a:solidFill>
+                  </a:tcPr>
+                </a:tc>
+                <a:tc>
+                  <a:txBody>
+                    <a:bodyPr/>
+                    <a:lstStyle/>
+                    <a:p>
+                      <a:pPr indent="0" marL="0">
+                        <a:buNone/>
+                      </a:pPr>
+                      <a:r>
+                        <a:rPr lang="en-US" sz="1200" dirty="0">
+                          <a:solidFill>
+                            <a:srgbClr val="283618"/>
+                          </a:solidFill>
+                          <a:latin typeface="Calibri" pitchFamily="34" charset="0"/>
+                          <a:ea typeface="Calibri" pitchFamily="34" charset="-122"/>
+                          <a:cs typeface="Calibri" pitchFamily="34" charset="-120"/>
+                        </a:rPr>
+                        <a:t>247 €</a:t>
+                      </a:r>
+                      <a:endParaRPr lang="en-US" sz="1200" dirty="0">
+                        <a:latin typeface="Calibri" charset="0"/>
+                        <a:ea typeface="Calibri" charset="0"/>
+                        <a:cs typeface="Calibri" charset="0"/>
+                      </a:endParaRPr>
+                    </a:p>
+                  </a:txBody>
+                  <a:tcPr marL="54864" marR="54864" marT="54864" marB="54864">
+                    <a:lnL w="6350" cap="flat" cmpd="sng" algn="ctr">
+                      <a:solidFill>
+                        <a:srgbClr val="D9D3B0"/>
+                      </a:solidFill>
+                      <a:prstDash val="solid"/>
+                      <a:round/>
+                      <a:headEnd type="none" w="med" len="med"/>
+                      <a:tailEnd type="none" w="med" len="med"/>
+                    </a:lnL>
+                    <a:lnR w="6350" cap="flat" cmpd="sng" algn="ctr">
+                      <a:solidFill>
+                        <a:srgbClr val="D9D3B0"/>
+                      </a:solidFill>
+                      <a:prstDash val="solid"/>
+                      <a:round/>
+                      <a:headEnd type="none" w="med" len="med"/>
+                      <a:tailEnd type="none" w="med" len="med"/>
+                    </a:lnR>
+                    <a:lnT w="6350" cap="flat" cmpd="sng" algn="ctr">
+                      <a:solidFill>
+                        <a:srgbClr val="D9D3B0"/>
+                      </a:solidFill>
+                      <a:prstDash val="solid"/>
+                      <a:round/>
+                      <a:headEnd type="none" w="med" len="med"/>
+                      <a:tailEnd type="none" w="med" len="med"/>
+                    </a:lnT>
+                    <a:lnB w="6350" cap="flat" cmpd="sng" algn="ctr">
+                      <a:solidFill>
+                        <a:srgbClr val="D9D3B0"/>
+                      </a:solidFill>
+                      <a:prstDash val="solid"/>
+                      <a:round/>
+                      <a:headEnd type="none" w="med" len="med"/>
+                      <a:tailEnd type="none" w="med" len="med"/>
+                    </a:lnB>
+                    <a:solidFill>
+                      <a:srgbClr val="FFFFFF"/>
+                    </a:solidFill>
+                  </a:tcPr>
+                </a:tc>
+              </a:tr>
+              <a:tr h="329184">
+                <a:tc>
+                  <a:txBody>
+                    <a:bodyPr/>
+                    <a:lstStyle/>
+                    <a:p>
+                      <a:pPr indent="0" marL="0">
+                        <a:buNone/>
+                      </a:pPr>
+                      <a:r>
+                        <a:rPr lang="en-US" sz="1200" dirty="0">
+                          <a:solidFill>
+                            <a:srgbClr val="283618"/>
+                          </a:solidFill>
+                          <a:latin typeface="Calibri" pitchFamily="34" charset="0"/>
+                          <a:ea typeface="Calibri" pitchFamily="34" charset="-122"/>
+                          <a:cs typeface="Calibri" pitchFamily="34" charset="-120"/>
+                        </a:rPr>
+                        <a:t>Avaria</a:t>
+                      </a:r>
+                      <a:endParaRPr lang="en-US" sz="1200" dirty="0">
+                        <a:latin typeface="Calibri" charset="0"/>
+                        <a:ea typeface="Calibri" charset="0"/>
+                        <a:cs typeface="Calibri" charset="0"/>
+                      </a:endParaRPr>
+                    </a:p>
+                  </a:txBody>
+                  <a:tcPr marL="54864" marR="54864" marT="54864" marB="54864">
+                    <a:lnL w="6350" cap="flat" cmpd="sng" algn="ctr">
+                      <a:solidFill>
+                        <a:srgbClr val="D9D3B0"/>
+                      </a:solidFill>
+                      <a:prstDash val="solid"/>
+                      <a:round/>
+                      <a:headEnd type="none" w="med" len="med"/>
+                      <a:tailEnd type="none" w="med" len="med"/>
+                    </a:lnL>
+                    <a:lnR w="6350" cap="flat" cmpd="sng" algn="ctr">
+                      <a:solidFill>
+                        <a:srgbClr val="D9D3B0"/>
+                      </a:solidFill>
+                      <a:prstDash val="solid"/>
+                      <a:round/>
+                      <a:headEnd type="none" w="med" len="med"/>
+                      <a:tailEnd type="none" w="med" len="med"/>
+                    </a:lnR>
+                    <a:lnT w="6350" cap="flat" cmpd="sng" algn="ctr">
+                      <a:solidFill>
+                        <a:srgbClr val="D9D3B0"/>
+                      </a:solidFill>
+                      <a:prstDash val="solid"/>
+                      <a:round/>
+                      <a:headEnd type="none" w="med" len="med"/>
+                      <a:tailEnd type="none" w="med" len="med"/>
+                    </a:lnT>
+                    <a:lnB w="6350" cap="flat" cmpd="sng" algn="ctr">
+                      <a:solidFill>
+                        <a:srgbClr val="D9D3B0"/>
+                      </a:solidFill>
+                      <a:prstDash val="solid"/>
+                      <a:round/>
+                      <a:headEnd type="none" w="med" len="med"/>
+                      <a:tailEnd type="none" w="med" len="med"/>
+                    </a:lnB>
+                    <a:solidFill>
+                      <a:srgbClr val="FFFFFF"/>
+                    </a:solidFill>
+                  </a:tcPr>
+                </a:tc>
+                <a:tc>
+                  <a:txBody>
+                    <a:bodyPr/>
+                    <a:lstStyle/>
+                    <a:p>
+                      <a:pPr indent="0" marL="0">
+                        <a:buNone/>
+                      </a:pPr>
+                      <a:r>
+                        <a:rPr lang="en-US" sz="1200" dirty="0">
+                          <a:solidFill>
+                            <a:srgbClr val="283618"/>
+                          </a:solidFill>
+                          <a:latin typeface="Calibri" pitchFamily="34" charset="0"/>
+                          <a:ea typeface="Calibri" pitchFamily="34" charset="-122"/>
+                          <a:cs typeface="Calibri" pitchFamily="34" charset="-120"/>
+                        </a:rPr>
+                        <a:t>104 €</a:t>
                       </a:r>
                       <a:endParaRPr lang="en-US" sz="1200" dirty="0">
                         <a:latin typeface="Calibri" charset="0"/>
@@ -7884,7 +8724,7 @@
                           <a:ea typeface="Calibri" pitchFamily="34" charset="-122"/>
                           <a:cs typeface="Calibri" pitchFamily="34" charset="-120"/>
                         </a:rPr>
-                        <a:t>Segurança Premium (+ Raspberry Pi)</a:t>
+                        <a:t>Premium (+ central em casa)</a:t>
                       </a:r>
                       <a:endParaRPr lang="en-US" sz="1200" dirty="0">
                         <a:latin typeface="Calibri" charset="0"/>
@@ -8016,7 +8856,7 @@
         </p:nvSpPr>
         <p:spPr>
           <a:xfrm>
-            <a:off x="457200" y="3840480"/>
+            <a:off x="457200" y="3977640"/>
             <a:ext cx="8229600" cy="548640"/>
           </a:xfrm>
           <a:prstGeom prst="rect">
@@ -8041,7 +8881,7 @@
                 <a:ea typeface="Calibri" pitchFamily="34" charset="-122"/>
                 <a:cs typeface="Calibri" pitchFamily="34" charset="-120"/>
               </a:rPr>
-              <a:t>Sem fidelização longa. Se o cliente deixar de pagar, os interruptores físicos continuam sempre a funcionar.</a:t>
+              <a:t>Mão de obra a 38 € por hora com IVA; preço de cada artigo no site. Sem fidelização: se o cliente deixar de pagar, os botões continuam sempre a funcionar.</a:t>
             </a:r>
             <a:endParaRPr lang="en-US" sz="1300" dirty="0"/>
           </a:p>
@@ -8327,7 +9167,7 @@
                 <a:ea typeface="Calibri" pitchFamily="34" charset="-122"/>
                 <a:cs typeface="Calibri" pitchFamily="34" charset="-120"/>
               </a:rPr>
-              <a:t>Alarmes com central</a:t>
+              <a:t>Eletricistas e plataformas de serviços</a:t>
             </a:r>
             <a:endParaRPr lang="en-US" sz="1400" dirty="0"/>
           </a:p>
@@ -8366,7 +9206,7 @@
                 <a:ea typeface="Calibri" pitchFamily="34" charset="-122"/>
                 <a:cs typeface="Calibri" pitchFamily="34" charset="-120"/>
               </a:rPr>
-              <a:t>Verisure: desde 37 €/mês, 24 meses</a:t>
+              <a:t>Preço só depois da visita ou de várias propostas</a:t>
             </a:r>
             <a:endParaRPr lang="en-US" sz="1200" dirty="0"/>
           </a:p>
@@ -8405,7 +9245,7 @@
                 <a:ea typeface="Calibri" pitchFamily="34" charset="-122"/>
                 <a:cs typeface="Calibri" pitchFamily="34" charset="-120"/>
               </a:rPr>
-              <a:t>✓ Mensalidade 4,99–19,99 €, sem fidelização longa</a:t>
+              <a:t>✓ Orçamento na hora e obra documentada</a:t>
             </a:r>
             <a:endParaRPr lang="en-US" sz="1200" dirty="0"/>
           </a:p>
@@ -8478,7 +9318,7 @@
                 <a:ea typeface="Calibri" pitchFamily="34" charset="-122"/>
                 <a:cs typeface="Calibri" pitchFamily="34" charset="-120"/>
               </a:rPr>
-              <a:t>Domótica KNX</a:t>
+              <a:t>Alarmes com central</a:t>
             </a:r>
             <a:endParaRPr lang="en-US" sz="1400" dirty="0"/>
           </a:p>
@@ -8517,7 +9357,7 @@
                 <a:ea typeface="Calibri" pitchFamily="34" charset="-122"/>
                 <a:cs typeface="Calibri" pitchFamily="34" charset="-120"/>
               </a:rPr>
-              <a:t>Desde ≈ 1 500 €, obras</a:t>
+              <a:t>Verisure: desde 37 € por mês, 24 meses</a:t>
             </a:r>
             <a:endParaRPr lang="en-US" sz="1200" dirty="0"/>
           </a:p>
@@ -8556,7 +9396,7 @@
                 <a:ea typeface="Calibri" pitchFamily="34" charset="-122"/>
                 <a:cs typeface="Calibri" pitchFamily="34" charset="-120"/>
               </a:rPr>
-              <a:t>✓ Kits desde 390 €, sem obras</a:t>
+              <a:t>✓ Mensalidade de 4,99 a 19,99 €, sem fidelização</a:t>
             </a:r>
             <a:endParaRPr lang="en-US" sz="1200" dirty="0"/>
           </a:p>
@@ -8629,7 +9469,7 @@
                 <a:ea typeface="Calibri" pitchFamily="34" charset="-122"/>
                 <a:cs typeface="Calibri" pitchFamily="34" charset="-120"/>
               </a:rPr>
-              <a:t>Eletricistas tradicionais</a:t>
+              <a:t>Domótica KNX</a:t>
             </a:r>
             <a:endParaRPr lang="en-US" sz="1400" dirty="0"/>
           </a:p>
@@ -8668,7 +9508,7 @@
                 <a:ea typeface="Calibri" pitchFamily="34" charset="-122"/>
                 <a:cs typeface="Calibri" pitchFamily="34" charset="-120"/>
               </a:rPr>
-              <a:t>Só a instalação</a:t>
+              <a:t>Desde cerca de 1 500 €, com obras</a:t>
             </a:r>
             <a:endParaRPr lang="en-US" sz="1200" dirty="0"/>
           </a:p>
@@ -8707,7 +9547,7 @@
                 <a:ea typeface="Calibri" pitchFamily="34" charset="-122"/>
                 <a:cs typeface="Calibri" pitchFamily="34" charset="-120"/>
               </a:rPr>
-              <a:t>✓ App própria, alertas e suporte</a:t>
+              <a:t>✓ Casa inteligente tipo por 843 €, sem obras</a:t>
             </a:r>
             <a:endParaRPr lang="en-US" sz="1200" dirty="0"/>
           </a:p>
@@ -8780,7 +9620,7 @@
                 <a:ea typeface="Calibri" pitchFamily="34" charset="-122"/>
                 <a:cs typeface="Calibri" pitchFamily="34" charset="-120"/>
               </a:rPr>
-              <a:t>Faça você mesmo (Tuya)</a:t>
+              <a:t>Montagem pelo próprio (Tuya)</a:t>
             </a:r>
             <a:endParaRPr lang="en-US" sz="1400" dirty="0"/>
           </a:p>
@@ -8858,7 +9698,7 @@
                 <a:ea typeface="Calibri" pitchFamily="34" charset="-122"/>
                 <a:cs typeface="Calibri" pitchFamily="34" charset="-120"/>
               </a:rPr>
-              <a:t>✓ Instalação segura e tudo numa app</a:t>
+              <a:t>✓ Feito por eletricista, tudo numa aplicação</a:t>
             </a:r>
             <a:endParaRPr lang="en-US" sz="1200" dirty="0"/>
           </a:p>
@@ -9286,7 +10126,7 @@
                 <a:ea typeface="Calibri" pitchFamily="34" charset="-122"/>
                 <a:cs typeface="Calibri" pitchFamily="34" charset="-120"/>
               </a:rPr>
-              <a:t>CEO e técnico responsável, 2 técnicos instaladores, 1 técnico de sistemas, 1 comercial part-time</a:t>
+              <a:t>1 gerente e 4 eletricistas parceiros, um por especialidade; contabilista e advogado externos</a:t>
             </a:r>
             <a:endParaRPr lang="en-US" sz="1200" dirty="0"/>
           </a:p>
@@ -9462,7 +10302,7 @@
                 <a:ea typeface="Calibri" pitchFamily="34" charset="-122"/>
                 <a:cs typeface="Calibri" pitchFamily="34" charset="-120"/>
               </a:rPr>
-              <a:t>Oficina, carros, ferramentas e EPI, kit de demonstração, stock de aparelhos</a:t>
+              <a:t>Bancada de preparação, quadro de demonstração, stock de aparelhos; os parceiros usam a sua ferramenta</a:t>
             </a:r>
             <a:endParaRPr lang="en-US" sz="1200" dirty="0"/>
           </a:p>
@@ -9638,7 +10478,7 @@
                 <a:ea typeface="Calibri" pitchFamily="34" charset="-122"/>
                 <a:cs typeface="Calibri" pitchFamily="34" charset="-120"/>
               </a:rPr>
-              <a:t>5 000 € de capital próprio; receitas das obras e das mensalidades</a:t>
+              <a:t>5290 € de capital próprio; receitas das obras e das mensalidades</a:t>
             </a:r>
             <a:endParaRPr lang="en-US" sz="1200" dirty="0"/>
           </a:p>
@@ -9814,7 +10654,7 @@
                 <a:ea typeface="Calibri" pitchFamily="34" charset="-122"/>
                 <a:cs typeface="Calibri" pitchFamily="34" charset="-120"/>
               </a:rPr>
-              <a:t>Plataforma própria: servidor, motor de automações, app Android e site</a:t>
+              <a:t>Plataforma própria: simulador de orçamento, painel de gestão, área do eletricista e aplicação do cliente</a:t>
             </a:r>
             <a:endParaRPr lang="en-US" sz="1200" dirty="0"/>
           </a:p>
@@ -9924,7 +10764,7 @@
                 <a:ea typeface="Cambria" pitchFamily="34" charset="-122"/>
                 <a:cs typeface="Cambria" pitchFamily="34" charset="-120"/>
               </a:rPr>
-              <a:t>Qual o investimento inicial?</a:t>
+              <a:t>Quem faz o quê</a:t>
             </a:r>
             <a:endParaRPr lang="en-US" sz="3000" dirty="0"/>
           </a:p>
@@ -9988,7 +10828,7 @@
                 <a:ea typeface="Cambria" pitchFamily="34" charset="-122"/>
                 <a:cs typeface="Cambria" pitchFamily="34" charset="-120"/>
               </a:rPr>
-              <a:t>7</a:t>
+              <a:t>6</a:t>
             </a:r>
             <a:endParaRPr lang="en-US" sz="792" dirty="0"/>
           </a:p>
@@ -10027,7 +10867,7 @@
                 <a:ea typeface="Calibri" pitchFamily="34" charset="-122"/>
                 <a:cs typeface="Calibri" pitchFamily="34" charset="-120"/>
               </a:rPr>
-              <a:t>Arranque com capital próprio</a:t>
+              <a:t>Um gerente e quatro especialidades, cada uma com suplente</a:t>
             </a:r>
             <a:endParaRPr lang="en-US" sz="1400" dirty="0"/>
           </a:p>
@@ -10035,14 +10875,48 @@
       </p:sp>
       <p:sp>
         <p:nvSpPr>
-          <p:cNvPr id="7" name="Text 5"/>
-          <p:cNvSpPr txBox="1"/>
-          <p:nvPr/>
-        </p:nvSpPr>
-        <p:spPr>
-          <a:xfrm>
-            <a:off x="457200" y="1828800"/>
-            <a:ext cx="3291840" cy="1005840"/>
+          <p:cNvPr id="7" name="Shape 5"/>
+          <p:cNvSpPr/>
+          <p:nvPr/>
+        </p:nvSpPr>
+        <p:spPr>
+          <a:xfrm>
+            <a:off x="457200" y="1691640"/>
+            <a:ext cx="8229600" cy="960120"/>
+          </a:xfrm>
+          <a:prstGeom prst="roundRect">
+            <a:avLst>
+              <a:gd name="adj" fmla="val 11429"/>
+            </a:avLst>
+          </a:prstGeom>
+          <a:solidFill>
+            <a:srgbClr val="283618"/>
+          </a:solidFill>
+          <a:ln w="9525">
+            <a:solidFill>
+              <a:srgbClr val="E6E0BF"/>
+            </a:solidFill>
+            <a:prstDash val="solid"/>
+          </a:ln>
+          <a:effectLst>
+            <a:outerShdw sx="100000" sy="100000" kx="0" ky="0" algn="bl" rotWithShape="0" blurRad="76200" dist="25400" dir="5400000">
+              <a:srgbClr val="283618">
+                <a:alpha val="8000"/>
+              </a:srgbClr>
+            </a:outerShdw>
+          </a:effectLst>
+        </p:spPr>
+      </p:sp>
+      <p:sp>
+        <p:nvSpPr>
+          <p:cNvPr id="8" name="Text 6"/>
+          <p:cNvSpPr txBox="1"/>
+          <p:nvPr/>
+        </p:nvSpPr>
+        <p:spPr>
+          <a:xfrm>
+            <a:off x="685800" y="1737360"/>
+            <a:ext cx="7772400" cy="868680"/>
           </a:xfrm>
           <a:prstGeom prst="rect">
             <a:avLst/>
@@ -10058,75 +10932,680 @@
               <a:buNone/>
             </a:pPr>
             <a:r>
-              <a:rPr lang="en-US" sz="6000" b="1" dirty="0">
+              <a:rPr lang="en-US" sz="1600" b="1" dirty="0">
+                <a:solidFill>
+                  <a:srgbClr val="DDA15E"/>
+                </a:solidFill>
+                <a:latin typeface="Calibri" pitchFamily="34" charset="0"/>
+                <a:ea typeface="Calibri" pitchFamily="34" charset="-122"/>
+                <a:cs typeface="Calibri" pitchFamily="34" charset="-120"/>
+              </a:rPr>
+              <a:t>Gerente (Rui Bragança)</a:t>
+            </a:r>
+            <a:endParaRPr lang="en-US" sz="1600" dirty="0"/>
+          </a:p>
+          <a:p>
+            <a:pPr indent="0" marL="0">
+              <a:buNone/>
+            </a:pPr>
+            <a:r>
+              <a:rPr lang="en-US" sz="1200" dirty="0">
+                <a:solidFill>
+                  <a:srgbClr val="FEFAE0"/>
+                </a:solidFill>
+                <a:latin typeface="Calibri" pitchFamily="34" charset="0"/>
+                <a:ea typeface="Calibri" pitchFamily="34" charset="-122"/>
+                <a:cs typeface="Calibri" pitchFamily="34" charset="-120"/>
+              </a:rPr>
+              <a:t>Direção e aprovação de cada obra · Sistemas e aparelhos (bancada, servidor, aplicação) · Atendimento e marcações</a:t>
+            </a:r>
+            <a:endParaRPr lang="en-US" sz="1600" dirty="0"/>
+          </a:p>
+        </p:txBody>
+      </p:sp>
+      <p:sp>
+        <p:nvSpPr>
+          <p:cNvPr id="9" name="Shape 7"/>
+          <p:cNvSpPr/>
+          <p:nvPr/>
+        </p:nvSpPr>
+        <p:spPr>
+          <a:xfrm>
+            <a:off x="457200" y="2834640"/>
+            <a:ext cx="1920240" cy="1600200"/>
+          </a:xfrm>
+          <a:prstGeom prst="roundRect">
+            <a:avLst>
+              <a:gd name="adj" fmla="val 6857"/>
+            </a:avLst>
+          </a:prstGeom>
+          <a:solidFill>
+            <a:srgbClr val="FFFFFF"/>
+          </a:solidFill>
+          <a:ln w="9525">
+            <a:solidFill>
+              <a:srgbClr val="E6E0BF"/>
+            </a:solidFill>
+            <a:prstDash val="solid"/>
+          </a:ln>
+          <a:effectLst>
+            <a:outerShdw sx="100000" sy="100000" kx="0" ky="0" algn="bl" rotWithShape="0" blurRad="76200" dist="25400" dir="5400000">
+              <a:srgbClr val="283618">
+                <a:alpha val="8000"/>
+              </a:srgbClr>
+            </a:outerShdw>
+          </a:effectLst>
+        </p:spPr>
+      </p:sp>
+      <p:sp>
+        <p:nvSpPr>
+          <p:cNvPr id="10" name="Text 8"/>
+          <p:cNvSpPr txBox="1"/>
+          <p:nvPr/>
+        </p:nvSpPr>
+        <p:spPr>
+          <a:xfrm>
+            <a:off x="594360" y="2926080"/>
+            <a:ext cx="1645920" cy="228600"/>
+          </a:xfrm>
+          <a:prstGeom prst="rect">
+            <a:avLst/>
+          </a:prstGeom>
+          <a:noFill/>
+          <a:ln/>
+        </p:spPr>
+        <p:txBody>
+          <a:bodyPr wrap="square" lIns="0" tIns="0" rIns="0" bIns="0" rtlCol="0" anchor="ctr"/>
+          <a:lstStyle/>
+          <a:p>
+            <a:pPr indent="0" marL="0">
+              <a:buNone/>
+            </a:pPr>
+            <a:r>
+              <a:rPr lang="en-US" sz="900" b="1" spc="200" kern="0" dirty="0">
                 <a:solidFill>
                   <a:srgbClr val="BC6C25"/>
+                </a:solidFill>
+                <a:latin typeface="Calibri" pitchFamily="34" charset="0"/>
+                <a:ea typeface="Calibri" pitchFamily="34" charset="-122"/>
+                <a:cs typeface="Calibri" pitchFamily="34" charset="-120"/>
+              </a:rPr>
+              <a:t>PARCEIRO 1</a:t>
+            </a:r>
+            <a:endParaRPr lang="en-US" sz="900" dirty="0"/>
+          </a:p>
+        </p:txBody>
+      </p:sp>
+      <p:sp>
+        <p:nvSpPr>
+          <p:cNvPr id="11" name="Text 9"/>
+          <p:cNvSpPr txBox="1"/>
+          <p:nvPr/>
+        </p:nvSpPr>
+        <p:spPr>
+          <a:xfrm>
+            <a:off x="594360" y="3154680"/>
+            <a:ext cx="1645920" cy="548640"/>
+          </a:xfrm>
+          <a:prstGeom prst="rect">
+            <a:avLst/>
+          </a:prstGeom>
+          <a:noFill/>
+          <a:ln/>
+        </p:spPr>
+        <p:txBody>
+          <a:bodyPr wrap="square" lIns="0" tIns="0" rIns="0" bIns="0" rtlCol="0" anchor="t"/>
+          <a:lstStyle/>
+          <a:p>
+            <a:pPr indent="0" marL="0">
+              <a:buNone/>
+            </a:pPr>
+            <a:r>
+              <a:rPr lang="en-US" sz="1400" b="1" dirty="0">
+                <a:solidFill>
+                  <a:srgbClr val="606C38"/>
                 </a:solidFill>
                 <a:latin typeface="Cambria" pitchFamily="34" charset="0"/>
                 <a:ea typeface="Cambria" pitchFamily="34" charset="-122"/>
                 <a:cs typeface="Cambria" pitchFamily="34" charset="-120"/>
               </a:rPr>
-              <a:t>5 000 €</a:t>
-            </a:r>
-            <a:endParaRPr lang="en-US" sz="6000" dirty="0"/>
-          </a:p>
-        </p:txBody>
-      </p:sp>
-      <p:sp>
-        <p:nvSpPr>
-          <p:cNvPr id="8" name="Text 6"/>
-          <p:cNvSpPr txBox="1"/>
-          <p:nvPr/>
-        </p:nvSpPr>
-        <p:spPr>
-          <a:xfrm>
-            <a:off x="457200" y="2834640"/>
-            <a:ext cx="3108960" cy="731520"/>
-          </a:xfrm>
-          <a:prstGeom prst="rect">
-            <a:avLst/>
-          </a:prstGeom>
-          <a:noFill/>
-          <a:ln/>
-        </p:spPr>
-        <p:txBody>
-          <a:bodyPr wrap="square" lIns="0" tIns="0" rIns="0" bIns="0" rtlCol="0" anchor="ctr"/>
-          <a:lstStyle/>
-          <a:p>
-            <a:pPr indent="0" marL="0">
-              <a:buNone/>
-            </a:pPr>
-            <a:r>
-              <a:rPr lang="en-US" sz="1300" dirty="0">
-                <a:solidFill>
-                  <a:srgbClr val="5C6446"/>
+              <a:t>Quadros e ensaios</a:t>
+            </a:r>
+            <a:endParaRPr lang="en-US" sz="1400" dirty="0"/>
+          </a:p>
+        </p:txBody>
+      </p:sp>
+      <p:sp>
+        <p:nvSpPr>
+          <p:cNvPr id="12" name="Text 10"/>
+          <p:cNvSpPr txBox="1"/>
+          <p:nvPr/>
+        </p:nvSpPr>
+        <p:spPr>
+          <a:xfrm>
+            <a:off x="594360" y="3703320"/>
+            <a:ext cx="1645920" cy="685800"/>
+          </a:xfrm>
+          <a:prstGeom prst="rect">
+            <a:avLst/>
+          </a:prstGeom>
+          <a:noFill/>
+          <a:ln/>
+        </p:spPr>
+        <p:txBody>
+          <a:bodyPr wrap="square" lIns="0" tIns="0" rIns="0" bIns="0" rtlCol="0" anchor="t"/>
+          <a:lstStyle/>
+          <a:p>
+            <a:pPr indent="0" marL="0">
+              <a:buNone/>
+            </a:pPr>
+            <a:r>
+              <a:rPr lang="en-US" sz="1100" dirty="0">
+                <a:solidFill>
+                  <a:srgbClr val="283618"/>
                 </a:solidFill>
                 <a:latin typeface="Calibri" pitchFamily="34" charset="0"/>
                 <a:ea typeface="Calibri" pitchFamily="34" charset="-122"/>
                 <a:cs typeface="Calibri" pitchFamily="34" charset="-120"/>
               </a:rPr>
-              <a:t>sem empréstimos no arranque; apoios IEFP e microcrédito como reserva</a:t>
-            </a:r>
-            <a:endParaRPr lang="en-US" sz="1300" dirty="0"/>
-          </a:p>
-        </p:txBody>
-      </p:sp>
-      <p:graphicFrame>
-        <p:nvGraphicFramePr>
-          <p:cNvPr id="9" name="Chart 0" descr=""/>
-          <p:cNvGraphicFramePr/>
-          <p:nvPr/>
-        </p:nvGraphicFramePr>
-        <p:xfrm>
-          <a:off x="3931920" y="1645920"/>
-          <a:ext cx="4846320" cy="3108960"/>
-        </p:xfrm>
-        <a:graphic xmlns:a="http://schemas.openxmlformats.org/drawingml/2006/main">
-          <a:graphicData uri="http://schemas.openxmlformats.org/drawingml/2006/chart">
-            <c:chart xmlns:c="http://schemas.openxmlformats.org/drawingml/2006/chart" r:id="rId1"/>
-          </a:graphicData>
-        </a:graphic>
-      </p:graphicFrame>
+              <a:t>Quadros novos; revê as obras dos colegas</a:t>
+            </a:r>
+            <a:endParaRPr lang="en-US" sz="1100" dirty="0"/>
+          </a:p>
+        </p:txBody>
+      </p:sp>
+      <p:sp>
+        <p:nvSpPr>
+          <p:cNvPr id="13" name="Shape 11"/>
+          <p:cNvSpPr/>
+          <p:nvPr/>
+        </p:nvSpPr>
+        <p:spPr>
+          <a:xfrm>
+            <a:off x="2560320" y="2834640"/>
+            <a:ext cx="1920240" cy="1600200"/>
+          </a:xfrm>
+          <a:prstGeom prst="roundRect">
+            <a:avLst>
+              <a:gd name="adj" fmla="val 6857"/>
+            </a:avLst>
+          </a:prstGeom>
+          <a:solidFill>
+            <a:srgbClr val="FFFFFF"/>
+          </a:solidFill>
+          <a:ln w="9525">
+            <a:solidFill>
+              <a:srgbClr val="E6E0BF"/>
+            </a:solidFill>
+            <a:prstDash val="solid"/>
+          </a:ln>
+          <a:effectLst>
+            <a:outerShdw sx="100000" sy="100000" kx="0" ky="0" algn="bl" rotWithShape="0" blurRad="76200" dist="25400" dir="5400000">
+              <a:srgbClr val="283618">
+                <a:alpha val="8000"/>
+              </a:srgbClr>
+            </a:outerShdw>
+          </a:effectLst>
+        </p:spPr>
+      </p:sp>
+      <p:sp>
+        <p:nvSpPr>
+          <p:cNvPr id="14" name="Text 12"/>
+          <p:cNvSpPr txBox="1"/>
+          <p:nvPr/>
+        </p:nvSpPr>
+        <p:spPr>
+          <a:xfrm>
+            <a:off x="2697480" y="2926080"/>
+            <a:ext cx="1645920" cy="228600"/>
+          </a:xfrm>
+          <a:prstGeom prst="rect">
+            <a:avLst/>
+          </a:prstGeom>
+          <a:noFill/>
+          <a:ln/>
+        </p:spPr>
+        <p:txBody>
+          <a:bodyPr wrap="square" lIns="0" tIns="0" rIns="0" bIns="0" rtlCol="0" anchor="ctr"/>
+          <a:lstStyle/>
+          <a:p>
+            <a:pPr indent="0" marL="0">
+              <a:buNone/>
+            </a:pPr>
+            <a:r>
+              <a:rPr lang="en-US" sz="900" b="1" spc="200" kern="0" dirty="0">
+                <a:solidFill>
+                  <a:srgbClr val="BC6C25"/>
+                </a:solidFill>
+                <a:latin typeface="Calibri" pitchFamily="34" charset="0"/>
+                <a:ea typeface="Calibri" pitchFamily="34" charset="-122"/>
+                <a:cs typeface="Calibri" pitchFamily="34" charset="-120"/>
+              </a:rPr>
+              <a:t>PARCEIRO 2</a:t>
+            </a:r>
+            <a:endParaRPr lang="en-US" sz="900" dirty="0"/>
+          </a:p>
+        </p:txBody>
+      </p:sp>
+      <p:sp>
+        <p:nvSpPr>
+          <p:cNvPr id="15" name="Text 13"/>
+          <p:cNvSpPr txBox="1"/>
+          <p:nvPr/>
+        </p:nvSpPr>
+        <p:spPr>
+          <a:xfrm>
+            <a:off x="2697480" y="3154680"/>
+            <a:ext cx="1645920" cy="548640"/>
+          </a:xfrm>
+          <a:prstGeom prst="rect">
+            <a:avLst/>
+          </a:prstGeom>
+          <a:noFill/>
+          <a:ln/>
+        </p:spPr>
+        <p:txBody>
+          <a:bodyPr wrap="square" lIns="0" tIns="0" rIns="0" bIns="0" rtlCol="0" anchor="t"/>
+          <a:lstStyle/>
+          <a:p>
+            <a:pPr indent="0" marL="0">
+              <a:buNone/>
+            </a:pPr>
+            <a:r>
+              <a:rPr lang="en-US" sz="1400" b="1" dirty="0">
+                <a:solidFill>
+                  <a:srgbClr val="606C38"/>
+                </a:solidFill>
+                <a:latin typeface="Cambria" pitchFamily="34" charset="0"/>
+                <a:ea typeface="Cambria" pitchFamily="34" charset="-122"/>
+                <a:cs typeface="Cambria" pitchFamily="34" charset="-120"/>
+              </a:rPr>
+              <a:t>Casa inteligente</a:t>
+            </a:r>
+            <a:endParaRPr lang="en-US" sz="1400" dirty="0"/>
+          </a:p>
+        </p:txBody>
+      </p:sp>
+      <p:sp>
+        <p:nvSpPr>
+          <p:cNvPr id="16" name="Text 14"/>
+          <p:cNvSpPr txBox="1"/>
+          <p:nvPr/>
+        </p:nvSpPr>
+        <p:spPr>
+          <a:xfrm>
+            <a:off x="2697480" y="3703320"/>
+            <a:ext cx="1645920" cy="685800"/>
+          </a:xfrm>
+          <a:prstGeom prst="rect">
+            <a:avLst/>
+          </a:prstGeom>
+          <a:noFill/>
+          <a:ln/>
+        </p:spPr>
+        <p:txBody>
+          <a:bodyPr wrap="square" lIns="0" tIns="0" rIns="0" bIns="0" rtlCol="0" anchor="t"/>
+          <a:lstStyle/>
+          <a:p>
+            <a:pPr indent="0" marL="0">
+              <a:buNone/>
+            </a:pPr>
+            <a:r>
+              <a:rPr lang="en-US" sz="1100" dirty="0">
+                <a:solidFill>
+                  <a:srgbClr val="283618"/>
+                </a:solidFill>
+                <a:latin typeface="Calibri" pitchFamily="34" charset="0"/>
+                <a:ea typeface="Calibri" pitchFamily="34" charset="-122"/>
+                <a:cs typeface="Calibri" pitchFamily="34" charset="-120"/>
+              </a:rPr>
+              <a:t>Aparelhos, aplicação, explicar ao cliente</a:t>
+            </a:r>
+            <a:endParaRPr lang="en-US" sz="1100" dirty="0"/>
+          </a:p>
+        </p:txBody>
+      </p:sp>
+      <p:sp>
+        <p:nvSpPr>
+          <p:cNvPr id="17" name="Shape 15"/>
+          <p:cNvSpPr/>
+          <p:nvPr/>
+        </p:nvSpPr>
+        <p:spPr>
+          <a:xfrm>
+            <a:off x="4663440" y="2834640"/>
+            <a:ext cx="1920240" cy="1600200"/>
+          </a:xfrm>
+          <a:prstGeom prst="roundRect">
+            <a:avLst>
+              <a:gd name="adj" fmla="val 6857"/>
+            </a:avLst>
+          </a:prstGeom>
+          <a:solidFill>
+            <a:srgbClr val="FFFFFF"/>
+          </a:solidFill>
+          <a:ln w="9525">
+            <a:solidFill>
+              <a:srgbClr val="E6E0BF"/>
+            </a:solidFill>
+            <a:prstDash val="solid"/>
+          </a:ln>
+          <a:effectLst>
+            <a:outerShdw sx="100000" sy="100000" kx="0" ky="0" algn="bl" rotWithShape="0" blurRad="76200" dist="25400" dir="5400000">
+              <a:srgbClr val="283618">
+                <a:alpha val="8000"/>
+              </a:srgbClr>
+            </a:outerShdw>
+          </a:effectLst>
+        </p:spPr>
+      </p:sp>
+      <p:sp>
+        <p:nvSpPr>
+          <p:cNvPr id="18" name="Text 16"/>
+          <p:cNvSpPr txBox="1"/>
+          <p:nvPr/>
+        </p:nvSpPr>
+        <p:spPr>
+          <a:xfrm>
+            <a:off x="4800600" y="2926080"/>
+            <a:ext cx="1645920" cy="228600"/>
+          </a:xfrm>
+          <a:prstGeom prst="rect">
+            <a:avLst/>
+          </a:prstGeom>
+          <a:noFill/>
+          <a:ln/>
+        </p:spPr>
+        <p:txBody>
+          <a:bodyPr wrap="square" lIns="0" tIns="0" rIns="0" bIns="0" rtlCol="0" anchor="ctr"/>
+          <a:lstStyle/>
+          <a:p>
+            <a:pPr indent="0" marL="0">
+              <a:buNone/>
+            </a:pPr>
+            <a:r>
+              <a:rPr lang="en-US" sz="900" b="1" spc="200" kern="0" dirty="0">
+                <a:solidFill>
+                  <a:srgbClr val="BC6C25"/>
+                </a:solidFill>
+                <a:latin typeface="Calibri" pitchFamily="34" charset="0"/>
+                <a:ea typeface="Calibri" pitchFamily="34" charset="-122"/>
+                <a:cs typeface="Calibri" pitchFamily="34" charset="-120"/>
+              </a:rPr>
+              <a:t>PARCEIRO 3</a:t>
+            </a:r>
+            <a:endParaRPr lang="en-US" sz="900" dirty="0"/>
+          </a:p>
+        </p:txBody>
+      </p:sp>
+      <p:sp>
+        <p:nvSpPr>
+          <p:cNvPr id="19" name="Text 17"/>
+          <p:cNvSpPr txBox="1"/>
+          <p:nvPr/>
+        </p:nvSpPr>
+        <p:spPr>
+          <a:xfrm>
+            <a:off x="4800600" y="3154680"/>
+            <a:ext cx="1645920" cy="548640"/>
+          </a:xfrm>
+          <a:prstGeom prst="rect">
+            <a:avLst/>
+          </a:prstGeom>
+          <a:noFill/>
+          <a:ln/>
+        </p:spPr>
+        <p:txBody>
+          <a:bodyPr wrap="square" lIns="0" tIns="0" rIns="0" bIns="0" rtlCol="0" anchor="t"/>
+          <a:lstStyle/>
+          <a:p>
+            <a:pPr indent="0" marL="0">
+              <a:buNone/>
+            </a:pPr>
+            <a:r>
+              <a:rPr lang="en-US" sz="1400" b="1" dirty="0">
+                <a:solidFill>
+                  <a:srgbClr val="606C38"/>
+                </a:solidFill>
+                <a:latin typeface="Cambria" pitchFamily="34" charset="0"/>
+                <a:ea typeface="Cambria" pitchFamily="34" charset="-122"/>
+                <a:cs typeface="Cambria" pitchFamily="34" charset="-120"/>
+              </a:rPr>
+              <a:t>Avarias e reparações</a:t>
+            </a:r>
+            <a:endParaRPr lang="en-US" sz="1400" dirty="0"/>
+          </a:p>
+        </p:txBody>
+      </p:sp>
+      <p:sp>
+        <p:nvSpPr>
+          <p:cNvPr id="20" name="Text 18"/>
+          <p:cNvSpPr txBox="1"/>
+          <p:nvPr/>
+        </p:nvSpPr>
+        <p:spPr>
+          <a:xfrm>
+            <a:off x="4800600" y="3703320"/>
+            <a:ext cx="1645920" cy="685800"/>
+          </a:xfrm>
+          <a:prstGeom prst="rect">
+            <a:avLst/>
+          </a:prstGeom>
+          <a:noFill/>
+          <a:ln/>
+        </p:spPr>
+        <p:txBody>
+          <a:bodyPr wrap="square" lIns="0" tIns="0" rIns="0" bIns="0" rtlCol="0" anchor="t"/>
+          <a:lstStyle/>
+          <a:p>
+            <a:pPr indent="0" marL="0">
+              <a:buNone/>
+            </a:pPr>
+            <a:r>
+              <a:rPr lang="en-US" sz="1100" dirty="0">
+                <a:solidFill>
+                  <a:srgbClr val="283618"/>
+                </a:solidFill>
+                <a:latin typeface="Calibri" pitchFamily="34" charset="0"/>
+                <a:ea typeface="Calibri" pitchFamily="34" charset="-122"/>
+                <a:cs typeface="Calibri" pitchFamily="34" charset="-120"/>
+              </a:rPr>
+              <a:t>Diagnóstico e resposta rápida</a:t>
+            </a:r>
+            <a:endParaRPr lang="en-US" sz="1100" dirty="0"/>
+          </a:p>
+        </p:txBody>
+      </p:sp>
+      <p:sp>
+        <p:nvSpPr>
+          <p:cNvPr id="21" name="Shape 19"/>
+          <p:cNvSpPr/>
+          <p:nvPr/>
+        </p:nvSpPr>
+        <p:spPr>
+          <a:xfrm>
+            <a:off x="6766560" y="2834640"/>
+            <a:ext cx="1920240" cy="1600200"/>
+          </a:xfrm>
+          <a:prstGeom prst="roundRect">
+            <a:avLst>
+              <a:gd name="adj" fmla="val 6857"/>
+            </a:avLst>
+          </a:prstGeom>
+          <a:solidFill>
+            <a:srgbClr val="FFFFFF"/>
+          </a:solidFill>
+          <a:ln w="9525">
+            <a:solidFill>
+              <a:srgbClr val="E6E0BF"/>
+            </a:solidFill>
+            <a:prstDash val="solid"/>
+          </a:ln>
+          <a:effectLst>
+            <a:outerShdw sx="100000" sy="100000" kx="0" ky="0" algn="bl" rotWithShape="0" blurRad="76200" dist="25400" dir="5400000">
+              <a:srgbClr val="283618">
+                <a:alpha val="8000"/>
+              </a:srgbClr>
+            </a:outerShdw>
+          </a:effectLst>
+        </p:spPr>
+      </p:sp>
+      <p:sp>
+        <p:nvSpPr>
+          <p:cNvPr id="22" name="Text 20"/>
+          <p:cNvSpPr txBox="1"/>
+          <p:nvPr/>
+        </p:nvSpPr>
+        <p:spPr>
+          <a:xfrm>
+            <a:off x="6903720" y="2926080"/>
+            <a:ext cx="1645920" cy="228600"/>
+          </a:xfrm>
+          <a:prstGeom prst="rect">
+            <a:avLst/>
+          </a:prstGeom>
+          <a:noFill/>
+          <a:ln/>
+        </p:spPr>
+        <p:txBody>
+          <a:bodyPr wrap="square" lIns="0" tIns="0" rIns="0" bIns="0" rtlCol="0" anchor="ctr"/>
+          <a:lstStyle/>
+          <a:p>
+            <a:pPr indent="0" marL="0">
+              <a:buNone/>
+            </a:pPr>
+            <a:r>
+              <a:rPr lang="en-US" sz="900" b="1" spc="200" kern="0" dirty="0">
+                <a:solidFill>
+                  <a:srgbClr val="BC6C25"/>
+                </a:solidFill>
+                <a:latin typeface="Calibri" pitchFamily="34" charset="0"/>
+                <a:ea typeface="Calibri" pitchFamily="34" charset="-122"/>
+                <a:cs typeface="Calibri" pitchFamily="34" charset="-120"/>
+              </a:rPr>
+              <a:t>PARCEIRO 4</a:t>
+            </a:r>
+            <a:endParaRPr lang="en-US" sz="900" dirty="0"/>
+          </a:p>
+        </p:txBody>
+      </p:sp>
+      <p:sp>
+        <p:nvSpPr>
+          <p:cNvPr id="23" name="Text 21"/>
+          <p:cNvSpPr txBox="1"/>
+          <p:nvPr/>
+        </p:nvSpPr>
+        <p:spPr>
+          <a:xfrm>
+            <a:off x="6903720" y="3154680"/>
+            <a:ext cx="1645920" cy="548640"/>
+          </a:xfrm>
+          <a:prstGeom prst="rect">
+            <a:avLst/>
+          </a:prstGeom>
+          <a:noFill/>
+          <a:ln/>
+        </p:spPr>
+        <p:txBody>
+          <a:bodyPr wrap="square" lIns="0" tIns="0" rIns="0" bIns="0" rtlCol="0" anchor="t"/>
+          <a:lstStyle/>
+          <a:p>
+            <a:pPr indent="0" marL="0">
+              <a:buNone/>
+            </a:pPr>
+            <a:r>
+              <a:rPr lang="en-US" sz="1400" b="1" dirty="0">
+                <a:solidFill>
+                  <a:srgbClr val="606C38"/>
+                </a:solidFill>
+                <a:latin typeface="Cambria" pitchFamily="34" charset="0"/>
+                <a:ea typeface="Cambria" pitchFamily="34" charset="-122"/>
+                <a:cs typeface="Cambria" pitchFamily="34" charset="-120"/>
+              </a:rPr>
+              <a:t>Carregadores e obras novas</a:t>
+            </a:r>
+            <a:endParaRPr lang="en-US" sz="1400" dirty="0"/>
+          </a:p>
+        </p:txBody>
+      </p:sp>
+      <p:sp>
+        <p:nvSpPr>
+          <p:cNvPr id="24" name="Text 22"/>
+          <p:cNvSpPr txBox="1"/>
+          <p:nvPr/>
+        </p:nvSpPr>
+        <p:spPr>
+          <a:xfrm>
+            <a:off x="6903720" y="3703320"/>
+            <a:ext cx="1645920" cy="685800"/>
+          </a:xfrm>
+          <a:prstGeom prst="rect">
+            <a:avLst/>
+          </a:prstGeom>
+          <a:noFill/>
+          <a:ln/>
+        </p:spPr>
+        <p:txBody>
+          <a:bodyPr wrap="square" lIns="0" tIns="0" rIns="0" bIns="0" rtlCol="0" anchor="t"/>
+          <a:lstStyle/>
+          <a:p>
+            <a:pPr indent="0" marL="0">
+              <a:buNone/>
+            </a:pPr>
+            <a:r>
+              <a:rPr lang="en-US" sz="1100" dirty="0">
+                <a:solidFill>
+                  <a:srgbClr val="283618"/>
+                </a:solidFill>
+                <a:latin typeface="Calibri" pitchFamily="34" charset="0"/>
+                <a:ea typeface="Calibri" pitchFamily="34" charset="-122"/>
+                <a:cs typeface="Calibri" pitchFamily="34" charset="-120"/>
+              </a:rPr>
+              <a:t>Linhas dedicadas; ajuda nos quadros</a:t>
+            </a:r>
+            <a:endParaRPr lang="en-US" sz="1100" dirty="0"/>
+          </a:p>
+        </p:txBody>
+      </p:sp>
+      <p:sp>
+        <p:nvSpPr>
+          <p:cNvPr id="25" name="Text 23"/>
+          <p:cNvSpPr txBox="1"/>
+          <p:nvPr/>
+        </p:nvSpPr>
+        <p:spPr>
+          <a:xfrm>
+            <a:off x="457200" y="4526280"/>
+            <a:ext cx="8229600" cy="457200"/>
+          </a:xfrm>
+          <a:prstGeom prst="rect">
+            <a:avLst/>
+          </a:prstGeom>
+          <a:noFill/>
+          <a:ln/>
+        </p:spPr>
+        <p:txBody>
+          <a:bodyPr wrap="square" lIns="0" tIns="0" rIns="0" bIns="0" rtlCol="0" anchor="ctr"/>
+          <a:lstStyle/>
+          <a:p>
+            <a:pPr indent="0" marL="0">
+              <a:buNone/>
+            </a:pPr>
+            <a:r>
+              <a:rPr lang="en-US" sz="1100" i="1" dirty="0">
+                <a:solidFill>
+                  <a:srgbClr val="5C6446"/>
+                </a:solidFill>
+                <a:latin typeface="Calibri" pitchFamily="34" charset="0"/>
+                <a:ea typeface="Calibri" pitchFamily="34" charset="-122"/>
+                <a:cs typeface="Calibri" pitchFamily="34" charset="-120"/>
+              </a:rPr>
+              <a:t>Parceiros independentes, pagos por obra: 70 % da mão de obra. Quem faz a obra não é quem a revê. Os melhores passam a contrato quando houver volume.</a:t>
+            </a:r>
+            <a:endParaRPr lang="en-US" sz="1100" dirty="0"/>
+          </a:p>
+        </p:txBody>
+      </p:sp>
     </p:spTree>
   </p:cSld>
   <p:clrMapOvr>
@@ -10231,7 +11710,7 @@
                 <a:ea typeface="Cambria" pitchFamily="34" charset="-122"/>
                 <a:cs typeface="Cambria" pitchFamily="34" charset="-120"/>
               </a:rPr>
-              <a:t>Como serão obtidas receitas?</a:t>
+              <a:t>Qual o investimento inicial?</a:t>
             </a:r>
             <a:endParaRPr lang="en-US" sz="3000" dirty="0"/>
           </a:p>
@@ -10295,7 +11774,7 @@
                 <a:ea typeface="Cambria" pitchFamily="34" charset="-122"/>
                 <a:cs typeface="Cambria" pitchFamily="34" charset="-120"/>
               </a:rPr>
-              <a:t>8</a:t>
+              <a:t>7</a:t>
             </a:r>
             <a:endParaRPr lang="en-US" sz="792" dirty="0"/>
           </a:p>
@@ -10334,7 +11813,7 @@
                 <a:ea typeface="Calibri" pitchFamily="34" charset="-122"/>
                 <a:cs typeface="Calibri" pitchFamily="34" charset="-120"/>
               </a:rPr>
-              <a:t>Instalações pagam o arranque; mensalidades repetem-se todos os meses</a:t>
+              <a:t>Capital próprio; a empresa e a plataforma já existem</a:t>
             </a:r>
             <a:endParaRPr lang="en-US" sz="1400" dirty="0"/>
           </a:p>
@@ -10348,8 +11827,8 @@
         </p:nvSpPr>
         <p:spPr>
           <a:xfrm>
-            <a:off x="457200" y="1783080"/>
-            <a:ext cx="3108960" cy="548640"/>
+            <a:off x="457200" y="1828800"/>
+            <a:ext cx="3291840" cy="1005840"/>
           </a:xfrm>
           <a:prstGeom prst="rect">
             <a:avLst/>
@@ -10365,17 +11844,17 @@
               <a:buNone/>
             </a:pPr>
             <a:r>
-              <a:rPr lang="en-US" sz="3200" b="1" dirty="0">
-                <a:solidFill>
-                  <a:srgbClr val="606C38"/>
+              <a:rPr lang="en-US" sz="6000" b="1" dirty="0">
+                <a:solidFill>
+                  <a:srgbClr val="BC6C25"/>
                 </a:solidFill>
                 <a:latin typeface="Cambria" pitchFamily="34" charset="0"/>
                 <a:ea typeface="Cambria" pitchFamily="34" charset="-122"/>
                 <a:cs typeface="Cambria" pitchFamily="34" charset="-120"/>
               </a:rPr>
-              <a:t>730 €</a:t>
-            </a:r>
-            <a:endParaRPr lang="en-US" sz="3200" dirty="0"/>
+              <a:t>5290 €</a:t>
+            </a:r>
+            <a:endParaRPr lang="en-US" sz="6000" dirty="0"/>
           </a:p>
         </p:txBody>
       </p:sp>
@@ -10387,8 +11866,8 @@
         </p:nvSpPr>
         <p:spPr>
           <a:xfrm>
-            <a:off x="457200" y="2313432"/>
-            <a:ext cx="3108960" cy="320040"/>
+            <a:off x="457200" y="2834640"/>
+            <a:ext cx="3108960" cy="731520"/>
           </a:xfrm>
           <a:prstGeom prst="rect">
             <a:avLst/>
@@ -10404,7 +11883,7 @@
               <a:buNone/>
             </a:pPr>
             <a:r>
-              <a:rPr lang="en-US" sz="1200" dirty="0">
+              <a:rPr lang="en-US" sz="1300" dirty="0">
                 <a:solidFill>
                   <a:srgbClr val="5C6446"/>
                 </a:solidFill>
@@ -10412,177 +11891,21 @@
                 <a:ea typeface="Calibri" pitchFamily="34" charset="-122"/>
                 <a:cs typeface="Calibri" pitchFamily="34" charset="-120"/>
               </a:rPr>
-              <a:t>valor médio por instalação</a:t>
-            </a:r>
-            <a:endParaRPr lang="en-US" sz="1200" dirty="0"/>
-          </a:p>
-        </p:txBody>
-      </p:sp>
-      <p:sp>
-        <p:nvSpPr>
-          <p:cNvPr id="9" name="Text 7"/>
-          <p:cNvSpPr txBox="1"/>
-          <p:nvPr/>
-        </p:nvSpPr>
-        <p:spPr>
-          <a:xfrm>
-            <a:off x="457200" y="2770632"/>
-            <a:ext cx="3108960" cy="548640"/>
-          </a:xfrm>
-          <a:prstGeom prst="rect">
-            <a:avLst/>
-          </a:prstGeom>
-          <a:noFill/>
-          <a:ln/>
-        </p:spPr>
-        <p:txBody>
-          <a:bodyPr wrap="square" lIns="0" tIns="0" rIns="0" bIns="0" rtlCol="0" anchor="ctr"/>
-          <a:lstStyle/>
-          <a:p>
-            <a:pPr indent="0" marL="0">
-              <a:buNone/>
-            </a:pPr>
-            <a:r>
-              <a:rPr lang="en-US" sz="3200" b="1" dirty="0">
-                <a:solidFill>
-                  <a:srgbClr val="606C38"/>
-                </a:solidFill>
-                <a:latin typeface="Cambria" pitchFamily="34" charset="0"/>
-                <a:ea typeface="Cambria" pitchFamily="34" charset="-122"/>
-                <a:cs typeface="Cambria" pitchFamily="34" charset="-120"/>
-              </a:rPr>
-              <a:t>3 / mês</a:t>
-            </a:r>
-            <a:endParaRPr lang="en-US" sz="3200" dirty="0"/>
-          </a:p>
-        </p:txBody>
-      </p:sp>
-      <p:sp>
-        <p:nvSpPr>
-          <p:cNvPr id="10" name="Text 8"/>
-          <p:cNvSpPr txBox="1"/>
-          <p:nvPr/>
-        </p:nvSpPr>
-        <p:spPr>
-          <a:xfrm>
-            <a:off x="457200" y="3300984"/>
-            <a:ext cx="3108960" cy="320040"/>
-          </a:xfrm>
-          <a:prstGeom prst="rect">
-            <a:avLst/>
-          </a:prstGeom>
-          <a:noFill/>
-          <a:ln/>
-        </p:spPr>
-        <p:txBody>
-          <a:bodyPr wrap="square" lIns="0" tIns="0" rIns="0" bIns="0" rtlCol="0" anchor="ctr"/>
-          <a:lstStyle/>
-          <a:p>
-            <a:pPr indent="0" marL="0">
-              <a:buNone/>
-            </a:pPr>
-            <a:r>
-              <a:rPr lang="en-US" sz="1200" dirty="0">
-                <a:solidFill>
-                  <a:srgbClr val="5C6446"/>
-                </a:solidFill>
-                <a:latin typeface="Calibri" pitchFamily="34" charset="0"/>
-                <a:ea typeface="Calibri" pitchFamily="34" charset="-122"/>
-                <a:cs typeface="Calibri" pitchFamily="34" charset="-120"/>
-              </a:rPr>
-              <a:t>instalações para o ponto de equilíbrio</a:t>
-            </a:r>
-            <a:endParaRPr lang="en-US" sz="1200" dirty="0"/>
-          </a:p>
-        </p:txBody>
-      </p:sp>
-      <p:sp>
-        <p:nvSpPr>
-          <p:cNvPr id="11" name="Text 9"/>
-          <p:cNvSpPr txBox="1"/>
-          <p:nvPr/>
-        </p:nvSpPr>
-        <p:spPr>
-          <a:xfrm>
-            <a:off x="457200" y="3758184"/>
-            <a:ext cx="3108960" cy="548640"/>
-          </a:xfrm>
-          <a:prstGeom prst="rect">
-            <a:avLst/>
-          </a:prstGeom>
-          <a:noFill/>
-          <a:ln/>
-        </p:spPr>
-        <p:txBody>
-          <a:bodyPr wrap="square" lIns="0" tIns="0" rIns="0" bIns="0" rtlCol="0" anchor="ctr"/>
-          <a:lstStyle/>
-          <a:p>
-            <a:pPr indent="0" marL="0">
-              <a:buNone/>
-            </a:pPr>
-            <a:r>
-              <a:rPr lang="en-US" sz="3200" b="1" dirty="0">
-                <a:solidFill>
-                  <a:srgbClr val="606C38"/>
-                </a:solidFill>
-                <a:latin typeface="Cambria" pitchFamily="34" charset="0"/>
-                <a:ea typeface="Cambria" pitchFamily="34" charset="-122"/>
-                <a:cs typeface="Cambria" pitchFamily="34" charset="-120"/>
-              </a:rPr>
-              <a:t>≈ 38</a:t>
-            </a:r>
-            <a:endParaRPr lang="en-US" sz="3200" dirty="0"/>
-          </a:p>
-        </p:txBody>
-      </p:sp>
-      <p:sp>
-        <p:nvSpPr>
-          <p:cNvPr id="12" name="Text 10"/>
-          <p:cNvSpPr txBox="1"/>
-          <p:nvPr/>
-        </p:nvSpPr>
-        <p:spPr>
-          <a:xfrm>
-            <a:off x="457200" y="4288536"/>
-            <a:ext cx="3108960" cy="320040"/>
-          </a:xfrm>
-          <a:prstGeom prst="rect">
-            <a:avLst/>
-          </a:prstGeom>
-          <a:noFill/>
-          <a:ln/>
-        </p:spPr>
-        <p:txBody>
-          <a:bodyPr wrap="square" lIns="0" tIns="0" rIns="0" bIns="0" rtlCol="0" anchor="ctr"/>
-          <a:lstStyle/>
-          <a:p>
-            <a:pPr indent="0" marL="0">
-              <a:buNone/>
-            </a:pPr>
-            <a:r>
-              <a:rPr lang="en-US" sz="1200" dirty="0">
-                <a:solidFill>
-                  <a:srgbClr val="5C6446"/>
-                </a:solidFill>
-                <a:latin typeface="Calibri" pitchFamily="34" charset="0"/>
-                <a:ea typeface="Calibri" pitchFamily="34" charset="-122"/>
-                <a:cs typeface="Calibri" pitchFamily="34" charset="-120"/>
-              </a:rPr>
-              <a:t>casas com mensalidade no mês 12</a:t>
-            </a:r>
-            <a:endParaRPr lang="en-US" sz="1200" dirty="0"/>
+              <a:t>sem empréstimos; o sinal de 30 % de cada obra paga o material dessa obra</a:t>
+            </a:r>
+            <a:endParaRPr lang="en-US" sz="1300" dirty="0"/>
           </a:p>
         </p:txBody>
       </p:sp>
       <p:graphicFrame>
         <p:nvGraphicFramePr>
-          <p:cNvPr id="13" name="Chart 0" descr=""/>
+          <p:cNvPr id="9" name="Chart 0" descr=""/>
           <p:cNvGraphicFramePr/>
           <p:nvPr/>
         </p:nvGraphicFramePr>
         <p:xfrm>
-          <a:off x="3840480" y="1645920"/>
-          <a:ext cx="4937760" cy="3108960"/>
+          <a:off x="3931920" y="1645920"/>
+          <a:ext cx="4846320" cy="3108960"/>
         </p:xfrm>
         <a:graphic xmlns:a="http://schemas.openxmlformats.org/drawingml/2006/main">
           <a:graphicData uri="http://schemas.openxmlformats.org/drawingml/2006/chart">

</xml_diff>